<commit_message>
Trim the final-review deck from 33 to 29 slides
Removed the simulator-internals and RL-hyperparameter slides and the two
extra before-vs-after dashboard slides (every test run, day by day). Their
facts are kept in the speaker notes. Dashboard slides renumbered to 1-5.
</commit_message>
<xml_diff>
--- a/reports/SupplyAI-RL_Final_Project_Review.pptx
+++ b/reports/SupplyAI-RL_Final_Project_Review.pptx
@@ -40,10 +40,6 @@
     <p:sldId id="332" r:id="rId48"/>
     <p:sldId id="333" r:id="rId49"/>
     <p:sldId id="334" r:id="rId50"/>
-    <p:sldId id="335" r:id="rId51"/>
-    <p:sldId id="336" r:id="rId52"/>
-    <p:sldId id="337" r:id="rId53"/>
-    <p:sldId id="338" r:id="rId54"/>
   </p:sldIdLst>
   <p:sldSz cx="12192000" cy="6858000"/>
   <p:notesSz cx="6858000" cy="9144000"/>
@@ -1318,7 +1314,7 @@
           <a:lstStyle/>
           <a:p>
             <a:r>
-              <a:t>The loop: state in, action out, reward back. Action masking is the biggest single improvement: it stops the agent wasting training on choices that are never legal.</a:t>
+              <a:t>If asked for detail: the simulator runs five steps a day (deliveries, customers, sales, orders, profit), with storage at 0.15% of cost per day, leftover stock worth 60% of cost, and one shared 20,000-unit warehouse. The agent sees 88 numbers and picks one of 21 options per product; the winning settings were learning rate 5e-5, entropy 0.005, gamma 0.995, rollout 1024, network 2 x 256, from an 8-configuration search with the best two run to 2M steps. The loop: state in, action out, reward back. Action masking is the biggest single improvement: it stops the agent wasting training on choices that are never legal.</a:t>
             </a:r>
           </a:p>
         </p:txBody>
@@ -1528,7 +1524,7 @@
           <a:lstStyle/>
           <a:p>
             <a:r>
-              <a:t>A Gymnasium environment. The three cards are three mistakes in earlier versions that we fixed after the simulator itself told us something was wrong. A demo confirms the simulator rewards sensible behaviour: reasonable rules earn about 27 lakh, never ordering loses 3.9 crore.</a:t>
+              <a:t>This is what makes a negative result meaningful. Three disjoint seed groups, tuned baselines, identical customers for every method.</a:t>
             </a:r>
           </a:p>
         </p:txBody>
@@ -1598,7 +1594,7 @@
           <a:lstStyle/>
           <a:p>
             <a:r>
-              <a:t>MaskablePPO is PPO with action masking. The agent's inputs include nothing about its own ordering history, which turns out to be the cause of its main weakness.</a:t>
+              <a:t>The key design decision: the LLM only presents facts the simulator computed. Then every number in its output is checked against those facts. If it invented one, a fixed template is shown instead. Three free models via OpenRouter, tried in order, with retries.</a:t>
             </a:r>
           </a:p>
         </p:txBody>
@@ -1668,7 +1664,7 @@
           <a:lstStyle/>
           <a:p>
             <a:r>
-              <a:t>This is what makes a negative result meaningful. Three disjoint seed groups, tuned baselines, identical customers for every method.</a:t>
+              <a:t>The LLM's value here is imagination, not trust. We validate everything. The curriculum experiment is controlled: same seed, same settings, same steps.</a:t>
             </a:r>
           </a:p>
         </p:txBody>
@@ -1738,7 +1734,7 @@
           <a:lstStyle/>
           <a:p>
             <a:r>
-              <a:t>The key design decision: the LLM only presents facts the simulator computed. Then every number in its output is checked against those facts. If it invented one, a fixed template is shown instead. Three free models via OpenRouter, tried in order, with retries.</a:t>
+              <a:t>Live demo starting point. The dashboard opens on the engine, the policy a buyer would actually run. Everything shown comes from a real episode run on demand; no number on the page is typed in.</a:t>
             </a:r>
           </a:p>
         </p:txBody>
@@ -1808,7 +1804,7 @@
           <a:lstStyle/>
           <a:p>
             <a:r>
-              <a:t>The LLM's value here is imagination, not trust. We validate everything. The curriculum experiment is controlled: same seed, same settings, same steps.</a:t>
+              <a:t>Left: switch the policy to the challenger and the supplier bars change completely. This is the visual evidence for the error analysis. Right: the crisis switch injects the LLM-written disruption for the whole run.</a:t>
             </a:r>
           </a:p>
         </p:txBody>
@@ -1878,7 +1874,7 @@
           <a:lstStyle/>
           <a:p>
             <a:r>
-              <a:t>Live demo starting point. The dashboard opens on the engine, the policy a buyer would actually run. Everything shown comes from a real episode run on demand; no number on the page is typed in.</a:t>
+              <a:t>Before = the shop orders the same fixed amount every day, tuned as carefully as every other baseline. After = the system's engine. Same 30 unseen runs. The honest reading: forecasting plus safety stock does the heavy lifting; the RL challenger also beats the fixed order but trails the engine.</a:t>
             </a:r>
           </a:p>
         </p:txBody>
@@ -1948,7 +1944,7 @@
           <a:lstStyle/>
           <a:p>
             <a:r>
-              <a:t>Left: switch the policy to the challenger and the supplier bars change completely. This is the visual evidence for the error analysis. Right: the crisis switch injects the LLM-written disruption for the whole run.</a:t>
+              <a:t>This is the explainer in action, live. The explanation is a restatement of computed facts, not an account of the neural network's reasoning, and we say so explicitly.</a:t>
             </a:r>
           </a:p>
         </p:txBody>
@@ -2018,7 +2014,7 @@
           <a:lstStyle/>
           <a:p>
             <a:r>
-              <a:t>Before = the shop orders the same fixed amount every day, tuned as carefully as every other baseline. After = the system's engine. Same 30 unseen runs. The honest reading: forecasting plus safety stock does the heavy lifting; the RL challenger also beats the fixed order but trails the engine.</a:t>
+              <a:t>Both tabs read the saved result files, so the dashboard cannot disagree with the report.</a:t>
             </a:r>
           </a:p>
         </p:txBody>
@@ -2088,7 +2084,7 @@
           <a:lstStyle/>
           <a:p>
             <a:r>
-              <a:t>Every dot is one test seed, sorted by the before profit. The point of this chart is that the improvement is consistent, not an average hiding losses.</a:t>
+              <a:t>State the result plainly: the classical engine wins by about 8 lakh per run, paired t of minus 6.45. The agent reaches 90.8% of its profit and beats EOQ and (s,S). The constant-order row is the 'no system' baseline.</a:t>
             </a:r>
           </a:p>
         </p:txBody>
@@ -2158,7 +2154,7 @@
           <a:lstStyle/>
           <a:p>
             <a:r>
-              <a:t>Live demo option: flip the crisis switch in the sidebar and watch both charts redraw for all three policies.</a:t>
+              <a:t>Two controlled improvements, each measured: masking about 3x, tuning closes 38% of the remaining gap. The curves show learning progress on the checkpoint-selection seeds; reported scores come from separate held-out seeds.</a:t>
             </a:r>
           </a:p>
         </p:txBody>
@@ -2228,7 +2224,7 @@
           <a:lstStyle/>
           <a:p>
             <a:r>
-              <a:t>This is the explainer in action, live. The explanation is a restatement of computed facts, not an account of the neural network's reasoning, and we say so explicitly.</a:t>
+              <a:t>Every method loses more than a third of its profit in a crisis; RL is not more adaptive than the tuned classical method. Our attempt to fix that with crisis training did not work. We report it as a negative result.</a:t>
             </a:r>
           </a:p>
         </p:txBody>
@@ -2298,7 +2294,7 @@
           <a:lstStyle/>
           <a:p>
             <a:r>
-              <a:t>Both tabs read the saved result files, so the dashboard cannot disagree with the report.</a:t>
+              <a:t>Be upfront about both numbers. 83% is the model by itself; 100% is the system with the check. The finding is that the check is essential, not decoration.</a:t>
             </a:r>
           </a:p>
         </p:txBody>
@@ -2368,7 +2364,7 @@
           <a:lstStyle/>
           <a:p>
             <a:r>
-              <a:t>State the result plainly: the classical engine wins by about 8 lakh per run, paired t of minus 6.45. The agent reaches 90.8% of its profit and beats EOQ and (s,S). The constant-order row is the 'no system' baseline.</a:t>
+              <a:t>We know why it loses. It cannot observe its own ordering history, so it cannot learn to stop fragmenting orders. This is a limit on what it observes, not a tuning problem. We have not yet tested the fix.</a:t>
             </a:r>
           </a:p>
         </p:txBody>
@@ -2438,7 +2434,7 @@
           <a:lstStyle/>
           <a:p>
             <a:r>
-              <a:t>Two controlled improvements, each measured: masking about 3x, tuning closes 38% of the remaining gap. The curves show learning progress on the checkpoint-selection seeds; reported scores come from separate held-out seeds.</a:t>
+              <a:t>Evidence that the work is real and reproducible. 137 tests: 135 run offline; 2 call the live LLM and are skipped without a key. The repository is public on GitHub: KJSK-Koushik/Supply-AI-RL-Explainable-supply-chain-Optimisation.</a:t>
             </a:r>
           </a:p>
         </p:txBody>
@@ -2508,7 +2504,7 @@
           <a:lstStyle/>
           <a:p>
             <a:r>
-              <a:t>Every method loses more than a third of its profit in a crisis; RL is not more adaptive than the tuned classical method. Our attempt to fix that with crisis training did not work. We report it as a negative result.</a:t>
+              <a:t>Listed in descending order of how much they should change a reader's confidence. The first two are the biggest: the data is old and the suppliers are invented.</a:t>
             </a:r>
           </a:p>
         </p:txBody>
@@ -2578,7 +2574,7 @@
           <a:lstStyle/>
           <a:p>
             <a:r>
-              <a:t>Be upfront about both numbers. 83% is the model by itself; 100% is the system with the check. The finding is that the check is essential, not decoration.</a:t>
+              <a:t>Close on the honest claim: the project works end to end, the comparison is fair, the classical method wins, and we know why. The next experiment is aimed straight at the cause.</a:t>
             </a:r>
           </a:p>
         </p:txBody>
@@ -2648,7 +2644,7 @@
           <a:lstStyle/>
           <a:p>
             <a:r>
-              <a:t>We know why it loses. It cannot observe its own ordering history, so it cannot learn to stop fragmenting orders. This is a limit on what it observes, not a tuning problem. We have not yet tested the fix.</a:t>
+              <a:t>Same eight references as the report. The report has the full paper; this is the short list.</a:t>
             </a:r>
           </a:p>
         </p:txBody>
@@ -2674,286 +2670,6 @@
 </file>
 
 <file path=ppt/notesSlides/notesSlide43.xml><?xml version="1.0" encoding="utf-8"?>
-<p:notes xmlns:a="http://schemas.openxmlformats.org/drawingml/2006/main" xmlns:p="http://schemas.openxmlformats.org/presentationml/2006/main" xmlns:r="http://schemas.openxmlformats.org/officeDocument/2006/relationships">
-  <p:cSld>
-    <p:spTree>
-      <p:nvGrpSpPr>
-        <p:cNvPr id="1" name=""/>
-        <p:cNvGrpSpPr/>
-        <p:nvPr/>
-      </p:nvGrpSpPr>
-      <p:grpSpPr>
-        <a:xfrm>
-          <a:off x="0" y="0"/>
-          <a:ext cx="0" cy="0"/>
-          <a:chOff x="0" y="0"/>
-          <a:chExt cx="0" cy="0"/>
-        </a:xfrm>
-      </p:grpSpPr>
-      <p:sp>
-        <p:nvSpPr>
-          <p:cNvPr id="2" name="Slide Image Placeholder 1"/>
-          <p:cNvSpPr>
-            <a:spLocks noGrp="1"/>
-          </p:cNvSpPr>
-          <p:nvPr>
-            <p:ph type="sldImg" idx="2"/>
-          </p:nvPr>
-        </p:nvSpPr>
-        <p:spPr/>
-      </p:sp>
-      <p:sp>
-        <p:nvSpPr>
-          <p:cNvPr id="3" name="Notes Placeholder 2"/>
-          <p:cNvSpPr>
-            <a:spLocks noGrp="1"/>
-          </p:cNvSpPr>
-          <p:nvPr>
-            <p:ph type="body" idx="3" sz="quarter"/>
-          </p:nvPr>
-        </p:nvSpPr>
-        <p:spPr/>
-        <p:txBody>
-          <a:bodyPr/>
-          <a:lstStyle/>
-          <a:p>
-            <a:r>
-              <a:t>Evidence that the work is real and reproducible. 137 tests: 135 run offline; 2 call the live LLM and are skipped without a key. The repository is public on GitHub: KJSK-Koushik/Supply-AI-RL-Explainable-supply-chain-Optimisation.</a:t>
-            </a:r>
-          </a:p>
-        </p:txBody>
-      </p:sp>
-      <p:sp>
-        <p:nvSpPr>
-          <p:cNvPr id="4" name="Slide Number Placeholder 3"/>
-          <p:cNvSpPr>
-            <a:spLocks noGrp="1"/>
-          </p:cNvSpPr>
-          <p:nvPr>
-            <p:ph type="sldNum" idx="5" sz="quarter"/>
-          </p:nvPr>
-        </p:nvSpPr>
-        <p:spPr/>
-      </p:sp>
-    </p:spTree>
-  </p:cSld>
-  <p:clrMapOvr>
-    <a:masterClrMapping/>
-  </p:clrMapOvr>
-</p:notes>
-</file>
-
-<file path=ppt/notesSlides/notesSlide44.xml><?xml version="1.0" encoding="utf-8"?>
-<p:notes xmlns:a="http://schemas.openxmlformats.org/drawingml/2006/main" xmlns:p="http://schemas.openxmlformats.org/presentationml/2006/main" xmlns:r="http://schemas.openxmlformats.org/officeDocument/2006/relationships">
-  <p:cSld>
-    <p:spTree>
-      <p:nvGrpSpPr>
-        <p:cNvPr id="1" name=""/>
-        <p:cNvGrpSpPr/>
-        <p:nvPr/>
-      </p:nvGrpSpPr>
-      <p:grpSpPr>
-        <a:xfrm>
-          <a:off x="0" y="0"/>
-          <a:ext cx="0" cy="0"/>
-          <a:chOff x="0" y="0"/>
-          <a:chExt cx="0" cy="0"/>
-        </a:xfrm>
-      </p:grpSpPr>
-      <p:sp>
-        <p:nvSpPr>
-          <p:cNvPr id="2" name="Slide Image Placeholder 1"/>
-          <p:cNvSpPr>
-            <a:spLocks noGrp="1"/>
-          </p:cNvSpPr>
-          <p:nvPr>
-            <p:ph type="sldImg" idx="2"/>
-          </p:nvPr>
-        </p:nvSpPr>
-        <p:spPr/>
-      </p:sp>
-      <p:sp>
-        <p:nvSpPr>
-          <p:cNvPr id="3" name="Notes Placeholder 2"/>
-          <p:cNvSpPr>
-            <a:spLocks noGrp="1"/>
-          </p:cNvSpPr>
-          <p:nvPr>
-            <p:ph type="body" idx="3" sz="quarter"/>
-          </p:nvPr>
-        </p:nvSpPr>
-        <p:spPr/>
-        <p:txBody>
-          <a:bodyPr/>
-          <a:lstStyle/>
-          <a:p>
-            <a:r>
-              <a:t>Listed in descending order of how much they should change a reader's confidence. The first two are the biggest: the data is old and the suppliers are invented.</a:t>
-            </a:r>
-          </a:p>
-        </p:txBody>
-      </p:sp>
-      <p:sp>
-        <p:nvSpPr>
-          <p:cNvPr id="4" name="Slide Number Placeholder 3"/>
-          <p:cNvSpPr>
-            <a:spLocks noGrp="1"/>
-          </p:cNvSpPr>
-          <p:nvPr>
-            <p:ph type="sldNum" idx="5" sz="quarter"/>
-          </p:nvPr>
-        </p:nvSpPr>
-        <p:spPr/>
-      </p:sp>
-    </p:spTree>
-  </p:cSld>
-  <p:clrMapOvr>
-    <a:masterClrMapping/>
-  </p:clrMapOvr>
-</p:notes>
-</file>
-
-<file path=ppt/notesSlides/notesSlide45.xml><?xml version="1.0" encoding="utf-8"?>
-<p:notes xmlns:a="http://schemas.openxmlformats.org/drawingml/2006/main" xmlns:p="http://schemas.openxmlformats.org/presentationml/2006/main" xmlns:r="http://schemas.openxmlformats.org/officeDocument/2006/relationships">
-  <p:cSld>
-    <p:spTree>
-      <p:nvGrpSpPr>
-        <p:cNvPr id="1" name=""/>
-        <p:cNvGrpSpPr/>
-        <p:nvPr/>
-      </p:nvGrpSpPr>
-      <p:grpSpPr>
-        <a:xfrm>
-          <a:off x="0" y="0"/>
-          <a:ext cx="0" cy="0"/>
-          <a:chOff x="0" y="0"/>
-          <a:chExt cx="0" cy="0"/>
-        </a:xfrm>
-      </p:grpSpPr>
-      <p:sp>
-        <p:nvSpPr>
-          <p:cNvPr id="2" name="Slide Image Placeholder 1"/>
-          <p:cNvSpPr>
-            <a:spLocks noGrp="1"/>
-          </p:cNvSpPr>
-          <p:nvPr>
-            <p:ph type="sldImg" idx="2"/>
-          </p:nvPr>
-        </p:nvSpPr>
-        <p:spPr/>
-      </p:sp>
-      <p:sp>
-        <p:nvSpPr>
-          <p:cNvPr id="3" name="Notes Placeholder 2"/>
-          <p:cNvSpPr>
-            <a:spLocks noGrp="1"/>
-          </p:cNvSpPr>
-          <p:nvPr>
-            <p:ph type="body" idx="3" sz="quarter"/>
-          </p:nvPr>
-        </p:nvSpPr>
-        <p:spPr/>
-        <p:txBody>
-          <a:bodyPr/>
-          <a:lstStyle/>
-          <a:p>
-            <a:r>
-              <a:t>Close on the honest claim: the project works end to end, the comparison is fair, the classical method wins, and we know why. The next experiment is aimed straight at the cause.</a:t>
-            </a:r>
-          </a:p>
-        </p:txBody>
-      </p:sp>
-      <p:sp>
-        <p:nvSpPr>
-          <p:cNvPr id="4" name="Slide Number Placeholder 3"/>
-          <p:cNvSpPr>
-            <a:spLocks noGrp="1"/>
-          </p:cNvSpPr>
-          <p:nvPr>
-            <p:ph type="sldNum" idx="5" sz="quarter"/>
-          </p:nvPr>
-        </p:nvSpPr>
-        <p:spPr/>
-      </p:sp>
-    </p:spTree>
-  </p:cSld>
-  <p:clrMapOvr>
-    <a:masterClrMapping/>
-  </p:clrMapOvr>
-</p:notes>
-</file>
-
-<file path=ppt/notesSlides/notesSlide46.xml><?xml version="1.0" encoding="utf-8"?>
-<p:notes xmlns:a="http://schemas.openxmlformats.org/drawingml/2006/main" xmlns:p="http://schemas.openxmlformats.org/presentationml/2006/main" xmlns:r="http://schemas.openxmlformats.org/officeDocument/2006/relationships">
-  <p:cSld>
-    <p:spTree>
-      <p:nvGrpSpPr>
-        <p:cNvPr id="1" name=""/>
-        <p:cNvGrpSpPr/>
-        <p:nvPr/>
-      </p:nvGrpSpPr>
-      <p:grpSpPr>
-        <a:xfrm>
-          <a:off x="0" y="0"/>
-          <a:ext cx="0" cy="0"/>
-          <a:chOff x="0" y="0"/>
-          <a:chExt cx="0" cy="0"/>
-        </a:xfrm>
-      </p:grpSpPr>
-      <p:sp>
-        <p:nvSpPr>
-          <p:cNvPr id="2" name="Slide Image Placeholder 1"/>
-          <p:cNvSpPr>
-            <a:spLocks noGrp="1"/>
-          </p:cNvSpPr>
-          <p:nvPr>
-            <p:ph type="sldImg" idx="2"/>
-          </p:nvPr>
-        </p:nvSpPr>
-        <p:spPr/>
-      </p:sp>
-      <p:sp>
-        <p:nvSpPr>
-          <p:cNvPr id="3" name="Notes Placeholder 2"/>
-          <p:cNvSpPr>
-            <a:spLocks noGrp="1"/>
-          </p:cNvSpPr>
-          <p:nvPr>
-            <p:ph type="body" idx="3" sz="quarter"/>
-          </p:nvPr>
-        </p:nvSpPr>
-        <p:spPr/>
-        <p:txBody>
-          <a:bodyPr/>
-          <a:lstStyle/>
-          <a:p>
-            <a:r>
-              <a:t>Same eight references as the report. The report has the full paper; this is the short list.</a:t>
-            </a:r>
-          </a:p>
-        </p:txBody>
-      </p:sp>
-      <p:sp>
-        <p:nvSpPr>
-          <p:cNvPr id="4" name="Slide Number Placeholder 3"/>
-          <p:cNvSpPr>
-            <a:spLocks noGrp="1"/>
-          </p:cNvSpPr>
-          <p:nvPr>
-            <p:ph type="sldNum" idx="5" sz="quarter"/>
-          </p:nvPr>
-        </p:nvSpPr>
-        <p:spPr/>
-      </p:sp>
-    </p:spTree>
-  </p:cSld>
-  <p:clrMapOvr>
-    <a:masterClrMapping/>
-  </p:clrMapOvr>
-</p:notes>
-</file>
-
-<file path=ppt/notesSlides/notesSlide47.xml><?xml version="1.0" encoding="utf-8"?>
 <p:notes xmlns:a="http://schemas.openxmlformats.org/drawingml/2006/main" xmlns:p="http://schemas.openxmlformats.org/presentationml/2006/main" xmlns:r="http://schemas.openxmlformats.org/officeDocument/2006/relationships">
   <p:cSld>
     <p:spTree>
@@ -7027,7 +6743,7 @@
                 </a:solidFill>
                 <a:latin typeface="Calibri"/>
               </a:rPr>
-              <a:t>6  Methodology: simulator, agent, baselines</a:t>
+              <a:t>6  Methodology: the agent, the baselines</a:t>
             </a:r>
           </a:p>
           <a:p>
@@ -15184,1790 +14900,6 @@
           <a:p>
             <a:r>
               <a:rPr sz="3200"/>
-              <a:t>Methodology: The Simulator</a:t>
-            </a:r>
-          </a:p>
-        </p:txBody>
-      </p:sp>
-      <p:sp>
-        <p:nvSpPr>
-          <p:cNvPr id="19" name="Slide Number Placeholder 18">
-            <a:extLst>
-              <a:ext uri="{FF2B5EF4-FFF2-40B4-BE49-F238E27FC236}">
-                <a16:creationId xmlns:a16="http://schemas.microsoft.com/office/drawing/2014/main" id="{9B6D94B3-8D6F-6862-5C85-C28EA1FEBFFD}"/>
-              </a:ext>
-            </a:extLst>
-          </p:cNvPr>
-          <p:cNvSpPr>
-            <a:spLocks noGrp="1"/>
-          </p:cNvSpPr>
-          <p:nvPr>
-            <p:ph type="sldNum" sz="quarter" idx="12"/>
-          </p:nvPr>
-        </p:nvSpPr>
-        <p:spPr/>
-        <p:txBody>
-          <a:bodyPr/>
-          <a:lstStyle/>
-          <a:p>
-            <a:fld id="{C2216105-7B7A-4C42-B2A1-5E9A2FA4F8FD}" type="slidenum">
-              <a:rPr lang="en-IN" smtClean="0"/>
-              <a:t>3</a:t>
-            </a:fld>
-            <a:endParaRPr lang="en-IN" dirty="0"/>
-          </a:p>
-        </p:txBody>
-      </p:sp>
-      <p:pic>
-        <p:nvPicPr>
-          <p:cNvPr id="20" name="Picture 19" descr="daily_cycle.png"/>
-          <p:cNvPicPr>
-            <a:picLocks noChangeAspect="1"/>
-          </p:cNvPicPr>
-          <p:nvPr/>
-        </p:nvPicPr>
-        <p:blipFill>
-          <a:blip r:embed="rId2"/>
-          <a:stretch>
-            <a:fillRect/>
-          </a:stretch>
-        </p:blipFill>
-        <p:spPr>
-          <a:xfrm>
-            <a:off x="365760" y="1234440"/>
-            <a:ext cx="11457432" cy="2545698"/>
-          </a:xfrm>
-          <a:prstGeom prst="rect">
-            <a:avLst/>
-          </a:prstGeom>
-        </p:spPr>
-      </p:pic>
-      <p:sp>
-        <p:nvSpPr>
-          <p:cNvPr id="21" name="Rounded Rectangle 20"/>
-          <p:cNvSpPr/>
-          <p:nvPr/>
-        </p:nvSpPr>
-        <p:spPr>
-          <a:xfrm>
-            <a:off x="411480" y="4069080"/>
-            <a:ext cx="3657600" cy="2240280"/>
-          </a:xfrm>
-          <a:prstGeom prst="roundRect">
-            <a:avLst>
-              <a:gd name="adj" fmla="val 7000"/>
-            </a:avLst>
-          </a:prstGeom>
-          <a:solidFill>
-            <a:srgbClr val="F1F5F9"/>
-          </a:solidFill>
-          <a:ln w="22225">
-            <a:solidFill>
-              <a:srgbClr val="2E8B57"/>
-            </a:solidFill>
-          </a:ln>
-          <a:effectLst/>
-        </p:spPr>
-        <p:style>
-          <a:lnRef idx="1">
-            <a:schemeClr val="accent1"/>
-          </a:lnRef>
-          <a:fillRef idx="3">
-            <a:schemeClr val="accent1"/>
-          </a:fillRef>
-          <a:effectRef idx="2">
-            <a:schemeClr val="accent1"/>
-          </a:effectRef>
-          <a:fontRef idx="minor">
-            <a:schemeClr val="lt1"/>
-          </a:fontRef>
-        </p:style>
-        <p:txBody>
-          <a:bodyPr rtlCol="0" anchor="ctr"/>
-          <a:lstStyle/>
-          <a:p/>
-        </p:txBody>
-      </p:sp>
-      <p:sp>
-        <p:nvSpPr>
-          <p:cNvPr id="22" name="TextBox 21"/>
-          <p:cNvSpPr txBox="1"/>
-          <p:nvPr/>
-        </p:nvSpPr>
-        <p:spPr>
-          <a:xfrm>
-            <a:off x="521208" y="4142232"/>
-            <a:ext cx="3438144" cy="2093976"/>
-          </a:xfrm>
-          <a:prstGeom prst="rect">
-            <a:avLst/>
-          </a:prstGeom>
-          <a:noFill/>
-        </p:spPr>
-        <p:txBody>
-          <a:bodyPr wrap="square" anchor="t" lIns="45720" rIns="45720" tIns="27432" bIns="27432">
-            <a:spAutoFit/>
-          </a:bodyPr>
-          <a:lstStyle/>
-          <a:p>
-            <a:pPr algn="l">
-              <a:spcAft>
-                <a:spcPts val="500"/>
-              </a:spcAft>
-            </a:pPr>
-            <a:r>
-              <a:rPr sz="1700" b="1" i="0">
-                <a:solidFill>
-                  <a:srgbClr val="2E8B57"/>
-                </a:solidFill>
-                <a:latin typeface="Calibri"/>
-              </a:rPr>
-              <a:t>Storage cost</a:t>
-            </a:r>
-          </a:p>
-          <a:p>
-            <a:pPr algn="l">
-              <a:spcAft>
-                <a:spcPts val="300"/>
-              </a:spcAft>
-            </a:pPr>
-            <a:r>
-              <a:rPr sz="1400" b="0" i="0">
-                <a:solidFill>
-                  <a:srgbClr val="1F2937"/>
-                </a:solidFill>
-                <a:latin typeface="Calibri"/>
-              </a:rPr>
-              <a:t>•  0.15% of item cost per day</a:t>
-            </a:r>
-          </a:p>
-          <a:p>
-            <a:pPr algn="l">
-              <a:spcAft>
-                <a:spcPts val="300"/>
-              </a:spcAft>
-            </a:pPr>
-            <a:r>
-              <a:rPr sz="1400" b="0" i="0">
-                <a:solidFill>
-                  <a:srgbClr val="1F2937"/>
-                </a:solidFill>
-                <a:latin typeface="Calibri"/>
-              </a:rPr>
-              <a:t>•  High on purpose: seasonal gift items lose value</a:t>
-            </a:r>
-          </a:p>
-          <a:p>
-            <a:pPr algn="l">
-              <a:spcAft>
-                <a:spcPts val="300"/>
-              </a:spcAft>
-            </a:pPr>
-            <a:r>
-              <a:rPr sz="1400" b="0" i="0">
-                <a:solidFill>
-                  <a:srgbClr val="1F2937"/>
-                </a:solidFill>
-                <a:latin typeface="Calibri"/>
-              </a:rPr>
-              <a:t>•  An earlier 730% a year made any stock absurdly costly</a:t>
-            </a:r>
-          </a:p>
-        </p:txBody>
-      </p:sp>
-      <p:sp>
-        <p:nvSpPr>
-          <p:cNvPr id="23" name="Rounded Rectangle 22"/>
-          <p:cNvSpPr/>
-          <p:nvPr/>
-        </p:nvSpPr>
-        <p:spPr>
-          <a:xfrm>
-            <a:off x="4251960" y="4069080"/>
-            <a:ext cx="3657600" cy="2240280"/>
-          </a:xfrm>
-          <a:prstGeom prst="roundRect">
-            <a:avLst>
-              <a:gd name="adj" fmla="val 7000"/>
-            </a:avLst>
-          </a:prstGeom>
-          <a:solidFill>
-            <a:srgbClr val="F1F5F9"/>
-          </a:solidFill>
-          <a:ln w="22225">
-            <a:solidFill>
-              <a:srgbClr val="2F6FB5"/>
-            </a:solidFill>
-          </a:ln>
-          <a:effectLst/>
-        </p:spPr>
-        <p:style>
-          <a:lnRef idx="1">
-            <a:schemeClr val="accent1"/>
-          </a:lnRef>
-          <a:fillRef idx="3">
-            <a:schemeClr val="accent1"/>
-          </a:fillRef>
-          <a:effectRef idx="2">
-            <a:schemeClr val="accent1"/>
-          </a:effectRef>
-          <a:fontRef idx="minor">
-            <a:schemeClr val="lt1"/>
-          </a:fontRef>
-        </p:style>
-        <p:txBody>
-          <a:bodyPr rtlCol="0" anchor="ctr"/>
-          <a:lstStyle/>
-          <a:p/>
-        </p:txBody>
-      </p:sp>
-      <p:sp>
-        <p:nvSpPr>
-          <p:cNvPr id="24" name="TextBox 23"/>
-          <p:cNvSpPr txBox="1"/>
-          <p:nvPr/>
-        </p:nvSpPr>
-        <p:spPr>
-          <a:xfrm>
-            <a:off x="4361688" y="4142232"/>
-            <a:ext cx="3438144" cy="2093976"/>
-          </a:xfrm>
-          <a:prstGeom prst="rect">
-            <a:avLst/>
-          </a:prstGeom>
-          <a:noFill/>
-        </p:spPr>
-        <p:txBody>
-          <a:bodyPr wrap="square" anchor="t" lIns="45720" rIns="45720" tIns="27432" bIns="27432">
-            <a:spAutoFit/>
-          </a:bodyPr>
-          <a:lstStyle/>
-          <a:p>
-            <a:pPr algn="l">
-              <a:spcAft>
-                <a:spcPts val="500"/>
-              </a:spcAft>
-            </a:pPr>
-            <a:r>
-              <a:rPr sz="1700" b="1" i="0">
-                <a:solidFill>
-                  <a:srgbClr val="2F6FB5"/>
-                </a:solidFill>
-                <a:latin typeface="Calibri"/>
-              </a:rPr>
-              <a:t>Leftover stock</a:t>
-            </a:r>
-          </a:p>
-          <a:p>
-            <a:pPr algn="l">
-              <a:spcAft>
-                <a:spcPts val="300"/>
-              </a:spcAft>
-            </a:pPr>
-            <a:r>
-              <a:rPr sz="1400" b="0" i="0">
-                <a:solidFill>
-                  <a:srgbClr val="1F2937"/>
-                </a:solidFill>
-                <a:latin typeface="Calibri"/>
-              </a:rPr>
-              <a:t>•  Worth 60% of cost at day 180</a:t>
-            </a:r>
-          </a:p>
-          <a:p>
-            <a:pPr algn="l">
-              <a:spcAft>
-                <a:spcPts val="300"/>
-              </a:spcAft>
-            </a:pPr>
-            <a:r>
-              <a:rPr sz="1400" b="0" i="0">
-                <a:solidFill>
-                  <a:srgbClr val="1F2937"/>
-                </a:solidFill>
-                <a:latin typeface="Calibri"/>
-              </a:rPr>
-              <a:t>•  An earlier version wrote it off, an artefact of stopping at 180 days</a:t>
-            </a:r>
-          </a:p>
-        </p:txBody>
-      </p:sp>
-      <p:sp>
-        <p:nvSpPr>
-          <p:cNvPr id="25" name="Rounded Rectangle 24"/>
-          <p:cNvSpPr/>
-          <p:nvPr/>
-        </p:nvSpPr>
-        <p:spPr>
-          <a:xfrm>
-            <a:off x="8092440" y="4069080"/>
-            <a:ext cx="3685032" cy="2240280"/>
-          </a:xfrm>
-          <a:prstGeom prst="roundRect">
-            <a:avLst>
-              <a:gd name="adj" fmla="val 7000"/>
-            </a:avLst>
-          </a:prstGeom>
-          <a:solidFill>
-            <a:srgbClr val="F1F5F9"/>
-          </a:solidFill>
-          <a:ln w="22225">
-            <a:solidFill>
-              <a:srgbClr val="D6336C"/>
-            </a:solidFill>
-          </a:ln>
-          <a:effectLst/>
-        </p:spPr>
-        <p:style>
-          <a:lnRef idx="1">
-            <a:schemeClr val="accent1"/>
-          </a:lnRef>
-          <a:fillRef idx="3">
-            <a:schemeClr val="accent1"/>
-          </a:fillRef>
-          <a:effectRef idx="2">
-            <a:schemeClr val="accent1"/>
-          </a:effectRef>
-          <a:fontRef idx="minor">
-            <a:schemeClr val="lt1"/>
-          </a:fontRef>
-        </p:style>
-        <p:txBody>
-          <a:bodyPr rtlCol="0" anchor="ctr"/>
-          <a:lstStyle/>
-          <a:p/>
-        </p:txBody>
-      </p:sp>
-      <p:sp>
-        <p:nvSpPr>
-          <p:cNvPr id="26" name="TextBox 25"/>
-          <p:cNvSpPr txBox="1"/>
-          <p:nvPr/>
-        </p:nvSpPr>
-        <p:spPr>
-          <a:xfrm>
-            <a:off x="8202167" y="4142232"/>
-            <a:ext cx="3465576" cy="2093976"/>
-          </a:xfrm>
-          <a:prstGeom prst="rect">
-            <a:avLst/>
-          </a:prstGeom>
-          <a:noFill/>
-        </p:spPr>
-        <p:txBody>
-          <a:bodyPr wrap="square" anchor="t" lIns="45720" rIns="45720" tIns="27432" bIns="27432">
-            <a:spAutoFit/>
-          </a:bodyPr>
-          <a:lstStyle/>
-          <a:p>
-            <a:pPr algn="l">
-              <a:spcAft>
-                <a:spcPts val="500"/>
-              </a:spcAft>
-            </a:pPr>
-            <a:r>
-              <a:rPr sz="1700" b="1" i="0">
-                <a:solidFill>
-                  <a:srgbClr val="D6336C"/>
-                </a:solidFill>
-                <a:latin typeface="Calibri"/>
-              </a:rPr>
-              <a:t>One shared warehouse</a:t>
-            </a:r>
-          </a:p>
-          <a:p>
-            <a:pPr algn="l">
-              <a:spcAft>
-                <a:spcPts val="300"/>
-              </a:spcAft>
-            </a:pPr>
-            <a:r>
-              <a:rPr sz="1400" b="0" i="0">
-                <a:solidFill>
-                  <a:srgbClr val="1F2937"/>
-                </a:solidFill>
-                <a:latin typeface="Calibri"/>
-              </a:rPr>
-              <a:t>•  With per-product limits, “always order the maximum” was best</a:t>
-            </a:r>
-          </a:p>
-          <a:p>
-            <a:pPr algn="l">
-              <a:spcAft>
-                <a:spcPts val="300"/>
-              </a:spcAft>
-            </a:pPr>
-            <a:r>
-              <a:rPr sz="1400" b="0" i="0">
-                <a:solidFill>
-                  <a:srgbClr val="1F2937"/>
-                </a:solidFill>
-                <a:latin typeface="Calibri"/>
-              </a:rPr>
-              <a:t>•  A shared limit made ordering a real trade-off</a:t>
-            </a:r>
-          </a:p>
-        </p:txBody>
-      </p:sp>
-    </p:spTree>
-  </p:cSld>
-  <p:clrMapOvr>
-    <a:masterClrMapping/>
-  </p:clrMapOvr>
-</p:sld>
-</file>
-
-<file path=ppt/slides/slide27.xml><?xml version="1.0" encoding="utf-8"?>
-<p:sld xmlns:a="http://schemas.openxmlformats.org/drawingml/2006/main" xmlns:p="http://schemas.openxmlformats.org/presentationml/2006/main" xmlns:r="http://schemas.openxmlformats.org/officeDocument/2006/relationships">
-  <p:cSld>
-    <p:spTree>
-      <p:nvGrpSpPr>
-        <p:cNvPr id="1" name=""/>
-        <p:cNvGrpSpPr/>
-        <p:nvPr/>
-      </p:nvGrpSpPr>
-      <p:grpSpPr/>
-      <p:sp>
-        <p:nvSpPr>
-          <p:cNvPr id="17" name="Rectangle 16">
-            <a:extLst>
-              <a:ext uri="{FF2B5EF4-FFF2-40B4-BE49-F238E27FC236}">
-                <a16:creationId xmlns:a16="http://schemas.microsoft.com/office/drawing/2014/main" id="{684365C9-E666-36EE-4DB1-04791BFC26FB}"/>
-              </a:ext>
-            </a:extLst>
-          </p:cNvPr>
-          <p:cNvSpPr/>
-          <p:nvPr/>
-        </p:nvSpPr>
-        <p:spPr>
-          <a:xfrm>
-            <a:off x="-1" y="0"/>
-            <a:ext cx="12191998" cy="1262131"/>
-          </a:xfrm>
-          <a:prstGeom prst="rect">
-            <a:avLst/>
-          </a:prstGeom>
-          <a:gradFill flip="none" rotWithShape="1">
-            <a:gsLst>
-              <a:gs pos="0">
-                <a:srgbClr val="1A9B46">
-                  <a:tint val="66000"/>
-                  <a:satMod val="160000"/>
-                </a:srgbClr>
-              </a:gs>
-              <a:gs pos="50000">
-                <a:srgbClr val="1A9B46">
-                  <a:tint val="44500"/>
-                  <a:satMod val="160000"/>
-                </a:srgbClr>
-              </a:gs>
-              <a:gs pos="100000">
-                <a:srgbClr val="1A9B46">
-                  <a:tint val="23500"/>
-                  <a:satMod val="160000"/>
-                </a:srgbClr>
-              </a:gs>
-            </a:gsLst>
-            <a:path path="circle">
-              <a:fillToRect l="50000" t="50000" r="50000" b="50000"/>
-            </a:path>
-            <a:tileRect/>
-          </a:gradFill>
-          <a:ln>
-            <a:noFill/>
-          </a:ln>
-        </p:spPr>
-        <p:style>
-          <a:lnRef idx="2">
-            <a:schemeClr val="accent1">
-              <a:shade val="50000"/>
-            </a:schemeClr>
-          </a:lnRef>
-          <a:fillRef idx="1">
-            <a:schemeClr val="accent1"/>
-          </a:fillRef>
-          <a:effectRef idx="0">
-            <a:schemeClr val="accent1"/>
-          </a:effectRef>
-          <a:fontRef idx="minor">
-            <a:schemeClr val="lt1"/>
-          </a:fontRef>
-        </p:style>
-        <p:txBody>
-          <a:bodyPr rtlCol="0" anchor="ctr"/>
-          <a:lstStyle/>
-          <a:p>
-            <a:pPr algn="ctr"/>
-            <a:endParaRPr lang="en-IN" sz="4400" dirty="0">
-              <a:solidFill>
-                <a:schemeClr val="accent1">
-                  <a:lumMod val="50000"/>
-                </a:schemeClr>
-              </a:solidFill>
-            </a:endParaRPr>
-          </a:p>
-        </p:txBody>
-      </p:sp>
-      <p:sp>
-        <p:nvSpPr>
-          <p:cNvPr id="10" name="Google Shape;91;p1">
-            <a:extLst>
-              <a:ext uri="{FF2B5EF4-FFF2-40B4-BE49-F238E27FC236}">
-                <a16:creationId xmlns:a16="http://schemas.microsoft.com/office/drawing/2014/main" id="{4D89FC00-7640-2DC1-0BAF-6A1DC613CF6B}"/>
-              </a:ext>
-            </a:extLst>
-          </p:cNvPr>
-          <p:cNvSpPr txBox="1"/>
-          <p:nvPr/>
-        </p:nvSpPr>
-        <p:spPr>
-          <a:xfrm>
-            <a:off x="-1" y="6416040"/>
-            <a:ext cx="12191998" cy="441960"/>
-          </a:xfrm>
-          <a:prstGeom prst="rect">
-            <a:avLst/>
-          </a:prstGeom>
-          <a:gradFill flip="none" rotWithShape="1">
-            <a:gsLst>
-              <a:gs pos="0">
-                <a:srgbClr val="1A9B46">
-                  <a:tint val="66000"/>
-                  <a:satMod val="160000"/>
-                </a:srgbClr>
-              </a:gs>
-              <a:gs pos="50000">
-                <a:srgbClr val="1A9B46">
-                  <a:tint val="44500"/>
-                  <a:satMod val="160000"/>
-                </a:srgbClr>
-              </a:gs>
-              <a:gs pos="100000">
-                <a:srgbClr val="1A9B46">
-                  <a:tint val="23500"/>
-                  <a:satMod val="160000"/>
-                </a:srgbClr>
-              </a:gs>
-            </a:gsLst>
-            <a:path path="circle">
-              <a:fillToRect l="50000" t="50000" r="50000" b="50000"/>
-            </a:path>
-            <a:tileRect/>
-          </a:gradFill>
-          <a:ln>
-            <a:noFill/>
-          </a:ln>
-        </p:spPr>
-        <p:txBody>
-          <a:bodyPr spcFirstLastPara="1" wrap="square" lIns="91425" tIns="45700" rIns="91425" bIns="45700" anchor="t" anchorCtr="0">
-            <a:noAutofit/>
-          </a:bodyPr>
-          <a:lstStyle/>
-          <a:p>
-            <a:pPr marL="0" marR="0" lvl="0" indent="0" algn="ctr" rtl="0">
-              <a:lnSpc>
-                <a:spcPct val="90000"/>
-              </a:lnSpc>
-              <a:spcBef>
-                <a:spcPts val="0"/>
-              </a:spcBef>
-              <a:spcAft>
-                <a:spcPts val="0"/>
-              </a:spcAft>
-              <a:buNone/>
-            </a:pPr>
-            <a:r>
-              <a:rPr lang="en-IN" sz="1600" b="1" i="0" u="none" strike="noStrike" cap="none" dirty="0">
-                <a:solidFill>
-                  <a:srgbClr val="081271"/>
-                </a:solidFill>
-                <a:latin typeface="Times New Roman"/>
-                <a:ea typeface="Times New Roman"/>
-                <a:cs typeface="Times New Roman"/>
-                <a:sym typeface="Times New Roman"/>
-              </a:rPr>
-              <a:t>[Final Project Review]</a:t>
-            </a:r>
-            <a:r>
-              <a:rPr lang="en-IN" sz="1600" b="1" dirty="0">
-                <a:solidFill>
-                  <a:srgbClr val="081271"/>
-                </a:solidFill>
-                <a:latin typeface="Times New Roman"/>
-                <a:ea typeface="Times New Roman"/>
-                <a:cs typeface="Times New Roman"/>
-                <a:sym typeface="Times New Roman"/>
-              </a:rPr>
-              <a:t/>
-            </a:r>
-            <a:r>
-              <a:rPr lang="en-IN" sz="1600" b="1" i="0" u="none" strike="noStrike" cap="none" dirty="0">
-                <a:solidFill>
-                  <a:srgbClr val="081271"/>
-                </a:solidFill>
-                <a:latin typeface="Times New Roman"/>
-                <a:ea typeface="Times New Roman"/>
-                <a:cs typeface="Times New Roman"/>
-                <a:sym typeface="Times New Roman"/>
-              </a:rPr>
-              <a:t/>
-            </a:r>
-            <a:endParaRPr sz="1600" b="1" i="0" u="none" strike="noStrike" cap="none" dirty="0">
-              <a:solidFill>
-                <a:srgbClr val="081271"/>
-              </a:solidFill>
-              <a:latin typeface="Times New Roman"/>
-              <a:ea typeface="Times New Roman"/>
-              <a:cs typeface="Times New Roman"/>
-              <a:sym typeface="Times New Roman"/>
-            </a:endParaRPr>
-          </a:p>
-        </p:txBody>
-      </p:sp>
-      <p:cxnSp>
-        <p:nvCxnSpPr>
-          <p:cNvPr id="16" name="Straight Connector 15">
-            <a:extLst>
-              <a:ext uri="{FF2B5EF4-FFF2-40B4-BE49-F238E27FC236}">
-                <a16:creationId xmlns:a16="http://schemas.microsoft.com/office/drawing/2014/main" id="{170CA935-25F2-6478-C664-35BFDF7E813C}"/>
-              </a:ext>
-            </a:extLst>
-          </p:cNvPr>
-          <p:cNvCxnSpPr/>
-          <p:nvPr/>
-        </p:nvCxnSpPr>
-        <p:spPr>
-          <a:xfrm>
-            <a:off x="0" y="1260899"/>
-            <a:ext cx="12192000" cy="0"/>
-          </a:xfrm>
-          <a:prstGeom prst="line">
-            <a:avLst/>
-          </a:prstGeom>
-          <a:ln w="28575">
-            <a:solidFill>
-              <a:srgbClr val="1A9B46"/>
-            </a:solidFill>
-          </a:ln>
-        </p:spPr>
-        <p:style>
-          <a:lnRef idx="1">
-            <a:schemeClr val="accent1"/>
-          </a:lnRef>
-          <a:fillRef idx="0">
-            <a:schemeClr val="accent1"/>
-          </a:fillRef>
-          <a:effectRef idx="0">
-            <a:schemeClr val="accent1"/>
-          </a:effectRef>
-          <a:fontRef idx="minor">
-            <a:schemeClr val="tx1"/>
-          </a:fontRef>
-        </p:style>
-      </p:cxnSp>
-      <p:sp>
-        <p:nvSpPr>
-          <p:cNvPr id="2" name="Title 1"/>
-          <p:cNvSpPr>
-            <a:spLocks noGrp="1"/>
-          </p:cNvSpPr>
-          <p:nvPr>
-            <p:ph type="title"/>
-          </p:nvPr>
-        </p:nvSpPr>
-        <p:spPr/>
-        <p:txBody>
-          <a:bodyPr/>
-          <a:lstStyle/>
-          <a:p>
-            <a:r>
-              <a:rPr sz="3200"/>
-              <a:t>Methodology: The RL Agent</a:t>
-            </a:r>
-          </a:p>
-        </p:txBody>
-      </p:sp>
-      <p:sp>
-        <p:nvSpPr>
-          <p:cNvPr id="19" name="Slide Number Placeholder 18">
-            <a:extLst>
-              <a:ext uri="{FF2B5EF4-FFF2-40B4-BE49-F238E27FC236}">
-                <a16:creationId xmlns:a16="http://schemas.microsoft.com/office/drawing/2014/main" id="{9B6D94B3-8D6F-6862-5C85-C28EA1FEBFFD}"/>
-              </a:ext>
-            </a:extLst>
-          </p:cNvPr>
-          <p:cNvSpPr>
-            <a:spLocks noGrp="1"/>
-          </p:cNvSpPr>
-          <p:nvPr>
-            <p:ph type="sldNum" sz="quarter" idx="12"/>
-          </p:nvPr>
-        </p:nvSpPr>
-        <p:spPr/>
-        <p:txBody>
-          <a:bodyPr/>
-          <a:lstStyle/>
-          <a:p>
-            <a:fld id="{C2216105-7B7A-4C42-B2A1-5E9A2FA4F8FD}" type="slidenum">
-              <a:rPr lang="en-IN" smtClean="0"/>
-              <a:t>3</a:t>
-            </a:fld>
-            <a:endParaRPr lang="en-IN" dirty="0"/>
-          </a:p>
-        </p:txBody>
-      </p:sp>
-      <p:sp>
-        <p:nvSpPr>
-          <p:cNvPr id="20" name="Rounded Rectangle 19"/>
-          <p:cNvSpPr/>
-          <p:nvPr/>
-        </p:nvSpPr>
-        <p:spPr>
-          <a:xfrm>
-            <a:off x="411480" y="1371600"/>
-            <a:ext cx="3657600" cy="2331720"/>
-          </a:xfrm>
-          <a:prstGeom prst="roundRect">
-            <a:avLst>
-              <a:gd name="adj" fmla="val 7000"/>
-            </a:avLst>
-          </a:prstGeom>
-          <a:solidFill>
-            <a:srgbClr val="E7F0FA"/>
-          </a:solidFill>
-          <a:ln w="22225">
-            <a:solidFill>
-              <a:srgbClr val="2F6FB5"/>
-            </a:solidFill>
-          </a:ln>
-          <a:effectLst/>
-        </p:spPr>
-        <p:style>
-          <a:lnRef idx="1">
-            <a:schemeClr val="accent1"/>
-          </a:lnRef>
-          <a:fillRef idx="3">
-            <a:schemeClr val="accent1"/>
-          </a:fillRef>
-          <a:effectRef idx="2">
-            <a:schemeClr val="accent1"/>
-          </a:effectRef>
-          <a:fontRef idx="minor">
-            <a:schemeClr val="lt1"/>
-          </a:fontRef>
-        </p:style>
-        <p:txBody>
-          <a:bodyPr rtlCol="0" anchor="ctr"/>
-          <a:lstStyle/>
-          <a:p/>
-        </p:txBody>
-      </p:sp>
-      <p:sp>
-        <p:nvSpPr>
-          <p:cNvPr id="21" name="TextBox 20"/>
-          <p:cNvSpPr txBox="1"/>
-          <p:nvPr/>
-        </p:nvSpPr>
-        <p:spPr>
-          <a:xfrm>
-            <a:off x="521208" y="1444752"/>
-            <a:ext cx="3438144" cy="2185415"/>
-          </a:xfrm>
-          <a:prstGeom prst="rect">
-            <a:avLst/>
-          </a:prstGeom>
-          <a:noFill/>
-        </p:spPr>
-        <p:txBody>
-          <a:bodyPr wrap="square" anchor="t" lIns="45720" rIns="45720" tIns="27432" bIns="27432">
-            <a:spAutoFit/>
-          </a:bodyPr>
-          <a:lstStyle/>
-          <a:p>
-            <a:pPr algn="l">
-              <a:spcAft>
-                <a:spcPts val="500"/>
-              </a:spcAft>
-            </a:pPr>
-            <a:r>
-              <a:rPr sz="1700" b="1" i="0">
-                <a:solidFill>
-                  <a:srgbClr val="2F6FB5"/>
-                </a:solidFill>
-                <a:latin typeface="Calibri"/>
-              </a:rPr>
-              <a:t>What it sees: 88 numbers</a:t>
-            </a:r>
-          </a:p>
-          <a:p>
-            <a:pPr algn="l">
-              <a:spcAft>
-                <a:spcPts val="300"/>
-              </a:spcAft>
-            </a:pPr>
-            <a:r>
-              <a:rPr sz="1400" b="0" i="0">
-                <a:solidFill>
-                  <a:srgbClr val="1F2937"/>
-                </a:solidFill>
-                <a:latin typeface="Calibri"/>
-              </a:rPr>
-              <a:t>•  Per product: stock, stock on order, days of cover, 7-day demand, variability, trend, backlog</a:t>
-            </a:r>
-          </a:p>
-          <a:p>
-            <a:pPr algn="l">
-              <a:spcAft>
-                <a:spcPts val="300"/>
-              </a:spcAft>
-            </a:pPr>
-            <a:r>
-              <a:rPr sz="1400" b="0" i="0">
-                <a:solidFill>
-                  <a:srgbClr val="1F2937"/>
-                </a:solidFill>
-                <a:latin typeface="Calibri"/>
-              </a:rPr>
-              <a:t>•  Weekday, season, supplier availability, lead time, reliability</a:t>
-            </a:r>
-          </a:p>
-        </p:txBody>
-      </p:sp>
-      <p:sp>
-        <p:nvSpPr>
-          <p:cNvPr id="22" name="Rounded Rectangle 21"/>
-          <p:cNvSpPr/>
-          <p:nvPr/>
-        </p:nvSpPr>
-        <p:spPr>
-          <a:xfrm>
-            <a:off x="4251960" y="1371600"/>
-            <a:ext cx="3657600" cy="2331720"/>
-          </a:xfrm>
-          <a:prstGeom prst="roundRect">
-            <a:avLst>
-              <a:gd name="adj" fmla="val 7000"/>
-            </a:avLst>
-          </a:prstGeom>
-          <a:solidFill>
-            <a:srgbClr val="FDE8EF"/>
-          </a:solidFill>
-          <a:ln w="22225">
-            <a:solidFill>
-              <a:srgbClr val="D6336C"/>
-            </a:solidFill>
-          </a:ln>
-          <a:effectLst/>
-        </p:spPr>
-        <p:style>
-          <a:lnRef idx="1">
-            <a:schemeClr val="accent1"/>
-          </a:lnRef>
-          <a:fillRef idx="3">
-            <a:schemeClr val="accent1"/>
-          </a:fillRef>
-          <a:effectRef idx="2">
-            <a:schemeClr val="accent1"/>
-          </a:effectRef>
-          <a:fontRef idx="minor">
-            <a:schemeClr val="lt1"/>
-          </a:fontRef>
-        </p:style>
-        <p:txBody>
-          <a:bodyPr rtlCol="0" anchor="ctr"/>
-          <a:lstStyle/>
-          <a:p/>
-        </p:txBody>
-      </p:sp>
-      <p:sp>
-        <p:nvSpPr>
-          <p:cNvPr id="23" name="TextBox 22"/>
-          <p:cNvSpPr txBox="1"/>
-          <p:nvPr/>
-        </p:nvSpPr>
-        <p:spPr>
-          <a:xfrm>
-            <a:off x="4361688" y="1444752"/>
-            <a:ext cx="3438144" cy="2185415"/>
-          </a:xfrm>
-          <a:prstGeom prst="rect">
-            <a:avLst/>
-          </a:prstGeom>
-          <a:noFill/>
-        </p:spPr>
-        <p:txBody>
-          <a:bodyPr wrap="square" anchor="t" lIns="45720" rIns="45720" tIns="27432" bIns="27432">
-            <a:spAutoFit/>
-          </a:bodyPr>
-          <a:lstStyle/>
-          <a:p>
-            <a:pPr algn="l">
-              <a:spcAft>
-                <a:spcPts val="500"/>
-              </a:spcAft>
-            </a:pPr>
-            <a:r>
-              <a:rPr sz="1700" b="1" i="0">
-                <a:solidFill>
-                  <a:srgbClr val="D6336C"/>
-                </a:solidFill>
-                <a:latin typeface="Calibri"/>
-              </a:rPr>
-              <a:t>What it decides</a:t>
-            </a:r>
-          </a:p>
-          <a:p>
-            <a:pPr algn="l">
-              <a:spcAft>
-                <a:spcPts val="300"/>
-              </a:spcAft>
-            </a:pPr>
-            <a:r>
-              <a:rPr sz="1400" b="0" i="0">
-                <a:solidFill>
-                  <a:srgbClr val="1F2937"/>
-                </a:solidFill>
-                <a:latin typeface="Calibri"/>
-              </a:rPr>
-              <a:t>•  One of 21 options per product</a:t>
-            </a:r>
-          </a:p>
-          <a:p>
-            <a:pPr algn="l">
-              <a:spcAft>
-                <a:spcPts val="300"/>
-              </a:spcAft>
-            </a:pPr>
-            <a:r>
-              <a:rPr sz="1400" b="0" i="0">
-                <a:solidFill>
-                  <a:srgbClr val="1F2937"/>
-                </a:solidFill>
-                <a:latin typeface="Calibri"/>
-              </a:rPr>
-              <a:t>•  7 quantity levels × 3 suppliers</a:t>
-            </a:r>
-          </a:p>
-          <a:p>
-            <a:pPr algn="l">
-              <a:spcAft>
-                <a:spcPts val="300"/>
-              </a:spcAft>
-            </a:pPr>
-            <a:r>
-              <a:rPr sz="1400" b="0" i="0">
-                <a:solidFill>
-                  <a:srgbClr val="1F2937"/>
-                </a:solidFill>
-                <a:latin typeface="Calibri"/>
-              </a:rPr>
-              <a:t>•  Offline suppliers and oversize orders are masked</a:t>
-            </a:r>
-          </a:p>
-        </p:txBody>
-      </p:sp>
-      <p:sp>
-        <p:nvSpPr>
-          <p:cNvPr id="24" name="Rounded Rectangle 23"/>
-          <p:cNvSpPr/>
-          <p:nvPr/>
-        </p:nvSpPr>
-        <p:spPr>
-          <a:xfrm>
-            <a:off x="8092440" y="1371600"/>
-            <a:ext cx="3685032" cy="2331720"/>
-          </a:xfrm>
-          <a:prstGeom prst="roundRect">
-            <a:avLst>
-              <a:gd name="adj" fmla="val 7000"/>
-            </a:avLst>
-          </a:prstGeom>
-          <a:solidFill>
-            <a:srgbClr val="E6F4EA"/>
-          </a:solidFill>
-          <a:ln w="22225">
-            <a:solidFill>
-              <a:srgbClr val="2E8B57"/>
-            </a:solidFill>
-          </a:ln>
-          <a:effectLst/>
-        </p:spPr>
-        <p:style>
-          <a:lnRef idx="1">
-            <a:schemeClr val="accent1"/>
-          </a:lnRef>
-          <a:fillRef idx="3">
-            <a:schemeClr val="accent1"/>
-          </a:fillRef>
-          <a:effectRef idx="2">
-            <a:schemeClr val="accent1"/>
-          </a:effectRef>
-          <a:fontRef idx="minor">
-            <a:schemeClr val="lt1"/>
-          </a:fontRef>
-        </p:style>
-        <p:txBody>
-          <a:bodyPr rtlCol="0" anchor="ctr"/>
-          <a:lstStyle/>
-          <a:p/>
-        </p:txBody>
-      </p:sp>
-      <p:sp>
-        <p:nvSpPr>
-          <p:cNvPr id="25" name="TextBox 24"/>
-          <p:cNvSpPr txBox="1"/>
-          <p:nvPr/>
-        </p:nvSpPr>
-        <p:spPr>
-          <a:xfrm>
-            <a:off x="8202167" y="1444752"/>
-            <a:ext cx="3465576" cy="2185415"/>
-          </a:xfrm>
-          <a:prstGeom prst="rect">
-            <a:avLst/>
-          </a:prstGeom>
-          <a:noFill/>
-        </p:spPr>
-        <p:txBody>
-          <a:bodyPr wrap="square" anchor="t" lIns="45720" rIns="45720" tIns="27432" bIns="27432">
-            <a:spAutoFit/>
-          </a:bodyPr>
-          <a:lstStyle/>
-          <a:p>
-            <a:pPr algn="l">
-              <a:spcAft>
-                <a:spcPts val="500"/>
-              </a:spcAft>
-            </a:pPr>
-            <a:r>
-              <a:rPr sz="1700" b="1" i="0">
-                <a:solidFill>
-                  <a:srgbClr val="2E8B57"/>
-                </a:solidFill>
-                <a:latin typeface="Calibri"/>
-              </a:rPr>
-              <a:t>What it is rewarded for</a:t>
-            </a:r>
-          </a:p>
-          <a:p>
-            <a:pPr algn="l">
-              <a:spcAft>
-                <a:spcPts val="300"/>
-              </a:spcAft>
-            </a:pPr>
-            <a:r>
-              <a:rPr sz="1400" b="0" i="0">
-                <a:solidFill>
-                  <a:srgbClr val="1F2937"/>
-                </a:solidFill>
-                <a:latin typeface="Calibri"/>
-              </a:rPr>
-              <a:t>•  That day’s profit, scaled and clipped</a:t>
-            </a:r>
-          </a:p>
-          <a:p>
-            <a:pPr algn="l">
-              <a:spcAft>
-                <a:spcPts val="300"/>
-              </a:spcAft>
-            </a:pPr>
-            <a:r>
-              <a:rPr sz="1400" b="0" i="0">
-                <a:solidFill>
-                  <a:srgbClr val="1F2937"/>
-                </a:solidFill>
-                <a:latin typeface="Calibri"/>
-              </a:rPr>
-              <a:t>•  Zero during the 14-day warm-up</a:t>
-            </a:r>
-          </a:p>
-          <a:p>
-            <a:pPr algn="l">
-              <a:spcAft>
-                <a:spcPts val="300"/>
-              </a:spcAft>
-            </a:pPr>
-            <a:r>
-              <a:rPr sz="1400" b="0" i="0">
-                <a:solidFill>
-                  <a:srgbClr val="1F2937"/>
-                </a:solidFill>
-                <a:latin typeface="Calibri"/>
-              </a:rPr>
-              <a:t>•  Not shown: any ordering history (see error analysis)</a:t>
-            </a:r>
-          </a:p>
-        </p:txBody>
-      </p:sp>
-      <p:graphicFrame>
-        <p:nvGraphicFramePr>
-          <p:cNvPr id="26" name="Table 25"/>
-          <p:cNvGraphicFramePr>
-            <a:graphicFrameLocks noGrp="1"/>
-          </p:cNvGraphicFramePr>
-          <p:nvPr/>
-        </p:nvGraphicFramePr>
-        <p:xfrm>
-          <a:off x="411480" y="3931920"/>
-          <a:ext cx="5120640" cy="2194560"/>
-        </p:xfrm>
-        <a:graphic>
-          <a:graphicData uri="http://schemas.openxmlformats.org/drawingml/2006/table">
-            <a:tbl>
-              <a:tblPr firstRow="1" bandRow="1">
-                <a:tableStyleId>{5C22544A-7EE6-4342-B048-85BDC9FD1C3A}</a:tableStyleId>
-              </a:tblPr>
-              <a:tblGrid>
-                <a:gridCol w="2560320"/>
-                <a:gridCol w="2560320"/>
-              </a:tblGrid>
-              <a:tr h="365760">
-                <a:tc>
-                  <a:txBody>
-                    <a:bodyPr wrap="square"/>
-                    <a:lstStyle/>
-                    <a:p>
-                      <a:pPr algn="l"/>
-                      <a:r>
-                        <a:rPr sz="1300" b="1" i="0">
-                          <a:solidFill>
-                            <a:srgbClr val="FFFFFF"/>
-                          </a:solidFill>
-                          <a:latin typeface="Calibri"/>
-                        </a:rPr>
-                        <a:t>Winning setting</a:t>
-                      </a:r>
-                    </a:p>
-                  </a:txBody>
-                  <a:tcPr marL="54864" marR="54864" marT="18288" marB="18288" anchor="ctr">
-                    <a:solidFill>
-                      <a:srgbClr val="2E8B57"/>
-                    </a:solidFill>
-                  </a:tcPr>
-                </a:tc>
-                <a:tc>
-                  <a:txBody>
-                    <a:bodyPr wrap="square"/>
-                    <a:lstStyle/>
-                    <a:p>
-                      <a:pPr algn="ctr"/>
-                      <a:r>
-                        <a:rPr sz="1300" b="1" i="0">
-                          <a:solidFill>
-                            <a:srgbClr val="FFFFFF"/>
-                          </a:solidFill>
-                          <a:latin typeface="Calibri"/>
-                        </a:rPr>
-                        <a:t>Value</a:t>
-                      </a:r>
-                    </a:p>
-                  </a:txBody>
-                  <a:tcPr marL="54864" marR="54864" marT="18288" marB="18288" anchor="ctr">
-                    <a:solidFill>
-                      <a:srgbClr val="2E8B57"/>
-                    </a:solidFill>
-                  </a:tcPr>
-                </a:tc>
-              </a:tr>
-              <a:tr h="365760">
-                <a:tc>
-                  <a:txBody>
-                    <a:bodyPr wrap="square"/>
-                    <a:lstStyle/>
-                    <a:p>
-                      <a:r>
-                        <a:rPr sz="1300" b="0" i="0">
-                          <a:solidFill>
-                            <a:srgbClr val="1F2937"/>
-                          </a:solidFill>
-                          <a:latin typeface="Calibri"/>
-                        </a:rPr>
-                        <a:t>Learning rate</a:t>
-                      </a:r>
-                    </a:p>
-                  </a:txBody>
-                  <a:tcPr marL="54864" marR="54864" marT="18288" marB="18288" anchor="ctr">
-                    <a:solidFill>
-                      <a:srgbClr val="FFFFFF"/>
-                    </a:solidFill>
-                  </a:tcPr>
-                </a:tc>
-                <a:tc>
-                  <a:txBody>
-                    <a:bodyPr wrap="square"/>
-                    <a:lstStyle/>
-                    <a:p>
-                      <a:pPr algn="ctr"/>
-                      <a:r>
-                        <a:rPr sz="1300" b="0" i="0">
-                          <a:solidFill>
-                            <a:srgbClr val="1F2937"/>
-                          </a:solidFill>
-                          <a:latin typeface="Calibri"/>
-                        </a:rPr>
-                        <a:t>5e-5 (lowest offered)</a:t>
-                      </a:r>
-                    </a:p>
-                  </a:txBody>
-                  <a:tcPr marL="54864" marR="54864" marT="18288" marB="18288" anchor="ctr">
-                    <a:solidFill>
-                      <a:srgbClr val="FFFFFF"/>
-                    </a:solidFill>
-                  </a:tcPr>
-                </a:tc>
-              </a:tr>
-              <a:tr h="365760">
-                <a:tc>
-                  <a:txBody>
-                    <a:bodyPr wrap="square"/>
-                    <a:lstStyle/>
-                    <a:p>
-                      <a:r>
-                        <a:rPr sz="1300" b="0" i="0">
-                          <a:solidFill>
-                            <a:srgbClr val="1F2937"/>
-                          </a:solidFill>
-                          <a:latin typeface="Calibri"/>
-                        </a:rPr>
-                        <a:t>Entropy coefficient</a:t>
-                      </a:r>
-                    </a:p>
-                  </a:txBody>
-                  <a:tcPr marL="54864" marR="54864" marT="18288" marB="18288" anchor="ctr">
-                    <a:solidFill>
-                      <a:srgbClr val="F1F5F9"/>
-                    </a:solidFill>
-                  </a:tcPr>
-                </a:tc>
-                <a:tc>
-                  <a:txBody>
-                    <a:bodyPr wrap="square"/>
-                    <a:lstStyle/>
-                    <a:p>
-                      <a:pPr algn="ctr"/>
-                      <a:r>
-                        <a:rPr sz="1300" b="0" i="0">
-                          <a:solidFill>
-                            <a:srgbClr val="1F2937"/>
-                          </a:solidFill>
-                          <a:latin typeface="Calibri"/>
-                        </a:rPr>
-                        <a:t>0.005</a:t>
-                      </a:r>
-                    </a:p>
-                  </a:txBody>
-                  <a:tcPr marL="54864" marR="54864" marT="18288" marB="18288" anchor="ctr">
-                    <a:solidFill>
-                      <a:srgbClr val="F1F5F9"/>
-                    </a:solidFill>
-                  </a:tcPr>
-                </a:tc>
-              </a:tr>
-              <a:tr h="365760">
-                <a:tc>
-                  <a:txBody>
-                    <a:bodyPr wrap="square"/>
-                    <a:lstStyle/>
-                    <a:p>
-                      <a:r>
-                        <a:rPr sz="1300" b="0" i="0">
-                          <a:solidFill>
-                            <a:srgbClr val="1F2937"/>
-                          </a:solidFill>
-                          <a:latin typeface="Calibri"/>
-                        </a:rPr>
-                        <a:t>Discount γ</a:t>
-                      </a:r>
-                    </a:p>
-                  </a:txBody>
-                  <a:tcPr marL="54864" marR="54864" marT="18288" marB="18288" anchor="ctr">
-                    <a:solidFill>
-                      <a:srgbClr val="FFFFFF"/>
-                    </a:solidFill>
-                  </a:tcPr>
-                </a:tc>
-                <a:tc>
-                  <a:txBody>
-                    <a:bodyPr wrap="square"/>
-                    <a:lstStyle/>
-                    <a:p>
-                      <a:pPr algn="ctr"/>
-                      <a:r>
-                        <a:rPr sz="1300" b="0" i="0">
-                          <a:solidFill>
-                            <a:srgbClr val="1F2937"/>
-                          </a:solidFill>
-                          <a:latin typeface="Calibri"/>
-                        </a:rPr>
-                        <a:t>0.995</a:t>
-                      </a:r>
-                    </a:p>
-                  </a:txBody>
-                  <a:tcPr marL="54864" marR="54864" marT="18288" marB="18288" anchor="ctr">
-                    <a:solidFill>
-                      <a:srgbClr val="FFFFFF"/>
-                    </a:solidFill>
-                  </a:tcPr>
-                </a:tc>
-              </a:tr>
-              <a:tr h="365760">
-                <a:tc>
-                  <a:txBody>
-                    <a:bodyPr wrap="square"/>
-                    <a:lstStyle/>
-                    <a:p>
-                      <a:r>
-                        <a:rPr sz="1300" b="0" i="0">
-                          <a:solidFill>
-                            <a:srgbClr val="1F2937"/>
-                          </a:solidFill>
-                          <a:latin typeface="Calibri"/>
-                        </a:rPr>
-                        <a:t>Rollout length</a:t>
-                      </a:r>
-                    </a:p>
-                  </a:txBody>
-                  <a:tcPr marL="54864" marR="54864" marT="18288" marB="18288" anchor="ctr">
-                    <a:solidFill>
-                      <a:srgbClr val="F1F5F9"/>
-                    </a:solidFill>
-                  </a:tcPr>
-                </a:tc>
-                <a:tc>
-                  <a:txBody>
-                    <a:bodyPr wrap="square"/>
-                    <a:lstStyle/>
-                    <a:p>
-                      <a:pPr algn="ctr"/>
-                      <a:r>
-                        <a:rPr sz="1300" b="0" i="0">
-                          <a:solidFill>
-                            <a:srgbClr val="1F2937"/>
-                          </a:solidFill>
-                          <a:latin typeface="Calibri"/>
-                        </a:rPr>
-                        <a:t>1024</a:t>
-                      </a:r>
-                    </a:p>
-                  </a:txBody>
-                  <a:tcPr marL="54864" marR="54864" marT="18288" marB="18288" anchor="ctr">
-                    <a:solidFill>
-                      <a:srgbClr val="F1F5F9"/>
-                    </a:solidFill>
-                  </a:tcPr>
-                </a:tc>
-              </a:tr>
-              <a:tr h="365760">
-                <a:tc>
-                  <a:txBody>
-                    <a:bodyPr wrap="square"/>
-                    <a:lstStyle/>
-                    <a:p>
-                      <a:r>
-                        <a:rPr sz="1300" b="0" i="0">
-                          <a:solidFill>
-                            <a:srgbClr val="1F2937"/>
-                          </a:solidFill>
-                          <a:latin typeface="Calibri"/>
-                        </a:rPr>
-                        <a:t>Network</a:t>
-                      </a:r>
-                    </a:p>
-                  </a:txBody>
-                  <a:tcPr marL="54864" marR="54864" marT="18288" marB="18288" anchor="ctr">
-                    <a:solidFill>
-                      <a:srgbClr val="FFFFFF"/>
-                    </a:solidFill>
-                  </a:tcPr>
-                </a:tc>
-                <a:tc>
-                  <a:txBody>
-                    <a:bodyPr wrap="square"/>
-                    <a:lstStyle/>
-                    <a:p>
-                      <a:pPr algn="ctr"/>
-                      <a:r>
-                        <a:rPr sz="1300" b="0" i="0">
-                          <a:solidFill>
-                            <a:srgbClr val="1F2937"/>
-                          </a:solidFill>
-                          <a:latin typeface="Calibri"/>
-                        </a:rPr>
-                        <a:t>2 × 256, CPU</a:t>
-                      </a:r>
-                    </a:p>
-                  </a:txBody>
-                  <a:tcPr marL="54864" marR="54864" marT="18288" marB="18288" anchor="ctr">
-                    <a:solidFill>
-                      <a:srgbClr val="FFFFFF"/>
-                    </a:solidFill>
-                  </a:tcPr>
-                </a:tc>
-              </a:tr>
-            </a:tbl>
-          </a:graphicData>
-        </a:graphic>
-      </p:graphicFrame>
-      <p:sp>
-        <p:nvSpPr>
-          <p:cNvPr id="27" name="TextBox 26"/>
-          <p:cNvSpPr txBox="1"/>
-          <p:nvPr/>
-        </p:nvSpPr>
-        <p:spPr>
-          <a:xfrm>
-            <a:off x="5806440" y="3931920"/>
-            <a:ext cx="5943600" cy="2377440"/>
-          </a:xfrm>
-          <a:prstGeom prst="rect">
-            <a:avLst/>
-          </a:prstGeom>
-          <a:noFill/>
-        </p:spPr>
-        <p:txBody>
-          <a:bodyPr wrap="square" anchor="t" lIns="45720" rIns="45720" tIns="27432" bIns="27432">
-            <a:spAutoFit/>
-          </a:bodyPr>
-          <a:lstStyle/>
-          <a:p>
-            <a:pPr algn="l">
-              <a:spcAft>
-                <a:spcPts val="400"/>
-              </a:spcAft>
-            </a:pPr>
-            <a:r>
-              <a:rPr sz="1700" b="1" i="0">
-                <a:solidFill>
-                  <a:srgbClr val="1B5E3A"/>
-                </a:solidFill>
-                <a:latin typeface="Calibri"/>
-              </a:rPr>
-              <a:t>Hyperparameter search</a:t>
-            </a:r>
-          </a:p>
-          <a:p>
-            <a:pPr algn="l">
-              <a:spcAft>
-                <a:spcPts val="400"/>
-              </a:spcAft>
-            </a:pPr>
-            <a:r>
-              <a:rPr sz="1400" b="0" i="0">
-                <a:solidFill>
-                  <a:srgbClr val="1F2937"/>
-                </a:solidFill>
-                <a:latin typeface="Calibri"/>
-              </a:rPr>
-              <a:t>•  8 configurations, 250,000-step trial each</a:t>
-            </a:r>
-          </a:p>
-          <a:p>
-            <a:pPr algn="l">
-              <a:spcAft>
-                <a:spcPts val="400"/>
-              </a:spcAft>
-            </a:pPr>
-            <a:r>
-              <a:rPr sz="1400" b="0" i="0">
-                <a:solidFill>
-                  <a:srgbClr val="1F2937"/>
-                </a:solidFill>
-                <a:latin typeface="Calibri"/>
-              </a:rPr>
-              <a:t>•  Best 2 trained to 2M steps on Kaggle (about 4.8 hours)</a:t>
-            </a:r>
-          </a:p>
-          <a:p>
-            <a:pPr algn="l">
-              <a:spcAft>
-                <a:spcPts val="400"/>
-              </a:spcAft>
-            </a:pPr>
-            <a:r>
-              <a:rPr sz="1400" b="0" i="0">
-                <a:solidFill>
-                  <a:srgbClr val="1F2937"/>
-                </a:solidFill>
-                <a:latin typeface="Calibri"/>
-              </a:rPr>
-              <a:t>•  Winner: lowest learning rate, larger network. Earlier runs were unstable because they learned too fast, not because the network was too small.</a:t>
-            </a:r>
-          </a:p>
-        </p:txBody>
-      </p:sp>
-    </p:spTree>
-  </p:cSld>
-  <p:clrMapOvr>
-    <a:masterClrMapping/>
-  </p:clrMapOvr>
-</p:sld>
-</file>
-
-<file path=ppt/slides/slide28.xml><?xml version="1.0" encoding="utf-8"?>
-<p:sld xmlns:a="http://schemas.openxmlformats.org/drawingml/2006/main" xmlns:p="http://schemas.openxmlformats.org/presentationml/2006/main" xmlns:r="http://schemas.openxmlformats.org/officeDocument/2006/relationships">
-  <p:cSld>
-    <p:spTree>
-      <p:nvGrpSpPr>
-        <p:cNvPr id="1" name=""/>
-        <p:cNvGrpSpPr/>
-        <p:nvPr/>
-      </p:nvGrpSpPr>
-      <p:grpSpPr/>
-      <p:sp>
-        <p:nvSpPr>
-          <p:cNvPr id="17" name="Rectangle 16">
-            <a:extLst>
-              <a:ext uri="{FF2B5EF4-FFF2-40B4-BE49-F238E27FC236}">
-                <a16:creationId xmlns:a16="http://schemas.microsoft.com/office/drawing/2014/main" id="{684365C9-E666-36EE-4DB1-04791BFC26FB}"/>
-              </a:ext>
-            </a:extLst>
-          </p:cNvPr>
-          <p:cNvSpPr/>
-          <p:nvPr/>
-        </p:nvSpPr>
-        <p:spPr>
-          <a:xfrm>
-            <a:off x="-1" y="0"/>
-            <a:ext cx="12191998" cy="1262131"/>
-          </a:xfrm>
-          <a:prstGeom prst="rect">
-            <a:avLst/>
-          </a:prstGeom>
-          <a:gradFill flip="none" rotWithShape="1">
-            <a:gsLst>
-              <a:gs pos="0">
-                <a:srgbClr val="1A9B46">
-                  <a:tint val="66000"/>
-                  <a:satMod val="160000"/>
-                </a:srgbClr>
-              </a:gs>
-              <a:gs pos="50000">
-                <a:srgbClr val="1A9B46">
-                  <a:tint val="44500"/>
-                  <a:satMod val="160000"/>
-                </a:srgbClr>
-              </a:gs>
-              <a:gs pos="100000">
-                <a:srgbClr val="1A9B46">
-                  <a:tint val="23500"/>
-                  <a:satMod val="160000"/>
-                </a:srgbClr>
-              </a:gs>
-            </a:gsLst>
-            <a:path path="circle">
-              <a:fillToRect l="50000" t="50000" r="50000" b="50000"/>
-            </a:path>
-            <a:tileRect/>
-          </a:gradFill>
-          <a:ln>
-            <a:noFill/>
-          </a:ln>
-        </p:spPr>
-        <p:style>
-          <a:lnRef idx="2">
-            <a:schemeClr val="accent1">
-              <a:shade val="50000"/>
-            </a:schemeClr>
-          </a:lnRef>
-          <a:fillRef idx="1">
-            <a:schemeClr val="accent1"/>
-          </a:fillRef>
-          <a:effectRef idx="0">
-            <a:schemeClr val="accent1"/>
-          </a:effectRef>
-          <a:fontRef idx="minor">
-            <a:schemeClr val="lt1"/>
-          </a:fontRef>
-        </p:style>
-        <p:txBody>
-          <a:bodyPr rtlCol="0" anchor="ctr"/>
-          <a:lstStyle/>
-          <a:p>
-            <a:pPr algn="ctr"/>
-            <a:endParaRPr lang="en-IN" sz="4400" dirty="0">
-              <a:solidFill>
-                <a:schemeClr val="accent1">
-                  <a:lumMod val="50000"/>
-                </a:schemeClr>
-              </a:solidFill>
-            </a:endParaRPr>
-          </a:p>
-        </p:txBody>
-      </p:sp>
-      <p:sp>
-        <p:nvSpPr>
-          <p:cNvPr id="10" name="Google Shape;91;p1">
-            <a:extLst>
-              <a:ext uri="{FF2B5EF4-FFF2-40B4-BE49-F238E27FC236}">
-                <a16:creationId xmlns:a16="http://schemas.microsoft.com/office/drawing/2014/main" id="{4D89FC00-7640-2DC1-0BAF-6A1DC613CF6B}"/>
-              </a:ext>
-            </a:extLst>
-          </p:cNvPr>
-          <p:cNvSpPr txBox="1"/>
-          <p:nvPr/>
-        </p:nvSpPr>
-        <p:spPr>
-          <a:xfrm>
-            <a:off x="-1" y="6416040"/>
-            <a:ext cx="12191998" cy="441960"/>
-          </a:xfrm>
-          <a:prstGeom prst="rect">
-            <a:avLst/>
-          </a:prstGeom>
-          <a:gradFill flip="none" rotWithShape="1">
-            <a:gsLst>
-              <a:gs pos="0">
-                <a:srgbClr val="1A9B46">
-                  <a:tint val="66000"/>
-                  <a:satMod val="160000"/>
-                </a:srgbClr>
-              </a:gs>
-              <a:gs pos="50000">
-                <a:srgbClr val="1A9B46">
-                  <a:tint val="44500"/>
-                  <a:satMod val="160000"/>
-                </a:srgbClr>
-              </a:gs>
-              <a:gs pos="100000">
-                <a:srgbClr val="1A9B46">
-                  <a:tint val="23500"/>
-                  <a:satMod val="160000"/>
-                </a:srgbClr>
-              </a:gs>
-            </a:gsLst>
-            <a:path path="circle">
-              <a:fillToRect l="50000" t="50000" r="50000" b="50000"/>
-            </a:path>
-            <a:tileRect/>
-          </a:gradFill>
-          <a:ln>
-            <a:noFill/>
-          </a:ln>
-        </p:spPr>
-        <p:txBody>
-          <a:bodyPr spcFirstLastPara="1" wrap="square" lIns="91425" tIns="45700" rIns="91425" bIns="45700" anchor="t" anchorCtr="0">
-            <a:noAutofit/>
-          </a:bodyPr>
-          <a:lstStyle/>
-          <a:p>
-            <a:pPr marL="0" marR="0" lvl="0" indent="0" algn="ctr" rtl="0">
-              <a:lnSpc>
-                <a:spcPct val="90000"/>
-              </a:lnSpc>
-              <a:spcBef>
-                <a:spcPts val="0"/>
-              </a:spcBef>
-              <a:spcAft>
-                <a:spcPts val="0"/>
-              </a:spcAft>
-              <a:buNone/>
-            </a:pPr>
-            <a:r>
-              <a:rPr lang="en-IN" sz="1600" b="1" i="0" u="none" strike="noStrike" cap="none" dirty="0">
-                <a:solidFill>
-                  <a:srgbClr val="081271"/>
-                </a:solidFill>
-                <a:latin typeface="Times New Roman"/>
-                <a:ea typeface="Times New Roman"/>
-                <a:cs typeface="Times New Roman"/>
-                <a:sym typeface="Times New Roman"/>
-              </a:rPr>
-              <a:t>[Final Project Review]</a:t>
-            </a:r>
-            <a:r>
-              <a:rPr lang="en-IN" sz="1600" b="1" dirty="0">
-                <a:solidFill>
-                  <a:srgbClr val="081271"/>
-                </a:solidFill>
-                <a:latin typeface="Times New Roman"/>
-                <a:ea typeface="Times New Roman"/>
-                <a:cs typeface="Times New Roman"/>
-                <a:sym typeface="Times New Roman"/>
-              </a:rPr>
-              <a:t/>
-            </a:r>
-            <a:r>
-              <a:rPr lang="en-IN" sz="1600" b="1" i="0" u="none" strike="noStrike" cap="none" dirty="0">
-                <a:solidFill>
-                  <a:srgbClr val="081271"/>
-                </a:solidFill>
-                <a:latin typeface="Times New Roman"/>
-                <a:ea typeface="Times New Roman"/>
-                <a:cs typeface="Times New Roman"/>
-                <a:sym typeface="Times New Roman"/>
-              </a:rPr>
-              <a:t/>
-            </a:r>
-            <a:endParaRPr sz="1600" b="1" i="0" u="none" strike="noStrike" cap="none" dirty="0">
-              <a:solidFill>
-                <a:srgbClr val="081271"/>
-              </a:solidFill>
-              <a:latin typeface="Times New Roman"/>
-              <a:ea typeface="Times New Roman"/>
-              <a:cs typeface="Times New Roman"/>
-              <a:sym typeface="Times New Roman"/>
-            </a:endParaRPr>
-          </a:p>
-        </p:txBody>
-      </p:sp>
-      <p:cxnSp>
-        <p:nvCxnSpPr>
-          <p:cNvPr id="16" name="Straight Connector 15">
-            <a:extLst>
-              <a:ext uri="{FF2B5EF4-FFF2-40B4-BE49-F238E27FC236}">
-                <a16:creationId xmlns:a16="http://schemas.microsoft.com/office/drawing/2014/main" id="{170CA935-25F2-6478-C664-35BFDF7E813C}"/>
-              </a:ext>
-            </a:extLst>
-          </p:cNvPr>
-          <p:cNvCxnSpPr/>
-          <p:nvPr/>
-        </p:nvCxnSpPr>
-        <p:spPr>
-          <a:xfrm>
-            <a:off x="0" y="1260899"/>
-            <a:ext cx="12192000" cy="0"/>
-          </a:xfrm>
-          <a:prstGeom prst="line">
-            <a:avLst/>
-          </a:prstGeom>
-          <a:ln w="28575">
-            <a:solidFill>
-              <a:srgbClr val="1A9B46"/>
-            </a:solidFill>
-          </a:ln>
-        </p:spPr>
-        <p:style>
-          <a:lnRef idx="1">
-            <a:schemeClr val="accent1"/>
-          </a:lnRef>
-          <a:fillRef idx="0">
-            <a:schemeClr val="accent1"/>
-          </a:fillRef>
-          <a:effectRef idx="0">
-            <a:schemeClr val="accent1"/>
-          </a:effectRef>
-          <a:fontRef idx="minor">
-            <a:schemeClr val="tx1"/>
-          </a:fontRef>
-        </p:style>
-      </p:cxnSp>
-      <p:sp>
-        <p:nvSpPr>
-          <p:cNvPr id="2" name="Title 1"/>
-          <p:cNvSpPr>
-            <a:spLocks noGrp="1"/>
-          </p:cNvSpPr>
-          <p:nvPr>
-            <p:ph type="title"/>
-          </p:nvPr>
-        </p:nvSpPr>
-        <p:spPr/>
-        <p:txBody>
-          <a:bodyPr/>
-          <a:lstStyle/>
-          <a:p>
-            <a:r>
-              <a:rPr sz="3200"/>
               <a:t>Classical Baselines and a Fair Evaluation</a:t>
             </a:r>
           </a:p>
@@ -17578,7 +15510,7 @@
 </p:sld>
 </file>
 
-<file path=ppt/slides/slide29.xml><?xml version="1.0" encoding="utf-8"?>
+<file path=ppt/slides/slide27.xml><?xml version="1.0" encoding="utf-8"?>
 <p:sld xmlns:a="http://schemas.openxmlformats.org/drawingml/2006/main" xmlns:p="http://schemas.openxmlformats.org/presentationml/2006/main" xmlns:r="http://schemas.openxmlformats.org/officeDocument/2006/relationships">
   <p:cSld>
     <p:spTree>
@@ -17957,7 +15889,7 @@
 </p:sld>
 </file>
 
-<file path=ppt/slides/slide30.xml><?xml version="1.0" encoding="utf-8"?>
+<file path=ppt/slides/slide28.xml><?xml version="1.0" encoding="utf-8"?>
 <p:sld xmlns:a="http://schemas.openxmlformats.org/drawingml/2006/main" xmlns:p="http://schemas.openxmlformats.org/presentationml/2006/main" xmlns:r="http://schemas.openxmlformats.org/officeDocument/2006/relationships">
   <p:cSld>
     <p:spTree>
@@ -18971,7 +16903,7 @@
 </p:sld>
 </file>
 
-<file path=ppt/slides/slide31.xml><?xml version="1.0" encoding="utf-8"?>
+<file path=ppt/slides/slide29.xml><?xml version="1.0" encoding="utf-8"?>
 <p:sld xmlns:a="http://schemas.openxmlformats.org/drawingml/2006/main" xmlns:p="http://schemas.openxmlformats.org/presentationml/2006/main" xmlns:r="http://schemas.openxmlformats.org/officeDocument/2006/relationships">
   <p:cSld>
     <p:spTree>
@@ -19236,7 +17168,7 @@
           <a:p>
             <a:r>
               <a:rPr sz="3200"/>
-              <a:t>Dashboard (1/7): Episode View, Engine</a:t>
+              <a:t>Dashboard (1/5): Episode View, Engine</a:t>
             </a:r>
           </a:p>
         </p:txBody>
@@ -19778,7 +17710,7 @@
 </p:sld>
 </file>
 
-<file path=ppt/slides/slide32.xml><?xml version="1.0" encoding="utf-8"?>
+<file path=ppt/slides/slide30.xml><?xml version="1.0" encoding="utf-8"?>
 <p:sld xmlns:a="http://schemas.openxmlformats.org/drawingml/2006/main" xmlns:p="http://schemas.openxmlformats.org/presentationml/2006/main" xmlns:r="http://schemas.openxmlformats.org/officeDocument/2006/relationships">
   <p:cSld>
     <p:spTree>
@@ -20043,7 +17975,7 @@
           <a:p>
             <a:r>
               <a:rPr sz="3200"/>
-              <a:t>Dashboard (2/7): The Challenger, and a Crisis</a:t>
+              <a:t>Dashboard (2/5): The Challenger, and a Crisis</a:t>
             </a:r>
           </a:p>
         </p:txBody>
@@ -20287,7 +18219,7 @@
 </p:sld>
 </file>
 
-<file path=ppt/slides/slide33.xml><?xml version="1.0" encoding="utf-8"?>
+<file path=ppt/slides/slide31.xml><?xml version="1.0" encoding="utf-8"?>
 <p:sld xmlns:a="http://schemas.openxmlformats.org/drawingml/2006/main" xmlns:p="http://schemas.openxmlformats.org/presentationml/2006/main" xmlns:r="http://schemas.openxmlformats.org/officeDocument/2006/relationships">
   <p:cSld>
     <p:spTree>
@@ -20552,7 +18484,7 @@
           <a:p>
             <a:r>
               <a:rPr sz="3200"/>
-              <a:t>Dashboard (3/7): Before vs After the System</a:t>
+              <a:t>Dashboard (3/5): Before vs After the System</a:t>
             </a:r>
           </a:p>
         </p:txBody>
@@ -21004,7 +18936,7 @@
 </p:sld>
 </file>
 
-<file path=ppt/slides/slide34.xml><?xml version="1.0" encoding="utf-8"?>
+<file path=ppt/slides/slide32.xml><?xml version="1.0" encoding="utf-8"?>
 <p:sld xmlns:a="http://schemas.openxmlformats.org/drawingml/2006/main" xmlns:p="http://schemas.openxmlformats.org/presentationml/2006/main" xmlns:r="http://schemas.openxmlformats.org/officeDocument/2006/relationships">
   <p:cSld>
     <p:spTree>
@@ -21269,7 +19201,7 @@
           <a:p>
             <a:r>
               <a:rPr sz="3200"/>
-              <a:t>Dashboard (4/7): Every Test Run, Not Just the Average</a:t>
+              <a:t>Dashboard (4/5): Explain a Decision</a:t>
             </a:r>
           </a:p>
         </p:txBody>
@@ -21305,7 +19237,7 @@
       </p:sp>
       <p:pic>
         <p:nvPicPr>
-          <p:cNvPr id="20" name="Picture 19" descr="_crop_before_after_90093155.png"/>
+          <p:cNvPr id="20" name="Picture 19" descr="_crop_explain_13376534.png"/>
           <p:cNvPicPr>
             <a:picLocks noChangeAspect="1"/>
           </p:cNvPicPr>
@@ -21319,8 +19251,8 @@
         </p:blipFill>
         <p:spPr>
           <a:xfrm>
-            <a:off x="1115567" y="1325880"/>
-            <a:ext cx="9957816" cy="3319272"/>
+            <a:off x="675885" y="1371600"/>
+            <a:ext cx="6877828" cy="2816352"/>
           </a:xfrm>
           <a:prstGeom prst="rect">
             <a:avLst/>
@@ -21340,8 +19272,8 @@
         </p:nvSpPr>
         <p:spPr>
           <a:xfrm>
-            <a:off x="411480" y="4672584"/>
-            <a:ext cx="11365992" cy="292608"/>
+            <a:off x="411480" y="4215384"/>
+            <a:ext cx="7406640" cy="292608"/>
           </a:xfrm>
           <a:prstGeom prst="rect">
             <a:avLst/>
@@ -21366,7 +19298,7 @@
                 </a:solidFill>
                 <a:latin typeface="Calibri"/>
               </a:rPr>
-              <a:t>Each dot is one of the 30 held-out test seeds, sorted by the “before” profit</a:t>
+              <a:t>Day 45, product 0: explanation written by the LLM, source shown as a badge</a:t>
             </a:r>
           </a:p>
         </p:txBody>
@@ -21379,8 +19311,8 @@
         </p:nvSpPr>
         <p:spPr>
           <a:xfrm>
-            <a:off x="411480" y="5074920"/>
-            <a:ext cx="11365992" cy="1280160"/>
+            <a:off x="8092440" y="1371600"/>
+            <a:ext cx="3685032" cy="4937760"/>
           </a:xfrm>
           <a:prstGeom prst="rect">
             <a:avLst/>
@@ -21395,26 +19327,17 @@
           <a:p>
             <a:pPr algn="l">
               <a:spcAft>
-                <a:spcPts val="600"/>
+                <a:spcPts val="400"/>
               </a:spcAft>
             </a:pPr>
             <a:r>
-              <a:rPr sz="1600" b="1" i="0">
+              <a:rPr sz="1700" b="1" i="0">
                 <a:solidFill>
                   <a:srgbClr val="1B5E3A"/>
                 </a:solidFill>
                 <a:latin typeface="Calibri"/>
               </a:rPr>
-              <a:t>•  Why show every run? </a:t>
-            </a:r>
-            <a:r>
-              <a:rPr sz="1600" b="0" i="0">
-                <a:solidFill>
-                  <a:srgbClr val="1F2937"/>
-                </a:solidFill>
-                <a:latin typeface="Calibri"/>
-              </a:rPr>
-              <a:t>An average can hide losses. The engine (green) is above the fixed order (grey) on 30 of 30 seeds; the RL challenger (pink) is above it on 29 of 30.</a:t>
+              <a:t>How to use it</a:t>
             </a:r>
           </a:p>
           <a:p>
@@ -21424,22 +19347,125 @@
               </a:spcAft>
             </a:pPr>
             <a:r>
-              <a:rPr sz="1600" b="1" i="0">
+              <a:rPr sz="1400" b="0" i="0">
+                <a:solidFill>
+                  <a:srgbClr val="1F2937"/>
+                </a:solidFill>
+                <a:latin typeface="Calibri"/>
+              </a:rPr>
+              <a:t>•  Pick a day and a product</a:t>
+            </a:r>
+          </a:p>
+          <a:p>
+            <a:pPr algn="l">
+              <a:spcAft>
+                <a:spcPts val="400"/>
+              </a:spcAft>
+            </a:pPr>
+            <a:r>
+              <a:rPr sz="1400" b="0" i="0">
+                <a:solidFill>
+                  <a:srgbClr val="1F2937"/>
+                </a:solidFill>
+                <a:latin typeface="Calibri"/>
+              </a:rPr>
+              <a:t>•  Press Explain this decision</a:t>
+            </a:r>
+          </a:p>
+          <a:p>
+            <a:pPr algn="l">
+              <a:spcAft>
+                <a:spcPts val="400"/>
+              </a:spcAft>
+            </a:pPr>
+            <a:r>
+              <a:rPr sz="1400" b="0" i="0">
+                <a:solidFill>
+                  <a:srgbClr val="1F2937"/>
+                </a:solidFill>
+                <a:latin typeface="Calibri"/>
+              </a:rPr>
+              <a:t>•  Read 2–3 plain sentences</a:t>
+            </a:r>
+          </a:p>
+          <a:p>
+            <a:pPr algn="l">
+              <a:spcAft>
+                <a:spcPts val="400"/>
+              </a:spcAft>
+            </a:pPr>
+            <a:r>
+              <a:rPr sz="1400" b="0" i="0">
+                <a:solidFill>
+                  <a:srgbClr val="1F2937"/>
+                </a:solidFill>
+                <a:latin typeface="Calibri"/>
+              </a:rPr>
+              <a:t>•  The black badge shows who wrote it: a model name, or “deterministic template” if the check rejected the LLM</a:t>
+            </a:r>
+          </a:p>
+          <a:p>
+            <a:pPr algn="l">
+              <a:spcAft>
+                <a:spcPts val="400"/>
+              </a:spcAft>
+            </a:pPr>
+            <a:r>
+              <a:rPr sz="1400" b="0" i="0">
+                <a:solidFill>
+                  <a:srgbClr val="1F2937"/>
+                </a:solidFill>
+                <a:latin typeface="Calibri"/>
+              </a:rPr>
+              <a:t>•  Expand “the facts the model was given” to verify every number</a:t>
+            </a:r>
+          </a:p>
+        </p:txBody>
+      </p:sp>
+      <p:sp>
+        <p:nvSpPr>
+          <p:cNvPr id="23" name="TextBox 22"/>
+          <p:cNvSpPr txBox="1"/>
+          <p:nvPr/>
+        </p:nvSpPr>
+        <p:spPr>
+          <a:xfrm>
+            <a:off x="411480" y="4709160"/>
+            <a:ext cx="7406640" cy="1554480"/>
+          </a:xfrm>
+          <a:prstGeom prst="rect">
+            <a:avLst/>
+          </a:prstGeom>
+          <a:noFill/>
+        </p:spPr>
+        <p:txBody>
+          <a:bodyPr wrap="square" anchor="t" lIns="45720" rIns="45720" tIns="27432" bIns="27432">
+            <a:spAutoFit/>
+          </a:bodyPr>
+          <a:lstStyle/>
+          <a:p>
+            <a:pPr algn="l">
+              <a:spcAft>
+                <a:spcPts val="400"/>
+              </a:spcAft>
+            </a:pPr>
+            <a:r>
+              <a:rPr sz="1400" b="1" i="0">
                 <a:solidFill>
                   <a:srgbClr val="D6336C"/>
                 </a:solidFill>
                 <a:latin typeface="Calibri"/>
               </a:rPr>
-              <a:t>•  One weak run is visible too: </a:t>
-            </a:r>
-            <a:r>
-              <a:rPr sz="1600" b="0" i="0">
+              <a:t>Check it yourself: </a:t>
+            </a:r>
+            <a:r>
+              <a:rPr sz="1400" b="0" i="0">
                 <a:solidFill>
                   <a:srgbClr val="1F2937"/>
                 </a:solidFill>
                 <a:latin typeface="Calibri"/>
               </a:rPr>
-              <a:t>the lone pink dot far below the others is a seed where the challenger did badly.</a:t>
+              <a:t>2,365 units, 14.0 days of cover, demand of 169 units and a 7-day average of 78 all appear in the facts panel. If the model had invented a figure, the template would have replaced this text.</a:t>
             </a:r>
           </a:p>
         </p:txBody>
@@ -21452,7 +19478,7 @@
 </p:sld>
 </file>
 
-<file path=ppt/slides/slide35.xml><?xml version="1.0" encoding="utf-8"?>
+<file path=ppt/slides/slide33.xml><?xml version="1.0" encoding="utf-8"?>
 <p:sld xmlns:a="http://schemas.openxmlformats.org/drawingml/2006/main" xmlns:p="http://schemas.openxmlformats.org/presentationml/2006/main" xmlns:r="http://schemas.openxmlformats.org/officeDocument/2006/relationships">
   <p:cSld>
     <p:spTree>
@@ -21717,1050 +19743,7 @@
           <a:p>
             <a:r>
               <a:rPr sz="3200"/>
-              <a:t>Dashboard (5/7): One Run, Day by Day</a:t>
-            </a:r>
-          </a:p>
-        </p:txBody>
-      </p:sp>
-      <p:sp>
-        <p:nvSpPr>
-          <p:cNvPr id="19" name="Slide Number Placeholder 18">
-            <a:extLst>
-              <a:ext uri="{FF2B5EF4-FFF2-40B4-BE49-F238E27FC236}">
-                <a16:creationId xmlns:a16="http://schemas.microsoft.com/office/drawing/2014/main" id="{9B6D94B3-8D6F-6862-5C85-C28EA1FEBFFD}"/>
-              </a:ext>
-            </a:extLst>
-          </p:cNvPr>
-          <p:cNvSpPr>
-            <a:spLocks noGrp="1"/>
-          </p:cNvSpPr>
-          <p:nvPr>
-            <p:ph type="sldNum" sz="quarter" idx="12"/>
-          </p:nvPr>
-        </p:nvSpPr>
-        <p:spPr/>
-        <p:txBody>
-          <a:bodyPr/>
-          <a:lstStyle/>
-          <a:p>
-            <a:fld id="{C2216105-7B7A-4C42-B2A1-5E9A2FA4F8FD}" type="slidenum">
-              <a:rPr lang="en-IN" smtClean="0"/>
-              <a:t>3</a:t>
-            </a:fld>
-            <a:endParaRPr lang="en-IN" dirty="0"/>
-          </a:p>
-        </p:txBody>
-      </p:sp>
-      <p:pic>
-        <p:nvPicPr>
-          <p:cNvPr id="20" name="Picture 19" descr="_crop_before_after_57854471.png"/>
-          <p:cNvPicPr>
-            <a:picLocks noChangeAspect="1"/>
-          </p:cNvPicPr>
-          <p:nvPr/>
-        </p:nvPicPr>
-        <p:blipFill>
-          <a:blip r:embed="rId2"/>
-          <a:stretch>
-            <a:fillRect/>
-          </a:stretch>
-        </p:blipFill>
-        <p:spPr>
-          <a:xfrm>
-            <a:off x="672832" y="1325880"/>
-            <a:ext cx="7158255" cy="3364992"/>
-          </a:xfrm>
-          <a:prstGeom prst="rect">
-            <a:avLst/>
-          </a:prstGeom>
-          <a:ln w="12700">
-            <a:solidFill>
-              <a:srgbClr val="CBD5E1"/>
-            </a:solidFill>
-          </a:ln>
-        </p:spPr>
-      </p:pic>
-      <p:sp>
-        <p:nvSpPr>
-          <p:cNvPr id="21" name="TextBox 20"/>
-          <p:cNvSpPr txBox="1"/>
-          <p:nvPr/>
-        </p:nvSpPr>
-        <p:spPr>
-          <a:xfrm>
-            <a:off x="411480" y="4718304"/>
-            <a:ext cx="7680960" cy="292608"/>
-          </a:xfrm>
-          <a:prstGeom prst="rect">
-            <a:avLst/>
-          </a:prstGeom>
-          <a:noFill/>
-        </p:spPr>
-        <p:txBody>
-          <a:bodyPr wrap="square" anchor="t" lIns="45720" rIns="45720" tIns="27432" bIns="27432">
-            <a:spAutoFit/>
-          </a:bodyPr>
-          <a:lstStyle/>
-          <a:p>
-            <a:pPr algn="ctr">
-              <a:spcAft>
-                <a:spcPts val="400"/>
-              </a:spcAft>
-            </a:pPr>
-            <a:r>
-              <a:rPr sz="1200" b="0" i="0">
-                <a:solidFill>
-                  <a:srgbClr val="5B6573"/>
-                </a:solidFill>
-                <a:latin typeface="Calibri"/>
-              </a:rPr>
-              <a:t>Seed 500: cumulative profit and stockouts, before vs after</a:t>
-            </a:r>
-          </a:p>
-        </p:txBody>
-      </p:sp>
-      <p:sp>
-        <p:nvSpPr>
-          <p:cNvPr id="22" name="TextBox 21"/>
-          <p:cNvSpPr txBox="1"/>
-          <p:nvPr/>
-        </p:nvSpPr>
-        <p:spPr>
-          <a:xfrm>
-            <a:off x="8366759" y="1371600"/>
-            <a:ext cx="3410712" cy="4846320"/>
-          </a:xfrm>
-          <a:prstGeom prst="rect">
-            <a:avLst/>
-          </a:prstGeom>
-          <a:noFill/>
-        </p:spPr>
-        <p:txBody>
-          <a:bodyPr wrap="square" anchor="t" lIns="45720" rIns="45720" tIns="27432" bIns="27432">
-            <a:spAutoFit/>
-          </a:bodyPr>
-          <a:lstStyle/>
-          <a:p>
-            <a:pPr algn="l">
-              <a:spcAft>
-                <a:spcPts val="600"/>
-              </a:spcAft>
-            </a:pPr>
-            <a:r>
-              <a:rPr sz="1800" b="1" i="0">
-                <a:solidFill>
-                  <a:srgbClr val="1B5E3A"/>
-                </a:solidFill>
-                <a:latin typeface="Calibri"/>
-              </a:rPr>
-              <a:t>Reading the charts</a:t>
-            </a:r>
-          </a:p>
-          <a:p>
-            <a:pPr algn="l">
-              <a:spcAft>
-                <a:spcPts val="600"/>
-              </a:spcAft>
-            </a:pPr>
-            <a:r>
-              <a:rPr sz="1500" b="0" i="0">
-                <a:solidFill>
-                  <a:srgbClr val="1F2937"/>
-                </a:solidFill>
-                <a:latin typeface="Calibri"/>
-              </a:rPr>
-              <a:t>•  Left: profit builds up over 180 days. Green (engine) pulls away from grey (fixed order).</a:t>
-            </a:r>
-          </a:p>
-          <a:p>
-            <a:pPr algn="l">
-              <a:spcAft>
-                <a:spcPts val="600"/>
-              </a:spcAft>
-            </a:pPr>
-            <a:r>
-              <a:rPr sz="1500" b="0" i="0">
-                <a:solidFill>
-                  <a:srgbClr val="1F2937"/>
-                </a:solidFill>
-                <a:latin typeface="Calibri"/>
-              </a:rPr>
-              <a:t>•  Right: product-days out of stock, counted up. The engine stays low; the fixed order and the challenger climb.</a:t>
-            </a:r>
-          </a:p>
-          <a:p>
-            <a:pPr algn="l">
-              <a:spcAft>
-                <a:spcPts val="400"/>
-              </a:spcAft>
-            </a:pPr>
-            <a:r>
-              <a:rPr sz="1500" b="0" i="0">
-                <a:solidFill>
-                  <a:srgbClr val="1F2937"/>
-                </a:solidFill>
-                <a:latin typeface="Calibri"/>
-              </a:rPr>
-              <a:t>•  The charts follow the sidebar’s seed and crisis switch, so before and after can be compared live under any condition.</a:t>
-            </a:r>
-          </a:p>
-        </p:txBody>
-      </p:sp>
-      <p:sp>
-        <p:nvSpPr>
-          <p:cNvPr id="23" name="TextBox 22"/>
-          <p:cNvSpPr txBox="1"/>
-          <p:nvPr/>
-        </p:nvSpPr>
-        <p:spPr>
-          <a:xfrm>
-            <a:off x="411480" y="5166360"/>
-            <a:ext cx="7680960" cy="1097280"/>
-          </a:xfrm>
-          <a:prstGeom prst="rect">
-            <a:avLst/>
-          </a:prstGeom>
-          <a:noFill/>
-        </p:spPr>
-        <p:txBody>
-          <a:bodyPr wrap="square" anchor="t" lIns="45720" rIns="45720" tIns="27432" bIns="27432">
-            <a:spAutoFit/>
-          </a:bodyPr>
-          <a:lstStyle/>
-          <a:p>
-            <a:pPr algn="l">
-              <a:spcAft>
-                <a:spcPts val="400"/>
-              </a:spcAft>
-            </a:pPr>
-            <a:r>
-              <a:rPr sz="1500" b="1" i="0">
-                <a:solidFill>
-                  <a:srgbClr val="D6336C"/>
-                </a:solidFill>
-                <a:latin typeface="Calibri"/>
-              </a:rPr>
-              <a:t>On this single run the challenger runs out of stock more than the engine: a visible example of its weakness.</a:t>
-            </a:r>
-          </a:p>
-        </p:txBody>
-      </p:sp>
-    </p:spTree>
-  </p:cSld>
-  <p:clrMapOvr>
-    <a:masterClrMapping/>
-  </p:clrMapOvr>
-</p:sld>
-</file>
-
-<file path=ppt/slides/slide36.xml><?xml version="1.0" encoding="utf-8"?>
-<p:sld xmlns:a="http://schemas.openxmlformats.org/drawingml/2006/main" xmlns:p="http://schemas.openxmlformats.org/presentationml/2006/main" xmlns:r="http://schemas.openxmlformats.org/officeDocument/2006/relationships">
-  <p:cSld>
-    <p:spTree>
-      <p:nvGrpSpPr>
-        <p:cNvPr id="1" name=""/>
-        <p:cNvGrpSpPr/>
-        <p:nvPr/>
-      </p:nvGrpSpPr>
-      <p:grpSpPr/>
-      <p:sp>
-        <p:nvSpPr>
-          <p:cNvPr id="17" name="Rectangle 16">
-            <a:extLst>
-              <a:ext uri="{FF2B5EF4-FFF2-40B4-BE49-F238E27FC236}">
-                <a16:creationId xmlns:a16="http://schemas.microsoft.com/office/drawing/2014/main" id="{684365C9-E666-36EE-4DB1-04791BFC26FB}"/>
-              </a:ext>
-            </a:extLst>
-          </p:cNvPr>
-          <p:cNvSpPr/>
-          <p:nvPr/>
-        </p:nvSpPr>
-        <p:spPr>
-          <a:xfrm>
-            <a:off x="-1" y="0"/>
-            <a:ext cx="12191998" cy="1262131"/>
-          </a:xfrm>
-          <a:prstGeom prst="rect">
-            <a:avLst/>
-          </a:prstGeom>
-          <a:gradFill flip="none" rotWithShape="1">
-            <a:gsLst>
-              <a:gs pos="0">
-                <a:srgbClr val="1A9B46">
-                  <a:tint val="66000"/>
-                  <a:satMod val="160000"/>
-                </a:srgbClr>
-              </a:gs>
-              <a:gs pos="50000">
-                <a:srgbClr val="1A9B46">
-                  <a:tint val="44500"/>
-                  <a:satMod val="160000"/>
-                </a:srgbClr>
-              </a:gs>
-              <a:gs pos="100000">
-                <a:srgbClr val="1A9B46">
-                  <a:tint val="23500"/>
-                  <a:satMod val="160000"/>
-                </a:srgbClr>
-              </a:gs>
-            </a:gsLst>
-            <a:path path="circle">
-              <a:fillToRect l="50000" t="50000" r="50000" b="50000"/>
-            </a:path>
-            <a:tileRect/>
-          </a:gradFill>
-          <a:ln>
-            <a:noFill/>
-          </a:ln>
-        </p:spPr>
-        <p:style>
-          <a:lnRef idx="2">
-            <a:schemeClr val="accent1">
-              <a:shade val="50000"/>
-            </a:schemeClr>
-          </a:lnRef>
-          <a:fillRef idx="1">
-            <a:schemeClr val="accent1"/>
-          </a:fillRef>
-          <a:effectRef idx="0">
-            <a:schemeClr val="accent1"/>
-          </a:effectRef>
-          <a:fontRef idx="minor">
-            <a:schemeClr val="lt1"/>
-          </a:fontRef>
-        </p:style>
-        <p:txBody>
-          <a:bodyPr rtlCol="0" anchor="ctr"/>
-          <a:lstStyle/>
-          <a:p>
-            <a:pPr algn="ctr"/>
-            <a:endParaRPr lang="en-IN" sz="4400" dirty="0">
-              <a:solidFill>
-                <a:schemeClr val="accent1">
-                  <a:lumMod val="50000"/>
-                </a:schemeClr>
-              </a:solidFill>
-            </a:endParaRPr>
-          </a:p>
-        </p:txBody>
-      </p:sp>
-      <p:sp>
-        <p:nvSpPr>
-          <p:cNvPr id="10" name="Google Shape;91;p1">
-            <a:extLst>
-              <a:ext uri="{FF2B5EF4-FFF2-40B4-BE49-F238E27FC236}">
-                <a16:creationId xmlns:a16="http://schemas.microsoft.com/office/drawing/2014/main" id="{4D89FC00-7640-2DC1-0BAF-6A1DC613CF6B}"/>
-              </a:ext>
-            </a:extLst>
-          </p:cNvPr>
-          <p:cNvSpPr txBox="1"/>
-          <p:nvPr/>
-        </p:nvSpPr>
-        <p:spPr>
-          <a:xfrm>
-            <a:off x="-1" y="6416040"/>
-            <a:ext cx="12191998" cy="441960"/>
-          </a:xfrm>
-          <a:prstGeom prst="rect">
-            <a:avLst/>
-          </a:prstGeom>
-          <a:gradFill flip="none" rotWithShape="1">
-            <a:gsLst>
-              <a:gs pos="0">
-                <a:srgbClr val="1A9B46">
-                  <a:tint val="66000"/>
-                  <a:satMod val="160000"/>
-                </a:srgbClr>
-              </a:gs>
-              <a:gs pos="50000">
-                <a:srgbClr val="1A9B46">
-                  <a:tint val="44500"/>
-                  <a:satMod val="160000"/>
-                </a:srgbClr>
-              </a:gs>
-              <a:gs pos="100000">
-                <a:srgbClr val="1A9B46">
-                  <a:tint val="23500"/>
-                  <a:satMod val="160000"/>
-                </a:srgbClr>
-              </a:gs>
-            </a:gsLst>
-            <a:path path="circle">
-              <a:fillToRect l="50000" t="50000" r="50000" b="50000"/>
-            </a:path>
-            <a:tileRect/>
-          </a:gradFill>
-          <a:ln>
-            <a:noFill/>
-          </a:ln>
-        </p:spPr>
-        <p:txBody>
-          <a:bodyPr spcFirstLastPara="1" wrap="square" lIns="91425" tIns="45700" rIns="91425" bIns="45700" anchor="t" anchorCtr="0">
-            <a:noAutofit/>
-          </a:bodyPr>
-          <a:lstStyle/>
-          <a:p>
-            <a:pPr marL="0" marR="0" lvl="0" indent="0" algn="ctr" rtl="0">
-              <a:lnSpc>
-                <a:spcPct val="90000"/>
-              </a:lnSpc>
-              <a:spcBef>
-                <a:spcPts val="0"/>
-              </a:spcBef>
-              <a:spcAft>
-                <a:spcPts val="0"/>
-              </a:spcAft>
-              <a:buNone/>
-            </a:pPr>
-            <a:r>
-              <a:rPr lang="en-IN" sz="1600" b="1" i="0" u="none" strike="noStrike" cap="none" dirty="0">
-                <a:solidFill>
-                  <a:srgbClr val="081271"/>
-                </a:solidFill>
-                <a:latin typeface="Times New Roman"/>
-                <a:ea typeface="Times New Roman"/>
-                <a:cs typeface="Times New Roman"/>
-                <a:sym typeface="Times New Roman"/>
-              </a:rPr>
-              <a:t>[Final Project Review]</a:t>
-            </a:r>
-            <a:r>
-              <a:rPr lang="en-IN" sz="1600" b="1" dirty="0">
-                <a:solidFill>
-                  <a:srgbClr val="081271"/>
-                </a:solidFill>
-                <a:latin typeface="Times New Roman"/>
-                <a:ea typeface="Times New Roman"/>
-                <a:cs typeface="Times New Roman"/>
-                <a:sym typeface="Times New Roman"/>
-              </a:rPr>
-              <a:t/>
-            </a:r>
-            <a:r>
-              <a:rPr lang="en-IN" sz="1600" b="1" i="0" u="none" strike="noStrike" cap="none" dirty="0">
-                <a:solidFill>
-                  <a:srgbClr val="081271"/>
-                </a:solidFill>
-                <a:latin typeface="Times New Roman"/>
-                <a:ea typeface="Times New Roman"/>
-                <a:cs typeface="Times New Roman"/>
-                <a:sym typeface="Times New Roman"/>
-              </a:rPr>
-              <a:t/>
-            </a:r>
-            <a:endParaRPr sz="1600" b="1" i="0" u="none" strike="noStrike" cap="none" dirty="0">
-              <a:solidFill>
-                <a:srgbClr val="081271"/>
-              </a:solidFill>
-              <a:latin typeface="Times New Roman"/>
-              <a:ea typeface="Times New Roman"/>
-              <a:cs typeface="Times New Roman"/>
-              <a:sym typeface="Times New Roman"/>
-            </a:endParaRPr>
-          </a:p>
-        </p:txBody>
-      </p:sp>
-      <p:cxnSp>
-        <p:nvCxnSpPr>
-          <p:cNvPr id="16" name="Straight Connector 15">
-            <a:extLst>
-              <a:ext uri="{FF2B5EF4-FFF2-40B4-BE49-F238E27FC236}">
-                <a16:creationId xmlns:a16="http://schemas.microsoft.com/office/drawing/2014/main" id="{170CA935-25F2-6478-C664-35BFDF7E813C}"/>
-              </a:ext>
-            </a:extLst>
-          </p:cNvPr>
-          <p:cNvCxnSpPr/>
-          <p:nvPr/>
-        </p:nvCxnSpPr>
-        <p:spPr>
-          <a:xfrm>
-            <a:off x="0" y="1260899"/>
-            <a:ext cx="12192000" cy="0"/>
-          </a:xfrm>
-          <a:prstGeom prst="line">
-            <a:avLst/>
-          </a:prstGeom>
-          <a:ln w="28575">
-            <a:solidFill>
-              <a:srgbClr val="1A9B46"/>
-            </a:solidFill>
-          </a:ln>
-        </p:spPr>
-        <p:style>
-          <a:lnRef idx="1">
-            <a:schemeClr val="accent1"/>
-          </a:lnRef>
-          <a:fillRef idx="0">
-            <a:schemeClr val="accent1"/>
-          </a:fillRef>
-          <a:effectRef idx="0">
-            <a:schemeClr val="accent1"/>
-          </a:effectRef>
-          <a:fontRef idx="minor">
-            <a:schemeClr val="tx1"/>
-          </a:fontRef>
-        </p:style>
-      </p:cxnSp>
-      <p:sp>
-        <p:nvSpPr>
-          <p:cNvPr id="2" name="Title 1"/>
-          <p:cNvSpPr>
-            <a:spLocks noGrp="1"/>
-          </p:cNvSpPr>
-          <p:nvPr>
-            <p:ph type="title"/>
-          </p:nvPr>
-        </p:nvSpPr>
-        <p:spPr/>
-        <p:txBody>
-          <a:bodyPr/>
-          <a:lstStyle/>
-          <a:p>
-            <a:r>
-              <a:rPr sz="3200"/>
-              <a:t>Dashboard (6/7): Explain a Decision</a:t>
-            </a:r>
-          </a:p>
-        </p:txBody>
-      </p:sp>
-      <p:sp>
-        <p:nvSpPr>
-          <p:cNvPr id="19" name="Slide Number Placeholder 18">
-            <a:extLst>
-              <a:ext uri="{FF2B5EF4-FFF2-40B4-BE49-F238E27FC236}">
-                <a16:creationId xmlns:a16="http://schemas.microsoft.com/office/drawing/2014/main" id="{9B6D94B3-8D6F-6862-5C85-C28EA1FEBFFD}"/>
-              </a:ext>
-            </a:extLst>
-          </p:cNvPr>
-          <p:cNvSpPr>
-            <a:spLocks noGrp="1"/>
-          </p:cNvSpPr>
-          <p:nvPr>
-            <p:ph type="sldNum" sz="quarter" idx="12"/>
-          </p:nvPr>
-        </p:nvSpPr>
-        <p:spPr/>
-        <p:txBody>
-          <a:bodyPr/>
-          <a:lstStyle/>
-          <a:p>
-            <a:fld id="{C2216105-7B7A-4C42-B2A1-5E9A2FA4F8FD}" type="slidenum">
-              <a:rPr lang="en-IN" smtClean="0"/>
-              <a:t>3</a:t>
-            </a:fld>
-            <a:endParaRPr lang="en-IN" dirty="0"/>
-          </a:p>
-        </p:txBody>
-      </p:sp>
-      <p:pic>
-        <p:nvPicPr>
-          <p:cNvPr id="20" name="Picture 19" descr="_crop_explain_13376534.png"/>
-          <p:cNvPicPr>
-            <a:picLocks noChangeAspect="1"/>
-          </p:cNvPicPr>
-          <p:nvPr/>
-        </p:nvPicPr>
-        <p:blipFill>
-          <a:blip r:embed="rId2"/>
-          <a:stretch>
-            <a:fillRect/>
-          </a:stretch>
-        </p:blipFill>
-        <p:spPr>
-          <a:xfrm>
-            <a:off x="675885" y="1371600"/>
-            <a:ext cx="6877828" cy="2816352"/>
-          </a:xfrm>
-          <a:prstGeom prst="rect">
-            <a:avLst/>
-          </a:prstGeom>
-          <a:ln w="12700">
-            <a:solidFill>
-              <a:srgbClr val="CBD5E1"/>
-            </a:solidFill>
-          </a:ln>
-        </p:spPr>
-      </p:pic>
-      <p:sp>
-        <p:nvSpPr>
-          <p:cNvPr id="21" name="TextBox 20"/>
-          <p:cNvSpPr txBox="1"/>
-          <p:nvPr/>
-        </p:nvSpPr>
-        <p:spPr>
-          <a:xfrm>
-            <a:off x="411480" y="4215384"/>
-            <a:ext cx="7406640" cy="292608"/>
-          </a:xfrm>
-          <a:prstGeom prst="rect">
-            <a:avLst/>
-          </a:prstGeom>
-          <a:noFill/>
-        </p:spPr>
-        <p:txBody>
-          <a:bodyPr wrap="square" anchor="t" lIns="45720" rIns="45720" tIns="27432" bIns="27432">
-            <a:spAutoFit/>
-          </a:bodyPr>
-          <a:lstStyle/>
-          <a:p>
-            <a:pPr algn="ctr">
-              <a:spcAft>
-                <a:spcPts val="400"/>
-              </a:spcAft>
-            </a:pPr>
-            <a:r>
-              <a:rPr sz="1200" b="0" i="0">
-                <a:solidFill>
-                  <a:srgbClr val="5B6573"/>
-                </a:solidFill>
-                <a:latin typeface="Calibri"/>
-              </a:rPr>
-              <a:t>Day 45, product 0: explanation written by the LLM, source shown as a badge</a:t>
-            </a:r>
-          </a:p>
-        </p:txBody>
-      </p:sp>
-      <p:sp>
-        <p:nvSpPr>
-          <p:cNvPr id="22" name="TextBox 21"/>
-          <p:cNvSpPr txBox="1"/>
-          <p:nvPr/>
-        </p:nvSpPr>
-        <p:spPr>
-          <a:xfrm>
-            <a:off x="8092440" y="1371600"/>
-            <a:ext cx="3685032" cy="4937760"/>
-          </a:xfrm>
-          <a:prstGeom prst="rect">
-            <a:avLst/>
-          </a:prstGeom>
-          <a:noFill/>
-        </p:spPr>
-        <p:txBody>
-          <a:bodyPr wrap="square" anchor="t" lIns="45720" rIns="45720" tIns="27432" bIns="27432">
-            <a:spAutoFit/>
-          </a:bodyPr>
-          <a:lstStyle/>
-          <a:p>
-            <a:pPr algn="l">
-              <a:spcAft>
-                <a:spcPts val="400"/>
-              </a:spcAft>
-            </a:pPr>
-            <a:r>
-              <a:rPr sz="1700" b="1" i="0">
-                <a:solidFill>
-                  <a:srgbClr val="1B5E3A"/>
-                </a:solidFill>
-                <a:latin typeface="Calibri"/>
-              </a:rPr>
-              <a:t>How to use it</a:t>
-            </a:r>
-          </a:p>
-          <a:p>
-            <a:pPr algn="l">
-              <a:spcAft>
-                <a:spcPts val="400"/>
-              </a:spcAft>
-            </a:pPr>
-            <a:r>
-              <a:rPr sz="1400" b="0" i="0">
-                <a:solidFill>
-                  <a:srgbClr val="1F2937"/>
-                </a:solidFill>
-                <a:latin typeface="Calibri"/>
-              </a:rPr>
-              <a:t>•  Pick a day and a product</a:t>
-            </a:r>
-          </a:p>
-          <a:p>
-            <a:pPr algn="l">
-              <a:spcAft>
-                <a:spcPts val="400"/>
-              </a:spcAft>
-            </a:pPr>
-            <a:r>
-              <a:rPr sz="1400" b="0" i="0">
-                <a:solidFill>
-                  <a:srgbClr val="1F2937"/>
-                </a:solidFill>
-                <a:latin typeface="Calibri"/>
-              </a:rPr>
-              <a:t>•  Press Explain this decision</a:t>
-            </a:r>
-          </a:p>
-          <a:p>
-            <a:pPr algn="l">
-              <a:spcAft>
-                <a:spcPts val="400"/>
-              </a:spcAft>
-            </a:pPr>
-            <a:r>
-              <a:rPr sz="1400" b="0" i="0">
-                <a:solidFill>
-                  <a:srgbClr val="1F2937"/>
-                </a:solidFill>
-                <a:latin typeface="Calibri"/>
-              </a:rPr>
-              <a:t>•  Read 2–3 plain sentences</a:t>
-            </a:r>
-          </a:p>
-          <a:p>
-            <a:pPr algn="l">
-              <a:spcAft>
-                <a:spcPts val="400"/>
-              </a:spcAft>
-            </a:pPr>
-            <a:r>
-              <a:rPr sz="1400" b="0" i="0">
-                <a:solidFill>
-                  <a:srgbClr val="1F2937"/>
-                </a:solidFill>
-                <a:latin typeface="Calibri"/>
-              </a:rPr>
-              <a:t>•  The black badge shows who wrote it: a model name, or “deterministic template” if the check rejected the LLM</a:t>
-            </a:r>
-          </a:p>
-          <a:p>
-            <a:pPr algn="l">
-              <a:spcAft>
-                <a:spcPts val="400"/>
-              </a:spcAft>
-            </a:pPr>
-            <a:r>
-              <a:rPr sz="1400" b="0" i="0">
-                <a:solidFill>
-                  <a:srgbClr val="1F2937"/>
-                </a:solidFill>
-                <a:latin typeface="Calibri"/>
-              </a:rPr>
-              <a:t>•  Expand “the facts the model was given” to verify every number</a:t>
-            </a:r>
-          </a:p>
-        </p:txBody>
-      </p:sp>
-      <p:sp>
-        <p:nvSpPr>
-          <p:cNvPr id="23" name="TextBox 22"/>
-          <p:cNvSpPr txBox="1"/>
-          <p:nvPr/>
-        </p:nvSpPr>
-        <p:spPr>
-          <a:xfrm>
-            <a:off x="411480" y="4709160"/>
-            <a:ext cx="7406640" cy="1554480"/>
-          </a:xfrm>
-          <a:prstGeom prst="rect">
-            <a:avLst/>
-          </a:prstGeom>
-          <a:noFill/>
-        </p:spPr>
-        <p:txBody>
-          <a:bodyPr wrap="square" anchor="t" lIns="45720" rIns="45720" tIns="27432" bIns="27432">
-            <a:spAutoFit/>
-          </a:bodyPr>
-          <a:lstStyle/>
-          <a:p>
-            <a:pPr algn="l">
-              <a:spcAft>
-                <a:spcPts val="400"/>
-              </a:spcAft>
-            </a:pPr>
-            <a:r>
-              <a:rPr sz="1400" b="1" i="0">
-                <a:solidFill>
-                  <a:srgbClr val="D6336C"/>
-                </a:solidFill>
-                <a:latin typeface="Calibri"/>
-              </a:rPr>
-              <a:t>Check it yourself: </a:t>
-            </a:r>
-            <a:r>
-              <a:rPr sz="1400" b="0" i="0">
-                <a:solidFill>
-                  <a:srgbClr val="1F2937"/>
-                </a:solidFill>
-                <a:latin typeface="Calibri"/>
-              </a:rPr>
-              <a:t>2,365 units, 14.0 days of cover, demand of 169 units and a 7-day average of 78 all appear in the facts panel. If the model had invented a figure, the template would have replaced this text.</a:t>
-            </a:r>
-          </a:p>
-        </p:txBody>
-      </p:sp>
-    </p:spTree>
-  </p:cSld>
-  <p:clrMapOvr>
-    <a:masterClrMapping/>
-  </p:clrMapOvr>
-</p:sld>
-</file>
-
-<file path=ppt/slides/slide37.xml><?xml version="1.0" encoding="utf-8"?>
-<p:sld xmlns:a="http://schemas.openxmlformats.org/drawingml/2006/main" xmlns:p="http://schemas.openxmlformats.org/presentationml/2006/main" xmlns:r="http://schemas.openxmlformats.org/officeDocument/2006/relationships">
-  <p:cSld>
-    <p:spTree>
-      <p:nvGrpSpPr>
-        <p:cNvPr id="1" name=""/>
-        <p:cNvGrpSpPr/>
-        <p:nvPr/>
-      </p:nvGrpSpPr>
-      <p:grpSpPr/>
-      <p:sp>
-        <p:nvSpPr>
-          <p:cNvPr id="17" name="Rectangle 16">
-            <a:extLst>
-              <a:ext uri="{FF2B5EF4-FFF2-40B4-BE49-F238E27FC236}">
-                <a16:creationId xmlns:a16="http://schemas.microsoft.com/office/drawing/2014/main" id="{684365C9-E666-36EE-4DB1-04791BFC26FB}"/>
-              </a:ext>
-            </a:extLst>
-          </p:cNvPr>
-          <p:cNvSpPr/>
-          <p:nvPr/>
-        </p:nvSpPr>
-        <p:spPr>
-          <a:xfrm>
-            <a:off x="-1" y="0"/>
-            <a:ext cx="12191998" cy="1262131"/>
-          </a:xfrm>
-          <a:prstGeom prst="rect">
-            <a:avLst/>
-          </a:prstGeom>
-          <a:gradFill flip="none" rotWithShape="1">
-            <a:gsLst>
-              <a:gs pos="0">
-                <a:srgbClr val="1A9B46">
-                  <a:tint val="66000"/>
-                  <a:satMod val="160000"/>
-                </a:srgbClr>
-              </a:gs>
-              <a:gs pos="50000">
-                <a:srgbClr val="1A9B46">
-                  <a:tint val="44500"/>
-                  <a:satMod val="160000"/>
-                </a:srgbClr>
-              </a:gs>
-              <a:gs pos="100000">
-                <a:srgbClr val="1A9B46">
-                  <a:tint val="23500"/>
-                  <a:satMod val="160000"/>
-                </a:srgbClr>
-              </a:gs>
-            </a:gsLst>
-            <a:path path="circle">
-              <a:fillToRect l="50000" t="50000" r="50000" b="50000"/>
-            </a:path>
-            <a:tileRect/>
-          </a:gradFill>
-          <a:ln>
-            <a:noFill/>
-          </a:ln>
-        </p:spPr>
-        <p:style>
-          <a:lnRef idx="2">
-            <a:schemeClr val="accent1">
-              <a:shade val="50000"/>
-            </a:schemeClr>
-          </a:lnRef>
-          <a:fillRef idx="1">
-            <a:schemeClr val="accent1"/>
-          </a:fillRef>
-          <a:effectRef idx="0">
-            <a:schemeClr val="accent1"/>
-          </a:effectRef>
-          <a:fontRef idx="minor">
-            <a:schemeClr val="lt1"/>
-          </a:fontRef>
-        </p:style>
-        <p:txBody>
-          <a:bodyPr rtlCol="0" anchor="ctr"/>
-          <a:lstStyle/>
-          <a:p>
-            <a:pPr algn="ctr"/>
-            <a:endParaRPr lang="en-IN" sz="4400" dirty="0">
-              <a:solidFill>
-                <a:schemeClr val="accent1">
-                  <a:lumMod val="50000"/>
-                </a:schemeClr>
-              </a:solidFill>
-            </a:endParaRPr>
-          </a:p>
-        </p:txBody>
-      </p:sp>
-      <p:sp>
-        <p:nvSpPr>
-          <p:cNvPr id="10" name="Google Shape;91;p1">
-            <a:extLst>
-              <a:ext uri="{FF2B5EF4-FFF2-40B4-BE49-F238E27FC236}">
-                <a16:creationId xmlns:a16="http://schemas.microsoft.com/office/drawing/2014/main" id="{4D89FC00-7640-2DC1-0BAF-6A1DC613CF6B}"/>
-              </a:ext>
-            </a:extLst>
-          </p:cNvPr>
-          <p:cNvSpPr txBox="1"/>
-          <p:nvPr/>
-        </p:nvSpPr>
-        <p:spPr>
-          <a:xfrm>
-            <a:off x="-1" y="6416040"/>
-            <a:ext cx="12191998" cy="441960"/>
-          </a:xfrm>
-          <a:prstGeom prst="rect">
-            <a:avLst/>
-          </a:prstGeom>
-          <a:gradFill flip="none" rotWithShape="1">
-            <a:gsLst>
-              <a:gs pos="0">
-                <a:srgbClr val="1A9B46">
-                  <a:tint val="66000"/>
-                  <a:satMod val="160000"/>
-                </a:srgbClr>
-              </a:gs>
-              <a:gs pos="50000">
-                <a:srgbClr val="1A9B46">
-                  <a:tint val="44500"/>
-                  <a:satMod val="160000"/>
-                </a:srgbClr>
-              </a:gs>
-              <a:gs pos="100000">
-                <a:srgbClr val="1A9B46">
-                  <a:tint val="23500"/>
-                  <a:satMod val="160000"/>
-                </a:srgbClr>
-              </a:gs>
-            </a:gsLst>
-            <a:path path="circle">
-              <a:fillToRect l="50000" t="50000" r="50000" b="50000"/>
-            </a:path>
-            <a:tileRect/>
-          </a:gradFill>
-          <a:ln>
-            <a:noFill/>
-          </a:ln>
-        </p:spPr>
-        <p:txBody>
-          <a:bodyPr spcFirstLastPara="1" wrap="square" lIns="91425" tIns="45700" rIns="91425" bIns="45700" anchor="t" anchorCtr="0">
-            <a:noAutofit/>
-          </a:bodyPr>
-          <a:lstStyle/>
-          <a:p>
-            <a:pPr marL="0" marR="0" lvl="0" indent="0" algn="ctr" rtl="0">
-              <a:lnSpc>
-                <a:spcPct val="90000"/>
-              </a:lnSpc>
-              <a:spcBef>
-                <a:spcPts val="0"/>
-              </a:spcBef>
-              <a:spcAft>
-                <a:spcPts val="0"/>
-              </a:spcAft>
-              <a:buNone/>
-            </a:pPr>
-            <a:r>
-              <a:rPr lang="en-IN" sz="1600" b="1" i="0" u="none" strike="noStrike" cap="none" dirty="0">
-                <a:solidFill>
-                  <a:srgbClr val="081271"/>
-                </a:solidFill>
-                <a:latin typeface="Times New Roman"/>
-                <a:ea typeface="Times New Roman"/>
-                <a:cs typeface="Times New Roman"/>
-                <a:sym typeface="Times New Roman"/>
-              </a:rPr>
-              <a:t>[Final Project Review]</a:t>
-            </a:r>
-            <a:r>
-              <a:rPr lang="en-IN" sz="1600" b="1" dirty="0">
-                <a:solidFill>
-                  <a:srgbClr val="081271"/>
-                </a:solidFill>
-                <a:latin typeface="Times New Roman"/>
-                <a:ea typeface="Times New Roman"/>
-                <a:cs typeface="Times New Roman"/>
-                <a:sym typeface="Times New Roman"/>
-              </a:rPr>
-              <a:t/>
-            </a:r>
-            <a:r>
-              <a:rPr lang="en-IN" sz="1600" b="1" i="0" u="none" strike="noStrike" cap="none" dirty="0">
-                <a:solidFill>
-                  <a:srgbClr val="081271"/>
-                </a:solidFill>
-                <a:latin typeface="Times New Roman"/>
-                <a:ea typeface="Times New Roman"/>
-                <a:cs typeface="Times New Roman"/>
-                <a:sym typeface="Times New Roman"/>
-              </a:rPr>
-              <a:t/>
-            </a:r>
-            <a:endParaRPr sz="1600" b="1" i="0" u="none" strike="noStrike" cap="none" dirty="0">
-              <a:solidFill>
-                <a:srgbClr val="081271"/>
-              </a:solidFill>
-              <a:latin typeface="Times New Roman"/>
-              <a:ea typeface="Times New Roman"/>
-              <a:cs typeface="Times New Roman"/>
-              <a:sym typeface="Times New Roman"/>
-            </a:endParaRPr>
-          </a:p>
-        </p:txBody>
-      </p:sp>
-      <p:cxnSp>
-        <p:nvCxnSpPr>
-          <p:cNvPr id="16" name="Straight Connector 15">
-            <a:extLst>
-              <a:ext uri="{FF2B5EF4-FFF2-40B4-BE49-F238E27FC236}">
-                <a16:creationId xmlns:a16="http://schemas.microsoft.com/office/drawing/2014/main" id="{170CA935-25F2-6478-C664-35BFDF7E813C}"/>
-              </a:ext>
-            </a:extLst>
-          </p:cNvPr>
-          <p:cNvCxnSpPr/>
-          <p:nvPr/>
-        </p:nvCxnSpPr>
-        <p:spPr>
-          <a:xfrm>
-            <a:off x="0" y="1260899"/>
-            <a:ext cx="12192000" cy="0"/>
-          </a:xfrm>
-          <a:prstGeom prst="line">
-            <a:avLst/>
-          </a:prstGeom>
-          <a:ln w="28575">
-            <a:solidFill>
-              <a:srgbClr val="1A9B46"/>
-            </a:solidFill>
-          </a:ln>
-        </p:spPr>
-        <p:style>
-          <a:lnRef idx="1">
-            <a:schemeClr val="accent1"/>
-          </a:lnRef>
-          <a:fillRef idx="0">
-            <a:schemeClr val="accent1"/>
-          </a:fillRef>
-          <a:effectRef idx="0">
-            <a:schemeClr val="accent1"/>
-          </a:effectRef>
-          <a:fontRef idx="minor">
-            <a:schemeClr val="tx1"/>
-          </a:fontRef>
-        </p:style>
-      </p:cxnSp>
-      <p:sp>
-        <p:nvSpPr>
-          <p:cNvPr id="2" name="Title 1"/>
-          <p:cNvSpPr>
-            <a:spLocks noGrp="1"/>
-          </p:cNvSpPr>
-          <p:nvPr>
-            <p:ph type="title"/>
-          </p:nvPr>
-        </p:nvSpPr>
-        <p:spPr/>
-        <p:txBody>
-          <a:bodyPr/>
-          <a:lstStyle/>
-          <a:p>
-            <a:r>
-              <a:rPr sz="3200"/>
-              <a:t>Dashboard (7/7): Policy Comparison and Robustness</a:t>
+              <a:t>Dashboard (5/5): Policy Comparison and Robustness</a:t>
             </a:r>
           </a:p>
         </p:txBody>
@@ -22993,7 +19976,7 @@
 </p:sld>
 </file>
 
-<file path=ppt/slides/slide38.xml><?xml version="1.0" encoding="utf-8"?>
+<file path=ppt/slides/slide34.xml><?xml version="1.0" encoding="utf-8"?>
 <p:sld xmlns:a="http://schemas.openxmlformats.org/drawingml/2006/main" xmlns:p="http://schemas.openxmlformats.org/presentationml/2006/main" xmlns:r="http://schemas.openxmlformats.org/officeDocument/2006/relationships">
   <p:cSld>
     <p:spTree>
@@ -24660,7 +21643,7 @@
 </p:sld>
 </file>
 
-<file path=ppt/slides/slide39.xml><?xml version="1.0" encoding="utf-8"?>
+<file path=ppt/slides/slide35.xml><?xml version="1.0" encoding="utf-8"?>
 <p:sld xmlns:a="http://schemas.openxmlformats.org/drawingml/2006/main" xmlns:p="http://schemas.openxmlformats.org/presentationml/2006/main" xmlns:r="http://schemas.openxmlformats.org/officeDocument/2006/relationships">
   <p:cSld>
     <p:spTree>
@@ -25525,7 +22508,7 @@
 </p:sld>
 </file>
 
-<file path=ppt/slides/slide40.xml><?xml version="1.0" encoding="utf-8"?>
+<file path=ppt/slides/slide36.xml><?xml version="1.0" encoding="utf-8"?>
 <p:sld xmlns:a="http://schemas.openxmlformats.org/drawingml/2006/main" xmlns:p="http://schemas.openxmlformats.org/presentationml/2006/main" xmlns:r="http://schemas.openxmlformats.org/officeDocument/2006/relationships">
   <p:cSld>
     <p:spTree>
@@ -26548,7 +23531,7 @@
 </p:sld>
 </file>
 
-<file path=ppt/slides/slide41.xml><?xml version="1.0" encoding="utf-8"?>
+<file path=ppt/slides/slide37.xml><?xml version="1.0" encoding="utf-8"?>
 <p:sld xmlns:a="http://schemas.openxmlformats.org/drawingml/2006/main" xmlns:p="http://schemas.openxmlformats.org/presentationml/2006/main" xmlns:r="http://schemas.openxmlformats.org/officeDocument/2006/relationships">
   <p:cSld>
     <p:spTree>
@@ -27507,7 +24490,7 @@
 </p:sld>
 </file>
 
-<file path=ppt/slides/slide42.xml><?xml version="1.0" encoding="utf-8"?>
+<file path=ppt/slides/slide38.xml><?xml version="1.0" encoding="utf-8"?>
 <p:sld xmlns:a="http://schemas.openxmlformats.org/drawingml/2006/main" xmlns:p="http://schemas.openxmlformats.org/presentationml/2006/main" xmlns:r="http://schemas.openxmlformats.org/officeDocument/2006/relationships">
   <p:cSld>
     <p:spTree>
@@ -28081,7 +25064,7 @@
 </p:sld>
 </file>
 
-<file path=ppt/slides/slide43.xml><?xml version="1.0" encoding="utf-8"?>
+<file path=ppt/slides/slide39.xml><?xml version="1.0" encoding="utf-8"?>
 <p:sld xmlns:a="http://schemas.openxmlformats.org/drawingml/2006/main" xmlns:p="http://schemas.openxmlformats.org/presentationml/2006/main" xmlns:r="http://schemas.openxmlformats.org/officeDocument/2006/relationships">
   <p:cSld>
     <p:spTree>
@@ -28561,7 +25544,7 @@
                 </a:solidFill>
                 <a:latin typeface="Calibri"/>
               </a:rPr>
-              <a:t>38+</a:t>
+              <a:t>39+</a:t>
             </a:r>
           </a:p>
           <a:p>
@@ -28662,7 +25645,7 @@
                 </a:solidFill>
                 <a:latin typeface="Calibri"/>
               </a:rPr>
-              <a:t>10,200</a:t>
+              <a:t>12,500</a:t>
             </a:r>
           </a:p>
           <a:p>
@@ -29138,7 +26121,7 @@
 </p:sld>
 </file>
 
-<file path=ppt/slides/slide44.xml><?xml version="1.0" encoding="utf-8"?>
+<file path=ppt/slides/slide40.xml><?xml version="1.0" encoding="utf-8"?>
 <p:sld xmlns:a="http://schemas.openxmlformats.org/drawingml/2006/main" xmlns:p="http://schemas.openxmlformats.org/presentationml/2006/main" xmlns:r="http://schemas.openxmlformats.org/officeDocument/2006/relationships">
   <p:cSld>
     <p:spTree>
@@ -30051,7 +27034,7 @@
 </p:sld>
 </file>
 
-<file path=ppt/slides/slide45.xml><?xml version="1.0" encoding="utf-8"?>
+<file path=ppt/slides/slide41.xml><?xml version="1.0" encoding="utf-8"?>
 <p:sld xmlns:a="http://schemas.openxmlformats.org/drawingml/2006/main" xmlns:p="http://schemas.openxmlformats.org/presentationml/2006/main" xmlns:r="http://schemas.openxmlformats.org/officeDocument/2006/relationships">
   <p:cSld>
     <p:spTree>
@@ -30688,7 +27671,7 @@
 </p:sld>
 </file>
 
-<file path=ppt/slides/slide46.xml><?xml version="1.0" encoding="utf-8"?>
+<file path=ppt/slides/slide42.xml><?xml version="1.0" encoding="utf-8"?>
 <p:sld xmlns:a="http://schemas.openxmlformats.org/drawingml/2006/main" xmlns:p="http://schemas.openxmlformats.org/presentationml/2006/main" xmlns:r="http://schemas.openxmlformats.org/officeDocument/2006/relationships">
   <p:cSld>
     <p:spTree>
@@ -31146,7 +28129,7 @@
 </p:sld>
 </file>
 
-<file path=ppt/slides/slide47.xml><?xml version="1.0" encoding="utf-8"?>
+<file path=ppt/slides/slide43.xml><?xml version="1.0" encoding="utf-8"?>
 <p:sld xmlns:a="http://schemas.openxmlformats.org/drawingml/2006/main" xmlns:p="http://schemas.openxmlformats.org/presentationml/2006/main" xmlns:r="http://schemas.openxmlformats.org/officeDocument/2006/relationships">
   <p:cSld>
     <p:spTree>

</xml_diff>

<commit_message>
Rewrite the final-review deck text in simpler words
Same slides, layout and numbers. Plain-English wording for the introduction,
problem, gaps, objectives, methodology, dataset, baselines, explainer,
crisis, dashboard, results and conclusion slides and for the three
infographics (architecture, agent loop, explainer pipeline). Technical terms
are kept but explained where they first appear.

scripts/simplify_deck_text.py records the edit. It rewrites text in place and
is not a build step.
</commit_message>
<xml_diff>
--- a/reports/SupplyAI-RL_Final_Project_Review.pptx
+++ b/reports/SupplyAI-RL_Final_Project_Review.pptx
@@ -6293,7 +6293,7 @@
                 </a:solidFill>
                 <a:latin typeface="Calibri" panose="020F0502020204030204"/>
               </a:rPr>
-              <a:t>Three demand types: steady, moderate, bursty</a:t>
+              <a:t>Three kinds of demand: steady, moderate, bursty</a:t>
             </a:r>
             <a:endParaRPr sz="1200" b="0" i="0">
               <a:solidFill>
@@ -6360,7 +6360,7 @@
                 </a:solidFill>
                 <a:latin typeface="Calibri" panose="020F0502020204030204"/>
               </a:rPr>
-              <a:t>•  1,067,371 sales records, UK online gift shop</a:t>
+              <a:t>•  1,067,371 sales records from a UK online gift shop</a:t>
             </a:r>
             <a:endParaRPr sz="1500" b="0" i="0">
               <a:solidFill>
@@ -6382,7 +6382,7 @@
                 </a:solidFill>
                 <a:latin typeface="Calibri" panose="020F0502020204030204"/>
               </a:rPr>
-              <a:t>•  Cleaned: cancellations, returns, negative quantities and missing codes removed; one row per product per day; Saturdays dropped (the shop never traded)</a:t>
+              <a:t>•  Cleaned: cancellations, returns and bad rows removed; one row per product per day; Saturdays dropped (the shop never opened)</a:t>
             </a:r>
             <a:endParaRPr sz="1500" b="0" i="0">
               <a:solidFill>
@@ -6404,7 +6404,7 @@
                 </a:solidFill>
                 <a:latin typeface="Calibri" panose="020F0502020204030204"/>
               </a:rPr>
-              <a:t>•  10 products chosen on purpose: 4 steady (CV 1.02–1.20), 3 moderate (1.29–1.65), 3 bursty (2.09–2.34)</a:t>
+              <a:t>•  10 products picked on purpose: 4 steady, 3 moderate, 3 bursty (very spiky sales)</a:t>
             </a:r>
             <a:endParaRPr sz="1500" b="0" i="0">
               <a:solidFill>
@@ -6426,7 +6426,7 @@
                 </a:solidFill>
                 <a:latin typeface="Calibri" panose="020F0502020204030204"/>
               </a:rPr>
-              <a:t>•  The agent never sees the records: five measurements (mean, variability, weekday, month, zero-sales days) drive a Gamma–Poisson demand model</a:t>
+              <a:t>•  The agent never sees the raw sales. We measure five things (average, ups and downs, weekday pattern, month pattern, zero-sale days) and the simulator recreates them</a:t>
             </a:r>
             <a:endParaRPr sz="1500" b="0" i="0">
               <a:solidFill>
@@ -6471,7 +6471,7 @@
                 </a:solidFill>
                 <a:latin typeface="Calibri" panose="020F0502020204030204"/>
               </a:rPr>
-              <a:t>If all ten products behaved alike, one simple rule would handle them all and there would be nothing for an AI to learn.</a:t>
+              <a:t>If all ten products behaved the same, one simple rule would work for all and an AI would have nothing to learn.</a:t>
             </a:r>
             <a:endParaRPr sz="1400" b="0" i="0">
               <a:solidFill>
@@ -6713,7 +6713,7 @@
           <a:p>
             <a:r>
               <a:rPr sz="3200"/>
-              <a:t>Classical Baselines and a Fair Evaluation</a:t>
+              <a:t>Classical Methods and a Fair Test</a:t>
             </a:r>
             <a:endParaRPr sz="3200"/>
           </a:p>
@@ -6864,7 +6864,7 @@
                           </a:solidFill>
                           <a:latin typeface="Calibri" panose="020F0502020204030204"/>
                         </a:rPr>
-                        <a:t>reorder below 11 days of cover, order up to 16</a:t>
+                        <a:t>order when stock covers under 11 days; refill up to 16 days</a:t>
                       </a:r>
                       <a:endParaRPr sz="1300" b="0" i="0">
                         <a:solidFill>
@@ -6922,7 +6922,7 @@
                           </a:solidFill>
                           <a:latin typeface="Calibri" panose="020F0502020204030204"/>
                         </a:rPr>
-                        <a:t>reorder at 8 days of cover, safety factor 1.6</a:t>
+                        <a:t>order at 8 days of stock left, with a safety margin of 1.6</a:t>
                       </a:r>
                       <a:endParaRPr sz="1300" b="0" i="0">
                         <a:solidFill>
@@ -6980,7 +6980,7 @@
                           </a:solidFill>
                           <a:latin typeface="Calibri" panose="020F0502020204030204"/>
                         </a:rPr>
-                        <a:t>3-day horizon, cheapest supplier</a:t>
+                        <a:t>plan 3 days ahead, use the cheapest supplier</a:t>
                       </a:r>
                       <a:endParaRPr sz="1300" b="0" i="0">
                         <a:solidFill>
@@ -7038,7 +7038,7 @@
                           </a:solidFill>
                           <a:latin typeface="Calibri" panose="020F0502020204030204"/>
                         </a:rPr>
-                        <a:t>1-day window, z = 1.28, review every 4 days</a:t>
+                        <a:t>forecast from yesterday, extra safety stock (about 90% service), check every 4 days</a:t>
                       </a:r>
                       <a:endParaRPr sz="1300" b="0" i="0">
                         <a:solidFill>
@@ -7095,7 +7095,7 @@
                           </a:solidFill>
                           <a:latin typeface="Calibri" panose="020F0502020204030204"/>
                         </a:rPr>
-                        <a:t>Seeds</a:t>
+                        <a:t>Seeds (test runs)</a:t>
                       </a:r>
                       <a:endParaRPr sz="1300" b="1" i="0">
                         <a:solidFill>
@@ -7240,7 +7240,7 @@
                           </a:solidFill>
                           <a:latin typeface="Calibri" panose="020F0502020204030204"/>
                         </a:rPr>
-                        <a:t>picking the best RL checkpoint</a:t>
+                        <a:t>choosing the best RL version</a:t>
                       </a:r>
                       <a:endParaRPr sz="1300" b="0" i="0">
                         <a:solidFill>
@@ -7298,7 +7298,7 @@
                           </a:solidFill>
                           <a:latin typeface="Calibri" panose="020F0502020204030204"/>
                         </a:rPr>
-                        <a:t>reporting only; never used to choose anything</a:t>
+                        <a:t>final results only; never used to make any choice</a:t>
                       </a:r>
                       <a:endParaRPr sz="1300" b="0" i="0">
                         <a:solidFill>
@@ -7362,7 +7362,7 @@
                 </a:solidFill>
                 <a:latin typeface="Calibri" panose="020F0502020204030204"/>
               </a:rPr>
-              <a:t>Widening the search lifted the best classical method from ₹69.7 lakh to ₹89.2 lakh on the tuning seeds. Untuned baselines would have made the AI look better than it is.</a:t>
+              <a:t>Better settings lifted the best classical method from ₹69.7 lakh to ₹89.2 lakh. Without tuning, the AI would have looked better than it really is.</a:t>
             </a:r>
             <a:endParaRPr sz="1600" b="0" i="0">
               <a:solidFill>
@@ -7384,7 +7384,7 @@
                 </a:solidFill>
                 <a:latin typeface="Calibri" panose="020F0502020204030204"/>
               </a:rPr>
-              <a:t>•  Same options for everyone. </a:t>
+              <a:t>•  Same choices for all. </a:t>
             </a:r>
             <a:r>
               <a:rPr sz="1600" b="0" i="0">
@@ -7393,7 +7393,7 @@
                 </a:solidFill>
                 <a:latin typeface="Calibri" panose="020F0502020204030204"/>
               </a:rPr>
-              <a:t>Every classical method picks from the same 21 options per product as the AI, so none has finer control.</a:t>
+              <a:t>Every classical method picks from the same 21 options per product as the AI.</a:t>
             </a:r>
             <a:endParaRPr sz="1600" b="0" i="0">
               <a:solidFill>
@@ -7415,7 +7415,7 @@
                 </a:solidFill>
                 <a:latin typeface="Calibri" panose="020F0502020204030204"/>
               </a:rPr>
-              <a:t>•  Paired comparison. </a:t>
+              <a:t>•  Same customers for all. </a:t>
             </a:r>
             <a:r>
               <a:rPr sz="1600" b="0" i="0">
@@ -7424,7 +7424,7 @@
                 </a:solidFill>
                 <a:latin typeface="Calibri" panose="020F0502020204030204"/>
               </a:rPr>
-              <a:t>Every method faces the same customers and delivery delays on each seed, so we test the per-seed difference, which removes run-to-run randomness.</a:t>
+              <a:t>Every method faces the same customers and delays on each test run, so we compare them run by run.</a:t>
             </a:r>
             <a:endParaRPr sz="1600" b="0" i="0">
               <a:solidFill>
@@ -7761,7 +7761,7 @@
                 </a:solidFill>
                 <a:latin typeface="Calibri" panose="020F0502020204030204"/>
               </a:rPr>
-              <a:t>the LLM is never asked why. The agent’s real reason is a neural network, and any “because” the LLM wrote would be a plausible story, not the cause.</a:t>
+              <a:t>the LLM is never asked why. The agent’s real reason is hidden inside a neural network, so any “because” from the LLM would just be a believable story.</a:t>
             </a:r>
             <a:endParaRPr sz="1500" b="0" i="0">
               <a:solidFill>
@@ -8003,7 +8003,7 @@
           <a:p>
             <a:r>
               <a:rPr sz="3200"/>
-              <a:t>LLM Crisis Generator and Curriculum Training</a:t>
+              <a:t>LLM Crisis Generator and Training on Crises</a:t>
             </a:r>
             <a:endParaRPr sz="3200"/>
           </a:p>
@@ -8184,7 +8184,7 @@
                           </a:solidFill>
                           <a:latin typeface="Calibri" panose="020F0502020204030204"/>
                         </a:rPr>
-                        <a:t>demand 3× on four products</a:t>
+                        <a:t>demand triples on four products</a:t>
                       </a:r>
                       <a:endParaRPr sz="1300" b="0" i="0">
                         <a:solidFill>
@@ -8270,7 +8270,7 @@
                           </a:solidFill>
                           <a:latin typeface="Calibri" panose="020F0502020204030204"/>
                         </a:rPr>
-                        <a:t>supplier 2 offline</a:t>
+                        <a:t>supplier 2 goes offline</a:t>
                       </a:r>
                       <a:endParaRPr sz="1300" b="0" i="0">
                         <a:solidFill>
@@ -8442,7 +8442,7 @@
                           </a:solidFill>
                           <a:latin typeface="Calibri" panose="020F0502020204030204"/>
                         </a:rPr>
-                        <a:t>costs 1.6×</a:t>
+                        <a:t>costs rise 1.6×</a:t>
                       </a:r>
                       <a:endParaRPr sz="1300" b="0" i="0">
                         <a:solidFill>
@@ -8525,7 +8525,7 @@
                 </a:solidFill>
                 <a:latin typeface="Calibri" panose="020F0502020204030204"/>
               </a:rPr>
-              <a:t>These overlap: the supplier goes down during the demand spike. A single-event test never reaches that combination.</a:t>
+              <a:t>These events overlap: a supplier fails during the demand spike. A one-event test never checks that combination.</a:t>
             </a:r>
             <a:endParaRPr sz="1400" b="0" i="0">
               <a:solidFill>
@@ -8616,7 +8616,7 @@
                 </a:solidFill>
                 <a:latin typeface="Calibri" panose="020F0502020204030204"/>
               </a:rPr>
-              <a:t>Nothing the LLM writes is trusted</a:t>
+              <a:t>We do not trust what the LLM writes</a:t>
             </a:r>
             <a:endParaRPr sz="1700" b="1" i="0">
               <a:solidFill>
@@ -8638,7 +8638,7 @@
                 </a:solidFill>
                 <a:latin typeface="Calibri" panose="020F0502020204030204"/>
               </a:rPr>
-              <a:t>•  Scenario type must be known</a:t>
+              <a:t>•  The event type must be one we know</a:t>
             </a:r>
             <a:endParaRPr sz="1400" b="0" i="0">
               <a:solidFill>
@@ -8660,7 +8660,7 @@
                 </a:solidFill>
                 <a:latin typeface="Calibri" panose="020F0502020204030204"/>
               </a:rPr>
-              <a:t>•  Supplier and product numbers must exist; out-of-range products are dropped, not wrapped</a:t>
+              <a:t>•  Suppliers and products must exist (wrong ones are dropped)</a:t>
             </a:r>
             <a:endParaRPr sz="1400" b="0" i="0">
               <a:solidFill>
@@ -8682,7 +8682,7 @@
                 </a:solidFill>
                 <a:latin typeface="Calibri" panose="020F0502020204030204"/>
               </a:rPr>
-              <a:t>•  Values clamped to safe ranges</a:t>
+              <a:t>•  Numbers are kept within safe ranges</a:t>
             </a:r>
             <a:endParaRPr sz="1400" b="0" i="0">
               <a:solidFill>
@@ -8704,7 +8704,7 @@
                 </a:solidFill>
                 <a:latin typeface="Calibri" panose="020F0502020204030204"/>
               </a:rPr>
-              <a:t>•  Windows moved inside the 180-day run</a:t>
+              <a:t>•  Events are moved to fit inside the 180 days</a:t>
             </a:r>
             <a:endParaRPr sz="1400" b="0" i="0">
               <a:solidFill>
@@ -8726,7 +8726,7 @@
                 </a:solidFill>
                 <a:latin typeface="Calibri" panose="020F0502020204030204"/>
               </a:rPr>
-              <a:t>•  6 deliberately broken inputs: 3 survived, none as written</a:t>
+              <a:t>•  6 deliberately bad inputs: none got through as written</a:t>
             </a:r>
             <a:endParaRPr sz="1400" b="0" i="0">
               <a:solidFill>
@@ -8817,7 +8817,7 @@
                 </a:solidFill>
                 <a:latin typeface="Calibri" panose="020F0502020204030204"/>
               </a:rPr>
-              <a:t>Curriculum training</a:t>
+              <a:t>Training on crises</a:t>
             </a:r>
             <a:endParaRPr sz="1700" b="1" i="0">
               <a:solidFill>
@@ -8839,7 +8839,7 @@
                 </a:solidFill>
                 <a:latin typeface="Calibri" panose="020F0502020204030204"/>
               </a:rPr>
-              <a:t>•  16 crisis sets from 19 LLM scenarios, saved, then split 10 train / 6 test</a:t>
+              <a:t>•  16 sets of crises (from 19 LLM scenarios): 10 for training, 6 for testing</a:t>
             </a:r>
             <a:endParaRPr sz="1400" b="0" i="0">
               <a:solidFill>
@@ -8861,7 +8861,7 @@
                 </a:solidFill>
                 <a:latin typeface="Calibri" panose="020F0502020204030204"/>
               </a:rPr>
-              <a:t>•  The agent trains on a random set from the 10 and is tested on the 6 it never saw; seed, settings and steps match the untuned agent, so crisis exposure is the only difference</a:t>
+              <a:t>•  The agent trains on the 10 and is tested on the 6 it never saw. Everything else matches the plain agent, so crises are the only difference</a:t>
             </a:r>
             <a:endParaRPr sz="1400" b="0" i="0">
               <a:solidFill>
@@ -8883,7 +8883,7 @@
                 </a:solidFill>
                 <a:latin typeface="Calibri" panose="020F0502020204030204"/>
               </a:rPr>
-              <a:t>•  The split is the whole method: testing on training crises would only measure memorisation</a:t>
+              <a:t>•  The split matters: testing on crises it trained on would only prove it memorised them</a:t>
             </a:r>
             <a:endParaRPr sz="1400" b="0" i="0">
               <a:solidFill>
@@ -9216,7 +9216,7 @@
                 </a:solidFill>
                 <a:latin typeface="Calibri" panose="020F0502020204030204"/>
               </a:rPr>
-              <a:t>Streamlit dashboard, forecast + safety stock, held-out seed 500</a:t>
+              <a:t>Dashboard: forecast + safety stock policy, test run 500</a:t>
             </a:r>
             <a:endParaRPr sz="1200" b="0" i="0">
               <a:solidFill>
@@ -9320,7 +9320,7 @@
                 </a:solidFill>
                 <a:latin typeface="Calibri" panose="020F0502020204030204"/>
               </a:rPr>
-              <a:t>Pick the policy and seed</a:t>
+              <a:t>Choose the policy and test run</a:t>
             </a:r>
             <a:endParaRPr sz="1600" b="1" i="0">
               <a:solidFill>
@@ -9342,7 +9342,7 @@
                 </a:solidFill>
                 <a:latin typeface="Calibri" panose="020F0502020204030204"/>
               </a:rPr>
-              <a:t>Sidebar: any policy, any held-out seed, optional crisis.</a:t>
+              <a:t>Sidebar: any policy, any test run, with or without a crisis.</a:t>
             </a:r>
             <a:endParaRPr sz="1400" b="0" i="0">
               <a:solidFill>
@@ -9468,7 +9468,7 @@
                 </a:solidFill>
                 <a:latin typeface="Calibri" panose="020F0502020204030204"/>
               </a:rPr>
-              <a:t>Profit ₹87.8 lakh, fill rate, ordering fees, stockout cost, overflow.</a:t>
+              <a:t>Profit ₹87.8 lakh, share of demand served, order fees, lost sales, wasted goods.</a:t>
             </a:r>
             <a:endParaRPr sz="1400" b="0" i="0">
               <a:solidFill>
@@ -9594,7 +9594,7 @@
                 </a:solidFill>
                 <a:latin typeface="Calibri" panose="020F0502020204030204"/>
               </a:rPr>
-              <a:t>Two single-axis charts: never a dual axis.</a:t>
+              <a:t>Two simple charts, each with its own scale.</a:t>
             </a:r>
             <a:endParaRPr sz="1400" b="0" i="0">
               <a:solidFill>
@@ -10053,7 +10053,7 @@
                 </a:solidFill>
                 <a:latin typeface="Calibri" panose="020F0502020204030204"/>
               </a:rPr>
-              <a:t>RL challenger: orders spread over all three suppliers</a:t>
+              <a:t>RL challenger: orders spread across all three suppliers</a:t>
             </a:r>
             <a:endParaRPr sz="1200" b="0" i="0">
               <a:solidFill>
@@ -10127,7 +10127,7 @@
                 </a:solidFill>
                 <a:latin typeface="Calibri" panose="020F0502020204030204"/>
               </a:rPr>
-              <a:t>Engine with a crisis injected: shaded band = disruption</a:t>
+              <a:t>Engine with a crisis added: shaded band = disruption</a:t>
             </a:r>
             <a:endParaRPr sz="1200" b="0" i="0">
               <a:solidFill>
@@ -10181,7 +10181,7 @@
                 </a:solidFill>
                 <a:latin typeface="Calibri" panose="020F0502020204030204"/>
               </a:rPr>
-              <a:t>602 orders across all three suppliers against the engine’s 323. That fragmentation is the cause of the agent’s double ordering fees.   </a:t>
+              <a:t>602 orders spread over all three suppliers, against 323 for the engine. This splitting is why the agent pays about double the order fees.   </a:t>
             </a:r>
             <a:r>
               <a:rPr sz="1400" b="1" i="0">
@@ -10199,7 +10199,7 @@
                 </a:solidFill>
                 <a:latin typeface="Calibri" panose="020F0502020204030204"/>
               </a:rPr>
-              <a:t>the red band marks the days the disruption is active, so stock and profit can be read against it.</a:t>
+              <a:t>the shaded band shows the days of the disruption, so you can read stock and profit against it.</a:t>
             </a:r>
             <a:endParaRPr sz="1400" b="0" i="0">
               <a:solidFill>
@@ -10532,7 +10532,7 @@
                 </a:solidFill>
                 <a:latin typeface="Calibri" panose="020F0502020204030204"/>
               </a:rPr>
-              <a:t>“Before”: a fixed daily order.  “After”: the engine, with the RL challenger beside it.</a:t>
+              <a:t>“Before”: the same fixed order every day.  “After”: our engine, with the RL challenger beside it.</a:t>
             </a:r>
             <a:endParaRPr sz="1200" b="0" i="0">
               <a:solidFill>
@@ -10758,7 +10758,7 @@
                 </a:solidFill>
                 <a:latin typeface="Calibri" panose="020F0502020204030204"/>
               </a:rPr>
-              <a:t>Fill rate   +5.6 points</a:t>
+              <a:t>Share of demand served   +5.6 points</a:t>
             </a:r>
             <a:endParaRPr sz="1300" b="0" i="0">
               <a:solidFill>
@@ -10871,7 +10871,7 @@
                 </a:solidFill>
                 <a:latin typeface="Calibri" panose="020F0502020204030204"/>
               </a:rPr>
-              <a:t>Stockout cost   -79%</a:t>
+              <a:t>Lost-sales cost   -79%</a:t>
             </a:r>
             <a:endParaRPr sz="1300" b="0" i="0">
               <a:solidFill>
@@ -10916,7 +10916,7 @@
                 </a:solidFill>
                 <a:latin typeface="Calibri" panose="020F0502020204030204"/>
               </a:rPr>
-              <a:t>Most of the gain comes from forecasting with safety stock, which is what the engine does, not from RL.</a:t>
+              <a:t>Most of this gain comes from smart forecasting with safety stock (the engine), not from RL.</a:t>
             </a:r>
             <a:endParaRPr sz="1300" b="0" i="1">
               <a:solidFill>
@@ -11249,7 +11249,7 @@
                 </a:solidFill>
                 <a:latin typeface="Calibri" panose="020F0502020204030204"/>
               </a:rPr>
-              <a:t>Day 45, product 0: explanation written by the LLM, source shown as a badge</a:t>
+              <a:t>Day 45, product 0: explanation written by the LLM; the badge shows who wrote it</a:t>
             </a:r>
             <a:endParaRPr sz="1200" b="0" i="0">
               <a:solidFill>
@@ -11316,7 +11316,7 @@
                 </a:solidFill>
                 <a:latin typeface="Calibri" panose="020F0502020204030204"/>
               </a:rPr>
-              <a:t>•  Pick a day and a product</a:t>
+              <a:t>•  Choose a day and a product</a:t>
             </a:r>
             <a:endParaRPr sz="1400" b="0" i="0">
               <a:solidFill>
@@ -11382,7 +11382,7 @@
                 </a:solidFill>
                 <a:latin typeface="Calibri" panose="020F0502020204030204"/>
               </a:rPr>
-              <a:t>•  The black badge shows who wrote it: a model name, or “deterministic template” if the check rejected the LLM</a:t>
+              <a:t>•  The black badge shows the writer: a model name, or “template” if our check rejected the LLM</a:t>
             </a:r>
             <a:endParaRPr sz="1400" b="0" i="0">
               <a:solidFill>
@@ -11404,7 +11404,7 @@
                 </a:solidFill>
                 <a:latin typeface="Calibri" panose="020F0502020204030204"/>
               </a:rPr>
-              <a:t>•  Expand “the facts the model was given” to verify every number</a:t>
+              <a:t>•  Open “the facts the model was given” to check every number</a:t>
             </a:r>
             <a:endParaRPr sz="1400" b="0" i="0">
               <a:solidFill>
@@ -11458,7 +11458,7 @@
                 </a:solidFill>
                 <a:latin typeface="Calibri" panose="020F0502020204030204"/>
               </a:rPr>
-              <a:t>2,365 units, 14.0 days of cover, demand of 169 units and a 7-day average of 78 all appear in the facts panel. If the model had invented a figure, the template would have replaced this text.</a:t>
+              <a:t>2,365 units, 14.0 days of cover, demand of 169 units and a 7-day average of 78 all appear in the facts panel. If the model had made up a number, the template would have replaced this text.</a:t>
             </a:r>
             <a:endParaRPr sz="1400" b="0" i="0">
               <a:solidFill>
@@ -11791,7 +11791,7 @@
                 </a:solidFill>
                 <a:latin typeface="Calibri" panose="020F0502020204030204"/>
               </a:rPr>
-              <a:t>Policy comparison tab: 30 held-out seeds</a:t>
+              <a:t>Comparison tab: 30 unseen test runs</a:t>
             </a:r>
             <a:endParaRPr sz="1200" b="0" i="0">
               <a:solidFill>
@@ -11865,7 +11865,7 @@
                 </a:solidFill>
                 <a:latin typeface="Calibri" panose="020F0502020204030204"/>
               </a:rPr>
-              <a:t>Robustness tab: calm vs 6 unseen crises</a:t>
+              <a:t>Robustness tab: normal days vs 6 unseen crises</a:t>
             </a:r>
             <a:endParaRPr sz="1200" b="0" i="0">
               <a:solidFill>
@@ -11910,7 +11910,7 @@
                 </a:solidFill>
                 <a:latin typeface="Calibri" panose="020F0502020204030204"/>
               </a:rPr>
-              <a:t>•  Only the rows a claim depends on are shown: the four classical methods, the tuned, untuned and no-masking agents; then the engine, the tuned agent, and the curriculum agent beside its control.</a:t>
+              <a:t>•  Only the rows needed for our claims are shown: the 4 classical methods and 3 RL agents (tuned, untuned, no masking); then the engine, the tuned agent, and the crisis-trained agent beside its control.</a:t>
             </a:r>
             <a:endParaRPr sz="1400" b="0" i="0">
               <a:solidFill>
@@ -11932,7 +11932,7 @@
                 </a:solidFill>
                 <a:latin typeface="Calibri" panose="020F0502020204030204"/>
               </a:rPr>
-              <a:t>•  The headline cards give the numbers directly; the table below each chart is the same data for anyone who wants to check it.</a:t>
+              <a:t>•  The cards give the key numbers; the table under each chart has the same data for checking.</a:t>
             </a:r>
             <a:endParaRPr sz="1400" b="0" i="0">
               <a:solidFill>
@@ -12299,7 +12299,7 @@
                           </a:solidFill>
                           <a:latin typeface="Calibri" panose="020F0502020204030204"/>
                         </a:rPr>
-                        <a:t>Fill</a:t>
+                        <a:t>Served</a:t>
                       </a:r>
                       <a:endParaRPr sz="1200" b="1" i="0">
                         <a:solidFill>
@@ -12357,7 +12357,7 @@
                           </a:solidFill>
                           <a:latin typeface="Calibri" panose="020F0502020204030204"/>
                         </a:rPr>
-                        <a:t>Stockout</a:t>
+                        <a:t>Lost sales</a:t>
                       </a:r>
                       <a:endParaRPr sz="1200" b="1" i="0">
                         <a:solidFill>
@@ -13263,7 +13263,7 @@
                           </a:solidFill>
                           <a:latin typeface="Calibri" panose="020F0502020204030204"/>
                         </a:rPr>
-                        <a:t>Constant order (no system)</a:t>
+                        <a:t>Fixed daily order (no system)</a:t>
                       </a:r>
                       <a:endParaRPr sz="1200" b="0" i="0">
                         <a:solidFill>
@@ -13790,7 +13790,7 @@
                 </a:solidFill>
                 <a:latin typeface="Calibri" panose="020F0502020204030204"/>
               </a:rPr>
-              <a:t>gap per run, paired t = -6.45</a:t>
+              <a:t>gap per run (t = −6.45: a real gap)</a:t>
             </a:r>
             <a:endParaRPr sz="1300" b="0" i="0">
               <a:solidFill>
@@ -13835,7 +13835,7 @@
                 </a:solidFill>
                 <a:latin typeface="Calibri" panose="020F0502020204030204"/>
               </a:rPr>
-              <a:t>The best classical method beats the tuned agent, and the difference is real (95% CI 5.5–10.6 lakh), not chance. The agent beats two of the four classical methods: EOQ and (s,S).</a:t>
+              <a:t>The best classical method beats the tuned agent, and the gap is real, not luck (95% range: 5.5–10.6 lakh). The agent does beat two of the four classical methods: EOQ and (s,S).</a:t>
             </a:r>
             <a:endParaRPr sz="1500" b="0" i="0">
               <a:solidFill>
@@ -13857,7 +13857,7 @@
                 </a:solidFill>
                 <a:latin typeface="Calibri" panose="020F0502020204030204"/>
               </a:rPr>
-              <a:t>Mean profit per 180-day run, 30 held-out seeds. Rupees at 1 GBP = 105.</a:t>
+              <a:t>Average profit per 180-day run over 30 unseen test runs. Rupees at 1 GBP = 105.</a:t>
             </a:r>
             <a:endParaRPr sz="1200" b="0" i="0">
               <a:solidFill>
@@ -14785,7 +14785,7 @@
                           </a:solidFill>
                           <a:latin typeface="Calibri" panose="020F0502020204030204"/>
                         </a:rPr>
-                        <a:t>Train score</a:t>
+                        <a:t>Practice score</a:t>
                       </a:r>
                       <a:endParaRPr sz="1400" b="1" i="0">
                         <a:solidFill>
@@ -14873,7 +14873,7 @@
                           </a:solidFill>
                           <a:latin typeface="Calibri" panose="020F0502020204030204"/>
                         </a:rPr>
-                        <a:t>PPO, no masking</a:t>
+                        <a:t>Basic RL (no masking)</a:t>
                       </a:r>
                       <a:endParaRPr sz="1400" b="0" i="0">
                         <a:solidFill>
@@ -14990,7 +14990,7 @@
                           </a:solidFill>
                           <a:latin typeface="Calibri" panose="020F0502020204030204"/>
                         </a:rPr>
-                        <a:t>+ action masking</a:t>
+                        <a:t>+ masking (block bad choices)</a:t>
                       </a:r>
                       <a:endParaRPr sz="1400" b="0" i="0">
                         <a:solidFill>
@@ -15249,7 +15249,7 @@
                 </a:solidFill>
                 <a:latin typeface="Calibri" panose="020F0502020204030204"/>
               </a:rPr>
-              <a:t>•  Action masking: about 3×. </a:t>
+              <a:t>•  Masking: about 3×. </a:t>
             </a:r>
             <a:r>
               <a:rPr sz="1600" b="0" i="0">
@@ -15258,7 +15258,7 @@
                 </a:solidFill>
                 <a:latin typeface="Calibri" panose="020F0502020204030204"/>
               </a:rPr>
-              <a:t>Without it the agent spends most of training discovering that some choices are pointless.</a:t>
+              <a:t>Without it, the agent wastes most of its training on choices that can never work.</a:t>
             </a:r>
             <a:endParaRPr sz="1600" b="0" i="0">
               <a:solidFill>
@@ -15289,7 +15289,7 @@
                 </a:solidFill>
                 <a:latin typeface="Calibri" panose="020F0502020204030204"/>
               </a:rPr>
-              <a:t>From a 13.0 to an 8.1 lakh gap.</a:t>
+              <a:t>The gap shrank from 13.0 to 8.1 lakh.</a:t>
             </a:r>
             <a:endParaRPr sz="1600" b="0" i="0">
               <a:solidFill>
@@ -15311,7 +15311,7 @@
                 </a:solidFill>
                 <a:latin typeface="Calibri" panose="020F0502020204030204"/>
               </a:rPr>
-              <a:t>Train scores use checkpoint-selection seeds 900–905; test scores use the held-out seeds 500–529.</a:t>
+              <a:t>Practice scores use runs 900–905; test scores use unseen runs 500–529.</a:t>
             </a:r>
             <a:endParaRPr sz="1200" b="0" i="0">
               <a:solidFill>
@@ -15385,7 +15385,7 @@
                 </a:solidFill>
                 <a:latin typeface="Calibri" panose="020F0502020204030204"/>
               </a:rPr>
-              <a:t>Learning curves: no masking, masking, tuned (checkpoint seeds)</a:t>
+              <a:t>Learning curves: no masking, masking, tuned</a:t>
             </a:r>
             <a:endParaRPr sz="1200" b="0" i="0">
               <a:solidFill>
@@ -15627,7 +15627,7 @@
           <a:p>
             <a:r>
               <a:rPr sz="3200"/>
-              <a:t>Results (3/4): Robustness to Unseen Crises</a:t>
+              <a:t>Results (3/4): Coping with Unseen Crises</a:t>
             </a:r>
             <a:endParaRPr sz="3200"/>
           </a:p>
@@ -15722,7 +15722,7 @@
                           </a:solidFill>
                           <a:latin typeface="Calibri" panose="020F0502020204030204"/>
                         </a:rPr>
-                        <a:t>Calm</a:t>
+                        <a:t>Normal</a:t>
                       </a:r>
                       <a:endParaRPr sz="1400" b="1" i="0">
                         <a:solidFill>
@@ -16371,7 +16371,7 @@
                 </a:solidFill>
                 <a:latin typeface="Calibri" panose="020F0502020204030204"/>
               </a:rPr>
-              <a:t>•  Under crisis it earns ₹38.9 lakh vs the control’s ₹38.8 lakh</a:t>
+              <a:t>•  In a crisis it earns ₹38.9 lakh, same as the control’s ₹38.8 lakh</a:t>
             </a:r>
             <a:endParaRPr sz="1400" b="0" i="0">
               <a:solidFill>
@@ -16393,7 +16393,7 @@
                 </a:solidFill>
                 <a:latin typeface="Calibri" panose="020F0502020204030204"/>
               </a:rPr>
-              <a:t>•  but gave up ₹7.7 lakh of calm profit</a:t>
+              <a:t>•  and it lost ₹7.7 lakh of normal profit</a:t>
             </a:r>
             <a:endParaRPr sz="1400" b="0" i="0">
               <a:solidFill>
@@ -16415,7 +16415,7 @@
                 </a:solidFill>
                 <a:latin typeface="Calibri" panose="020F0502020204030204"/>
               </a:rPr>
-              <a:t>•  Paired t = +1.69: not significant</a:t>
+              <a:t>•  t = +1.69: not a real difference</a:t>
             </a:r>
             <a:endParaRPr sz="1400" b="0" i="0">
               <a:solidFill>
@@ -16460,7 +16460,7 @@
                 </a:solidFill>
                 <a:latin typeface="Calibri" panose="020F0502020204030204"/>
               </a:rPr>
-              <a:t>•  A smaller percentage drop is misleading </a:t>
+              <a:t>•  A smaller % drop can mislead </a:t>
             </a:r>
             <a:r>
               <a:rPr sz="1600" b="0" i="0">
@@ -16469,7 +16469,7 @@
                 </a:solidFill>
                 <a:latin typeface="Calibri" panose="020F0502020204030204"/>
               </a:rPr>
-              <a:t>when the base is lower: the crisis-trained agent drops less because it has less to lose. We show the drop beside absolute profit so “less to lose” cannot pass for robustness.</a:t>
+              <a:t>when the starting profit is lower: the crisis-trained agent drops less because it had less to lose. We show the drop next to the actual profit so we are not fooled.</a:t>
             </a:r>
             <a:endParaRPr sz="1600" b="0" i="0">
               <a:solidFill>
@@ -16500,7 +16500,7 @@
                 </a:solidFill>
                 <a:latin typeface="Calibri" panose="020F0502020204030204"/>
               </a:rPr>
-              <a:t>plain hyperparameter tuning made the agent more robust than crisis training did. The tuned agent never saw a crisis in training, yet has the highest crisis profit and smallest drop of all agent versions.</a:t>
+              <a:t>simply tuning the settings made the agent more crisis-proof than crisis training did. The tuned agent never trained on a crisis, yet has the highest crisis profit and the smallest drop of the agents.</a:t>
             </a:r>
             <a:endParaRPr sz="1600" b="0" i="0">
               <a:solidFill>
@@ -16522,7 +16522,7 @@
                 </a:solidFill>
                 <a:latin typeface="Calibri" panose="020F0502020204030204"/>
               </a:rPr>
-              <a:t>Limit: the crisis-trained agent faced a harder task with the same step budget, so under-training may explain part of its result.</a:t>
+              <a:t>Limit: the crisis-trained agent had a harder job with the same training time, so it may simply be under-trained.</a:t>
             </a:r>
             <a:endParaRPr sz="1300" b="0" i="0">
               <a:solidFill>
@@ -16894,7 +16894,7 @@
                 </a:solidFill>
                 <a:latin typeface="Calibri" panose="020F0502020204030204"/>
               </a:rPr>
-              <a:t>raw LLM accuracy: grounded and complete, before the check</a:t>
+              <a:t>raw LLM accuracy: correct and complete, before our check</a:t>
             </a:r>
             <a:endParaRPr sz="1300" b="0" i="0">
               <a:solidFill>
@@ -17007,7 +17007,7 @@
                 </a:solidFill>
                 <a:latin typeface="Calibri" panose="020F0502020204030204"/>
               </a:rPr>
-              <a:t>delivered accuracy: what the manager saw, after the check</a:t>
+              <a:t>delivered accuracy: what the manager actually saw</a:t>
             </a:r>
             <a:endParaRPr sz="1300" b="0" i="0">
               <a:solidFill>
@@ -17120,7 +17120,7 @@
                 </a:solidFill>
                 <a:latin typeface="Calibri" panose="020F0502020204030204"/>
               </a:rPr>
-              <a:t>raw outputs contained an invented number; all 5 caught</a:t>
+              <a:t>outputs had an invented number; all 5 caught</a:t>
             </a:r>
             <a:endParaRPr sz="1300" b="0" i="0">
               <a:solidFill>
@@ -17226,7 +17226,7 @@
                           </a:solidFill>
                           <a:latin typeface="Calibri" panose="020F0502020204030204"/>
                         </a:rPr>
-                        <a:t>LLM reachable (after retries)</a:t>
+                        <a:t>LLM answered (after retries)</a:t>
                       </a:r>
                       <a:endParaRPr sz="1400" b="0" i="0">
                         <a:solidFill>
@@ -17285,7 +17285,7 @@
                           </a:solidFill>
                           <a:latin typeface="Calibri" panose="020F0502020204030204"/>
                         </a:rPr>
-                        <a:t>Grounded (raw output used only real numbers)</a:t>
+                        <a:t>Only real numbers used (before the check)</a:t>
                       </a:r>
                       <a:endParaRPr sz="1400" b="0" i="0">
                         <a:solidFill>
@@ -17509,7 +17509,7 @@
                 </a:solidFill>
                 <a:latin typeface="Calibri" panose="020F0502020204030204"/>
               </a:rPr>
-              <a:t>•  The five bad outputs read fluently and confidently. A buyer would not have noticed.</a:t>
+              <a:t>•  The five bad outputs sounded confident and fluent. A buyer would not notice.</a:t>
             </a:r>
             <a:endParaRPr sz="1400" b="0" i="0">
               <a:solidFill>
@@ -17531,7 +17531,7 @@
                 </a:solidFill>
                 <a:latin typeface="Calibri" panose="020F0502020204030204"/>
               </a:rPr>
-              <a:t>•  Without the check, one explanation in six would carry a made-up figure.</a:t>
+              <a:t>•  Without the check, 1 explanation in 6 would contain a made-up number.</a:t>
             </a:r>
             <a:endParaRPr sz="1400" b="0" i="0">
               <a:solidFill>
@@ -17553,7 +17553,7 @@
                 </a:solidFill>
                 <a:latin typeface="Calibri" panose="020F0502020204030204"/>
               </a:rPr>
-              <a:t>•  An earlier metric scored only outputs that had already passed the check and reported 100% for a model that invented numbers 17% of the time. We replaced it with both numbers.</a:t>
+              <a:t>•  An earlier version only scored outputs that had already passed the check, so it showed 100% for a model that made up numbers 17% of the time. We now show both numbers.</a:t>
             </a:r>
             <a:endParaRPr sz="1400" b="0" i="0">
               <a:solidFill>
@@ -17925,7 +17925,7 @@
                 </a:solidFill>
                 <a:latin typeface="Calibri" panose="020F0502020204030204"/>
               </a:rPr>
-              <a:t>•  A complete system: simulator, RL agent, 4 tuned baselines, LLM explainer, crisis generator, dashboard</a:t>
+              <a:t>•  A complete system: simulator, RL agent, 4 tuned classical methods, LLM explainer, crisis generator, dashboard</a:t>
             </a:r>
             <a:endParaRPr sz="1600" b="0" i="0">
               <a:solidFill>
@@ -17947,7 +17947,7 @@
                 </a:solidFill>
                 <a:latin typeface="Calibri" panose="020F0502020204030204"/>
               </a:rPr>
-              <a:t>•  The tuned agent reaches 90.8% of the best classical profit and beats two of four classical methods; the gap is real (t = -6.45) and traced to supplier fragmentation</a:t>
+              <a:t>•  The tuned agent earns 90.8% of the best classical method and beats two of the four; the gap is real (t = -6.45) and comes from splitting orders across suppliers</a:t>
             </a:r>
             <a:endParaRPr sz="1600" b="0" i="0">
               <a:solidFill>
@@ -17991,7 +17991,7 @@
                 </a:solidFill>
                 <a:latin typeface="Calibri" panose="020F0502020204030204"/>
               </a:rPr>
-              <a:t>•  The explainer is only accurate because it is checked: 83% raw, 100% delivered</a:t>
+              <a:t>•  The explainer is accurate only because it is checked: 83% before, 100% after</a:t>
             </a:r>
             <a:endParaRPr sz="1600" b="0" i="0">
               <a:solidFill>
@@ -18013,7 +18013,7 @@
                 </a:solidFill>
                 <a:latin typeface="Calibri" panose="020F0502020204030204"/>
               </a:rPr>
-              <a:t>•  The honest deployment: classical engine decides, RL scored beside it, nothing executes</a:t>
+              <a:t>•  Safe way to use it: the classical engine decides, RL is scored alongside, nothing is executed</a:t>
             </a:r>
             <a:endParaRPr sz="1600" b="0" i="0">
               <a:solidFill>
@@ -18126,7 +18126,7 @@
                 </a:solidFill>
                 <a:latin typeface="Calibri" panose="020F0502020204030204"/>
               </a:rPr>
-              <a:t>•  Give the agent ordering memory (days since last order, last supplier, fees so far) and re-run on the same 30 seeds: the experiment most likely to close the gap</a:t>
+              <a:t>•  Give the agent a memory of its own orders (days since last order, last supplier, fees so far) and test again on the same 30 runs: the best chance to close the gap</a:t>
             </a:r>
             <a:endParaRPr sz="1600" b="0" i="0">
               <a:solidFill>
@@ -18148,7 +18148,7 @@
                 </a:solidFill>
                 <a:latin typeface="Calibri" panose="020F0502020204030204"/>
               </a:rPr>
-              <a:t>•  Test all methods under changed market conditions (more demand variation, longer delays) to show how rankings move</a:t>
+              <a:t>•  Test all methods when the market changes (wilder demand, longer delays)</a:t>
             </a:r>
             <a:endParaRPr sz="1600" b="0" i="0">
               <a:solidFill>
@@ -18170,7 +18170,7 @@
                 </a:solidFill>
                 <a:latin typeface="Calibri" panose="020F0502020204030204"/>
               </a:rPr>
-              <a:t>•  Longer crisis training, to separate under-training from a failed method</a:t>
+              <a:t>•  Train longer on crises, to see whether the method failed or was just under-trained</a:t>
             </a:r>
             <a:endParaRPr sz="1600" b="0" i="0">
               <a:solidFill>
@@ -18192,7 +18192,7 @@
                 </a:solidFill>
                 <a:latin typeface="Calibri" panose="020F0502020204030204"/>
               </a:rPr>
-              <a:t>•  Recent real data and real supplier terms if a partner can supply them</a:t>
+              <a:t>•  Use recent real data and real supplier terms if a partner can provide them</a:t>
             </a:r>
             <a:endParaRPr sz="1600" b="0" i="0">
               <a:solidFill>
@@ -18214,7 +18214,7 @@
                 </a:solidFill>
                 <a:latin typeface="Calibri" panose="020F0502020204030204"/>
               </a:rPr>
-              <a:t>•  Before any live use: new-product handling, order-value limits, an audit trail, a signal for when a human should decide</a:t>
+              <a:t>•  Before real use: handle new products, set order limits, keep an audit trail, and flag when a human should decide</a:t>
             </a:r>
             <a:endParaRPr sz="1600" b="0" i="0">
               <a:solidFill>
@@ -19247,7 +19247,7 @@
                 </a:solidFill>
                 <a:latin typeface="Calibri" panose="020F0502020204030204"/>
               </a:rPr>
-              <a:t>•  Money sits in the warehouse</a:t>
+              <a:t>•  Money is stuck in the warehouse</a:t>
             </a:r>
             <a:endParaRPr sz="1400" b="0" i="0">
               <a:solidFill>
@@ -19269,7 +19269,7 @@
                 </a:solidFill>
                 <a:latin typeface="Calibri" panose="020F0502020204030204"/>
               </a:rPr>
-              <a:t>•  Storage costs pile up</a:t>
+              <a:t>•  Storage costs keep adding up</a:t>
             </a:r>
             <a:endParaRPr sz="1400" b="0" i="0">
               <a:solidFill>
@@ -19291,7 +19291,7 @@
                 </a:solidFill>
                 <a:latin typeface="Calibri" panose="020F0502020204030204"/>
               </a:rPr>
-              <a:t>•  Seasonal goods are marked down</a:t>
+              <a:t>•  Seasonal goods lose value</a:t>
             </a:r>
             <a:endParaRPr sz="1400" b="0" i="0">
               <a:solidFill>
@@ -19404,7 +19404,7 @@
                 </a:solidFill>
                 <a:latin typeface="Calibri" panose="020F0502020204030204"/>
               </a:rPr>
-              <a:t>•  The customer buys elsewhere</a:t>
+              <a:t>•  The customer goes elsewhere</a:t>
             </a:r>
             <a:endParaRPr sz="1400" b="0" i="0">
               <a:solidFill>
@@ -19426,7 +19426,7 @@
                 </a:solidFill>
                 <a:latin typeface="Calibri" panose="020F0502020204030204"/>
               </a:rPr>
-              <a:t>•  The sale is gone for good</a:t>
+              <a:t>•  The sale is lost for good</a:t>
             </a:r>
             <a:endParaRPr sz="1400" b="0" i="0">
               <a:solidFill>
@@ -19448,7 +19448,7 @@
                 </a:solidFill>
                 <a:latin typeface="Calibri" panose="020F0502020204030204"/>
               </a:rPr>
-              <a:t>•  Lost-sale penalty applies</a:t>
+              <a:t>•  We also pay a penalty</a:t>
             </a:r>
             <a:endParaRPr sz="1400" b="0" i="0">
               <a:solidFill>
@@ -19583,7 +19583,7 @@
                 </a:solidFill>
                 <a:latin typeface="Calibri" panose="020F0502020204030204"/>
               </a:rPr>
-              <a:t>•  Fast but expensive</a:t>
+              <a:t>•  Fast but costly</a:t>
             </a:r>
             <a:endParaRPr sz="1400" b="0" i="0">
               <a:solidFill>
@@ -19605,7 +19605,7 @@
                 </a:solidFill>
                 <a:latin typeface="Calibri" panose="020F0502020204030204"/>
               </a:rPr>
-              <a:t>•  Reasonable but ships only 80%</a:t>
+              <a:t>•  Looks fine but ships only 80%</a:t>
             </a:r>
             <a:endParaRPr sz="1400" b="0" i="0">
               <a:solidFill>
@@ -19650,7 +19650,7 @@
                 </a:solidFill>
                 <a:latin typeface="Calibri" panose="020F0502020204030204"/>
               </a:rPr>
-              <a:t>•  A sequential problem. </a:t>
+              <a:t>•  A chain of decisions. </a:t>
             </a:r>
             <a:r>
               <a:rPr sz="1800" b="0" i="0">
@@ -19659,7 +19659,7 @@
                 </a:solidFill>
                 <a:latin typeface="Calibri" panose="020F0502020204030204"/>
               </a:rPr>
-              <a:t>Today’s order becomes next week’s stock, so what you do now changes what you can do later.</a:t>
+              <a:t>Today’s order becomes next week’s stock, so every choice affects the next ones.</a:t>
             </a:r>
             <a:endParaRPr sz="1800" b="0" i="0">
               <a:solidFill>
@@ -19681,7 +19681,7 @@
                 </a:solidFill>
                 <a:latin typeface="Calibri" panose="020F0502020204030204"/>
               </a:rPr>
-              <a:t>•  Classical rules struggle. </a:t>
+              <a:t>•  Old rules fall short. </a:t>
             </a:r>
             <a:r>
               <a:rPr sz="1800" b="0" i="0">
@@ -19690,7 +19690,7 @@
                 </a:solidFill>
                 <a:latin typeface="Calibri" panose="020F0502020204030204"/>
               </a:rPr>
-              <a:t>(s,S), EOQ, newsvendor and forecast + safety stock treat each product alone and assume well-behaved demand. In our data, daily demand varies about 216× more than a Poisson model allows.</a:t>
+              <a:t>Textbook rules (like (s,S) and EOQ) look at each product alone and expect steady demand. In our data, daily demand swings about 216× more than a simple model expects.</a:t>
             </a:r>
             <a:endParaRPr sz="1800" b="0" i="0">
               <a:solidFill>
@@ -19712,7 +19712,7 @@
                 </a:solidFill>
                 <a:latin typeface="Calibri" panose="020F0502020204030204"/>
               </a:rPr>
-              <a:t>•  Our hypothesis. </a:t>
+              <a:t>•  Our idea. </a:t>
             </a:r>
             <a:r>
               <a:rPr sz="1800" b="0" i="0">
@@ -19721,7 +19721,7 @@
                 </a:solidFill>
                 <a:latin typeface="Calibri" panose="020F0502020204030204"/>
               </a:rPr>
-              <a:t>RL can learn a joint ordering and sourcing policy that adapts to season, volatility and supplier state, which a formula cannot.</a:t>
+              <a:t>A reinforcement learning (RL) agent can learn when to order and from whom, and adapt to the season and to supplier problems, which a fixed formula cannot.</a:t>
             </a:r>
             <a:endParaRPr sz="1800" b="0" i="0">
               <a:solidFill>
@@ -19743,7 +19743,7 @@
                 </a:solidFill>
                 <a:latin typeface="Calibri" panose="020F0502020204030204"/>
               </a:rPr>
-              <a:t>•  But trust matters. </a:t>
+              <a:t>•  Trust matters. </a:t>
             </a:r>
             <a:r>
               <a:rPr sz="1800" b="0" i="0">
@@ -19752,7 +19752,7 @@
                 </a:solidFill>
                 <a:latin typeface="Calibri" panose="020F0502020204030204"/>
               </a:rPr>
-              <a:t>A manager will not act on a number they cannot understand, so an LLM explains the situation behind every order, with every number checked.</a:t>
+              <a:t>A manager will not follow a number they cannot understand. So a language model (LLM) explains each order in plain words, and every number it quotes is checked.</a:t>
             </a:r>
             <a:endParaRPr sz="1800" b="0" i="0">
               <a:solidFill>
@@ -20058,7 +20058,7 @@
                           </a:solidFill>
                           <a:latin typeface="Calibri" panose="020F0502020204030204"/>
                         </a:rPr>
-                        <a:t>The task</a:t>
+                        <a:t>What</a:t>
                       </a:r>
                       <a:endParaRPr sz="1400" b="1" i="0">
                         <a:solidFill>
@@ -20087,7 +20087,7 @@
                           </a:solidFill>
                           <a:latin typeface="Calibri" panose="020F0502020204030204"/>
                         </a:rPr>
-                        <a:t>Definition</a:t>
+                        <a:t>Details</a:t>
                       </a:r>
                       <a:endParaRPr sz="1400" b="1" i="0">
                         <a:solidFill>
@@ -20145,7 +20145,7 @@
                           </a:solidFill>
                           <a:latin typeface="Calibri" panose="020F0502020204030204"/>
                         </a:rPr>
-                        <a:t>10 real products (UCI Online Retail II)</a:t>
+                        <a:t>10 real products from a UK shop’s sales data</a:t>
                       </a:r>
                       <a:endParaRPr sz="1400" b="0" i="0">
                         <a:solidFill>
@@ -20203,7 +20203,7 @@
                           </a:solidFill>
                           <a:latin typeface="Calibri" panose="020F0502020204030204"/>
                         </a:rPr>
-                        <a:t>3, invented: no public dataset has supplier terms</a:t>
+                        <a:t>3, made up by us (no public data on suppliers)</a:t>
                       </a:r>
                       <a:endParaRPr sz="1400" b="0" i="0">
                         <a:solidFill>
@@ -20261,7 +20261,7 @@
                           </a:solidFill>
                           <a:latin typeface="Calibri" panose="020F0502020204030204"/>
                         </a:rPr>
-                        <a:t>180 simulated days; first 14 are warm-up, not scored</a:t>
+                        <a:t>180 days per run; the first 14 days are a warm-up and not counted</a:t>
                       </a:r>
                       <a:endParaRPr sz="1400" b="0" i="0">
                         <a:solidFill>
@@ -20319,7 +20319,7 @@
                           </a:solidFill>
                           <a:latin typeface="Calibri" panose="020F0502020204030204"/>
                         </a:rPr>
-                        <a:t>one shared store of 20,000 units; overflow is refused</a:t>
+                        <a:t>one shared store, 20,000 units; extra goods are turned away</a:t>
                       </a:r>
                       <a:endParaRPr sz="1400" b="0" i="0">
                         <a:solidFill>
@@ -20377,7 +20377,7 @@
                           </a:solidFill>
                           <a:latin typeface="Calibri" panose="020F0502020204030204"/>
                         </a:rPr>
-                        <a:t>each day, each product: 7 quantity levels × 3 suppliers = 21 options</a:t>
+                        <a:t>every day, for each product: 7 quantities × 3 suppliers = 21 choices</a:t>
                       </a:r>
                       <a:endParaRPr sz="1400" b="0" i="0">
                         <a:solidFill>
@@ -20435,7 +20435,7 @@
                           </a:solidFill>
                           <a:latin typeface="Calibri" panose="020F0502020204030204"/>
                         </a:rPr>
-                        <a:t>maximise profit = sales − purchases − storage − fees − stockout − overflow</a:t>
+                        <a:t>maximise profit = sales − purchases − storage − fees − lost sales − wasted goods</a:t>
                       </a:r>
                       <a:endParaRPr sz="1400" b="0" i="0">
                         <a:solidFill>
@@ -20553,7 +20553,7 @@
                           </a:solidFill>
                           <a:latin typeface="Calibri" panose="020F0502020204030204"/>
                         </a:rPr>
-                        <a:t>Lead time</a:t>
+                        <a:t>Delivery</a:t>
                       </a:r>
                       <a:endParaRPr sz="1300" b="1" i="0">
                         <a:solidFill>
@@ -20582,7 +20582,7 @@
                           </a:solidFill>
                           <a:latin typeface="Calibri" panose="020F0502020204030204"/>
                         </a:rPr>
-                        <a:t>Ships</a:t>
+                        <a:t>Delivers</a:t>
                       </a:r>
                       <a:endParaRPr sz="1300" b="1" i="0">
                         <a:solidFill>
@@ -21104,7 +21104,7 @@
                 </a:solidFill>
                 <a:latin typeface="Calibri" panose="020F0502020204030204"/>
               </a:rPr>
-              <a:t>None is best: the cheap one ties up a week of stock in transit, the fast one eats margin, the middle one is unreliable.</a:t>
+              <a:t>No supplier is best: the cheap one is slow, the fast one costs more, and the middle one is unreliable.</a:t>
             </a:r>
             <a:endParaRPr sz="1400" b="0" i="0">
               <a:solidFill>
@@ -21217,7 +21217,7 @@
                 </a:solidFill>
                 <a:latin typeface="Calibri" panose="020F0502020204030204"/>
               </a:rPr>
-              <a:t>possible order combinations every day (21¹⁰)</a:t>
+              <a:t>different order combinations every day</a:t>
             </a:r>
             <a:endParaRPr sz="1300" b="0" i="0">
               <a:solidFill>
@@ -21330,7 +21330,7 @@
                 </a:solidFill>
                 <a:latin typeface="Calibri" panose="020F0502020204030204"/>
               </a:rPr>
-              <a:t>variance of daily demand vs its mean</a:t>
+              <a:t>how much more daily demand swings than a simple model expects</a:t>
             </a:r>
             <a:endParaRPr sz="1300" b="0" i="0">
               <a:solidFill>
@@ -21443,7 +21443,7 @@
                 </a:solidFill>
                 <a:latin typeface="Calibri" panose="020F0502020204030204"/>
               </a:rPr>
-              <a:t>quantity and supplier decided together</a:t>
+              <a:t>quantity and supplier are chosen together</a:t>
             </a:r>
             <a:endParaRPr sz="1300" b="0" i="0">
               <a:solidFill>
@@ -21954,7 +21954,7 @@
                           </a:solidFill>
                           <a:latin typeface="Calibri" panose="020F0502020204030204"/>
                         </a:rPr>
-                        <a:t>Clipped surrogate policy gradient</a:t>
+                        <a:t>A stable way to train an RL agent</a:t>
                       </a:r>
                       <a:endParaRPr sz="1300" b="0" i="0">
                         <a:solidFill>
@@ -21982,7 +21982,7 @@
                           </a:solidFill>
                           <a:latin typeface="Calibri" panose="020F0502020204030204"/>
                         </a:rPr>
-                        <a:t>Stable, sample-efficient default RL baseline</a:t>
+                        <a:t>Reliable; a common default</a:t>
                       </a:r>
                       <a:endParaRPr sz="1300" b="0" i="0">
                         <a:solidFill>
@@ -22010,7 +22010,7 @@
                           </a:solidFill>
                           <a:latin typeface="Calibri" panose="020F0502020204030204"/>
                         </a:rPr>
-                        <a:t>General purpose; no supply-chain structure</a:t>
+                        <a:t>General purpose; not built for supply chains</a:t>
                       </a:r>
                       <a:endParaRPr sz="1300" b="0" i="0">
                         <a:solidFill>
@@ -22096,7 +22096,7 @@
                           </a:solidFill>
                           <a:latin typeface="Calibri" panose="020F0502020204030204"/>
                         </a:rPr>
-                        <a:t>DQN on a serial chain</a:t>
+                        <a:t>Deep RL on a simple supply chain</a:t>
                       </a:r>
                       <a:endParaRPr sz="1300" b="0" i="0">
                         <a:solidFill>
@@ -22124,7 +22124,7 @@
                           </a:solidFill>
                           <a:latin typeface="Calibri" panose="020F0502020204030204"/>
                         </a:rPr>
-                        <a:t>DRL matches or beats base-stock under cooperation</a:t>
+                        <a:t>Matches or beats standard ordering rules when teams cooperate</a:t>
                       </a:r>
                       <a:endParaRPr sz="1300" b="0" i="0">
                         <a:solidFill>
@@ -22152,7 +22152,7 @@
                           </a:solidFill>
                           <a:latin typeface="Calibri" panose="020F0502020204030204"/>
                         </a:rPr>
-                        <a:t>Single product, serial chain, no sourcing choice</a:t>
+                        <a:t>One product, no supplier choice</a:t>
                       </a:r>
                       <a:endParaRPr sz="1300" b="0" i="0">
                         <a:solidFill>
@@ -22238,7 +22238,7 @@
                           </a:solidFill>
                           <a:latin typeface="Calibri" panose="020F0502020204030204"/>
                         </a:rPr>
-                        <a:t>A3C on lost-sales and dual-sourcing</a:t>
+                        <a:t>Deep RL on lost sales and two suppliers</a:t>
                       </a:r>
                       <a:endParaRPr sz="1300" b="0" i="0">
                         <a:solidFill>
@@ -22266,7 +22266,7 @@
                           </a:solidFill>
                           <a:latin typeface="Calibri" panose="020F0502020204030204"/>
                         </a:rPr>
-                        <a:t>Competitive with tuned heuristics, not clearly superior</a:t>
+                        <a:t>As good as well-tuned rules, not clearly better</a:t>
                       </a:r>
                       <a:endParaRPr sz="1300" b="0" i="0">
                         <a:solidFill>
@@ -22294,7 +22294,7 @@
                           </a:solidFill>
                           <a:latin typeface="Calibri" panose="020F0502020204030204"/>
                         </a:rPr>
-                        <a:t>Heavy tuning cost; no explanation layer</a:t>
+                        <a:t>Needs a lot of tuning; no explanations</a:t>
                       </a:r>
                       <a:endParaRPr sz="1300" b="0" i="0">
                         <a:solidFill>
@@ -22380,7 +22380,7 @@
                           </a:solidFill>
                           <a:latin typeface="Calibri" panose="020F0502020204030204"/>
                         </a:rPr>
-                        <a:t>Survey and roadmap</a:t>
+                        <a:t>Survey of the field</a:t>
                       </a:r>
                       <a:endParaRPr sz="1300" b="0" i="0">
                         <a:solidFill>
@@ -22408,7 +22408,7 @@
                           </a:solidFill>
                           <a:latin typeface="Calibri" panose="020F0502020204030204"/>
                         </a:rPr>
-                        <a:t>Names fair benchmarking and interpretability as open problems</a:t>
+                        <a:t>Says fair comparisons and explanations are still open problems</a:t>
                       </a:r>
                       <a:endParaRPr sz="1300" b="0" i="0">
                         <a:solidFill>
@@ -22436,7 +22436,7 @@
                           </a:solidFill>
                           <a:latin typeface="Calibri" panose="020F0502020204030204"/>
                         </a:rPr>
-                        <a:t>Conceptual; no implementation</a:t>
+                        <a:t>Ideas only; no experiments</a:t>
                       </a:r>
                       <a:endParaRPr sz="1300" b="0" i="0">
                         <a:solidFill>
@@ -22522,7 +22522,7 @@
                           </a:solidFill>
                           <a:latin typeface="Calibri" panose="020F0502020204030204"/>
                         </a:rPr>
-                        <a:t>Masking in policy gradients</a:t>
+                        <a:t>Blocking impossible actions during training</a:t>
                       </a:r>
                       <a:endParaRPr sz="1300" b="0" i="0">
                         <a:solidFill>
@@ -22550,7 +22550,7 @@
                           </a:solidFill>
                           <a:latin typeface="Calibri" panose="020F0502020204030204"/>
                         </a:rPr>
-                        <a:t>Masking is a valid gradient and scales to large action spaces</a:t>
+                        <a:t>Works well even with very many actions</a:t>
                       </a:r>
                       <a:endParaRPr sz="1300" b="0" i="0">
                         <a:solidFill>
@@ -22578,7 +22578,7 @@
                           </a:solidFill>
                           <a:latin typeface="Calibri" panose="020F0502020204030204"/>
                         </a:rPr>
-                        <a:t>Not shown on inventory or sourcing</a:t>
+                        <a:t>Not tried on inventory</a:t>
                       </a:r>
                       <a:endParaRPr sz="1300" b="0" i="0">
                         <a:solidFill>
@@ -22951,7 +22951,7 @@
                 </a:solidFill>
                 <a:latin typeface="Calibri" panose="020F0502020204030204"/>
               </a:rPr>
-              <a:t>Narrow problem settings</a:t>
+              <a:t>Problems are too simple</a:t>
             </a:r>
             <a:endParaRPr sz="1700" b="1" i="0">
               <a:solidFill>
@@ -22973,7 +22973,7 @@
                 </a:solidFill>
                 <a:latin typeface="Calibri" panose="020F0502020204030204"/>
               </a:rPr>
-              <a:t>Single-product or serial chains dominate; joint quantity and supplier choice under one shared capacity is rarely modelled.</a:t>
+              <a:t>Most studies use one product or a simple chain. Choosing quantity and supplier together, with one shared warehouse, is rarely studied.</a:t>
             </a:r>
             <a:endParaRPr sz="1400" b="0" i="0">
               <a:solidFill>
@@ -23086,7 +23086,7 @@
                 </a:solidFill>
                 <a:latin typeface="Calibri" panose="020F0502020204030204"/>
               </a:rPr>
-              <a:t>We model 10 products, 3 suppliers and one shared warehouse, with a joint action.</a:t>
+              <a:t>We model 10 products, 3 suppliers and one shared warehouse, and choose both together.</a:t>
             </a:r>
             <a:endParaRPr sz="1400" b="0" i="0">
               <a:solidFill>
@@ -23190,7 +23190,7 @@
                 </a:solidFill>
                 <a:latin typeface="Calibri" panose="020F0502020204030204"/>
               </a:rPr>
-              <a:t>Explainability is deferred</a:t>
+              <a:t>No explanations</a:t>
             </a:r>
             <a:endParaRPr sz="1700" b="1" i="0">
               <a:solidFill>
@@ -23212,7 +23212,7 @@
                 </a:solidFill>
                 <a:latin typeface="Calibri" panose="020F0502020204030204"/>
               </a:rPr>
-              <a:t>Learned policies output a number, not a reason, so they stay in simulation.</a:t>
+              <a:t>A learned agent gives a number, not a reason, so it stays in simulation.</a:t>
             </a:r>
             <a:endParaRPr sz="1400" b="0" i="0">
               <a:solidFill>
@@ -23325,7 +23325,7 @@
                 </a:solidFill>
                 <a:latin typeface="Calibri" panose="020F0502020204030204"/>
               </a:rPr>
-              <a:t>An LLM explains each decision from computed facts; every number is checked.</a:t>
+              <a:t>An LLM explains each decision using facts from the simulator, and every number is checked.</a:t>
             </a:r>
             <a:endParaRPr sz="1400" b="0" i="0">
               <a:solidFill>
@@ -23429,7 +23429,7 @@
                 </a:solidFill>
                 <a:latin typeface="Calibri" panose="020F0502020204030204"/>
               </a:rPr>
-              <a:t>Stress testing is hand-built</a:t>
+              <a:t>Stress tests are made by hand</a:t>
             </a:r>
             <a:endParaRPr sz="1700" b="1" i="0">
               <a:solidFill>
@@ -23451,7 +23451,7 @@
                 </a:solidFill>
                 <a:latin typeface="Calibri" panose="020F0502020204030204"/>
               </a:rPr>
-              <a:t>Spikes and failures are coded case by case, so coverage is narrow.</a:t>
+              <a:t>Crises are coded one by one, so only a few are ever tested.</a:t>
             </a:r>
             <a:endParaRPr sz="1400" b="0" i="0">
               <a:solidFill>
@@ -23564,7 +23564,7 @@
                 </a:solidFill>
                 <a:latin typeface="Calibri" panose="020F0502020204030204"/>
               </a:rPr>
-              <a:t>An LLM writes overlapping crises; each is validated and clamped before use.</a:t>
+              <a:t>An LLM writes crises that overlap; each is checked and kept within safe ranges.</a:t>
             </a:r>
             <a:endParaRPr sz="1400" b="0" i="0">
               <a:solidFill>
@@ -23668,7 +23668,7 @@
                 </a:solidFill>
                 <a:latin typeface="Calibri" panose="020F0502020204030204"/>
               </a:rPr>
-              <a:t>Weak baselines</a:t>
+              <a:t>Weak comparisons</a:t>
             </a:r>
             <a:endParaRPr sz="1700" b="1" i="0">
               <a:solidFill>
@@ -23690,7 +23690,7 @@
                 </a:solidFill>
                 <a:latin typeface="Calibri" panose="020F0502020204030204"/>
               </a:rPr>
-              <a:t>Baselines are often left untuned, so a new method “wins” for free.</a:t>
+              <a:t>Old rules are often left untuned, so a new method looks good for free.</a:t>
             </a:r>
             <a:endParaRPr sz="1400" b="0" i="0">
               <a:solidFill>
@@ -23803,7 +23803,7 @@
                 </a:solidFill>
                 <a:latin typeface="Calibri" panose="020F0502020204030204"/>
               </a:rPr>
-              <a:t>All four classical methods are tuned on separate seeds before any comparison.</a:t>
+              <a:t>We tuned all four classical methods first, on separate test runs.</a:t>
             </a:r>
             <a:endParaRPr sz="1400" b="0" i="0">
               <a:solidFill>
@@ -24256,7 +24256,7 @@
                           </a:solidFill>
                           <a:latin typeface="Calibri" panose="020F0502020204030204"/>
                         </a:rPr>
-                        <a:t>Build a supply chain simulation from real data</a:t>
+                        <a:t>Build a supply-chain simulation from real data</a:t>
                       </a:r>
                       <a:endParaRPr sz="1400" b="0" i="0">
                         <a:solidFill>
@@ -24314,7 +24314,7 @@
                           </a:solidFill>
                           <a:latin typeface="Calibri" panose="020F0502020204030204"/>
                         </a:rPr>
-                        <a:t>1.07M records calibrate it; sensible rules profit, silly ones lose</a:t>
+                        <a:t>Built from 1.07M real sales; sensible ordering earns profit, silly ordering loses</a:t>
                       </a:r>
                       <a:endParaRPr sz="1400" b="0" i="0">
                         <a:solidFill>
@@ -24430,7 +24430,7 @@
                           </a:solidFill>
                           <a:latin typeface="Calibri" panose="020F0502020204030204"/>
                         </a:rPr>
-                        <a:t>MaskablePPO, tuned, 2M steps; 90.8% of the best classical method</a:t>
+                        <a:t>Tuned agent, 2M training steps; earns 90.8% of the best classical method</a:t>
                       </a:r>
                       <a:endParaRPr sz="1400" b="0" i="0">
                         <a:solidFill>
@@ -24488,7 +24488,7 @@
                           </a:solidFill>
                           <a:latin typeface="Calibri" panose="020F0502020204030204"/>
                         </a:rPr>
-                        <a:t>LLM explains each decision in business language</a:t>
+                        <a:t>LLM explains each decision in plain business language</a:t>
                       </a:r>
                       <a:endParaRPr sz="1400" b="0" i="0">
                         <a:solidFill>
@@ -24546,7 +24546,7 @@
                           </a:solidFill>
                           <a:latin typeface="Calibri" panose="020F0502020204030204"/>
                         </a:rPr>
-                        <a:t>100% delivered accuracy; 83% raw, the check caught every invented number</a:t>
+                        <a:t>100% of explanations shown were correct; 83% before our check, which caught every invented number</a:t>
                       </a:r>
                       <a:endParaRPr sz="1400" b="0" i="0">
                         <a:solidFill>
@@ -24604,7 +24604,7 @@
                           </a:solidFill>
                           <a:latin typeface="Calibri" panose="020F0502020204030204"/>
                         </a:rPr>
-                        <a:t>LLM generates demand-spike and supplier-delay scenarios</a:t>
+                        <a:t>LLM creates demand-spike and supplier-delay scenarios</a:t>
                       </a:r>
                       <a:endParaRPr sz="1400" b="0" i="0">
                         <a:solidFill>
@@ -24662,7 +24662,7 @@
                           </a:solidFill>
                           <a:latin typeface="Calibri" panose="020F0502020204030204"/>
                         </a:rPr>
-                        <a:t>6 unseen crises used for testing; curriculum training tested</a:t>
+                        <a:t>6 unseen crises used for testing; crisis training also tried</a:t>
                       </a:r>
                       <a:endParaRPr sz="1400" b="0" i="0">
                         <a:solidFill>
@@ -24778,7 +24778,7 @@
                           </a:solidFill>
                           <a:latin typeface="Calibri" panose="020F0502020204030204"/>
                         </a:rPr>
-                        <a:t>30 held-out seeds, paired t-test: the classical method still wins</a:t>
+                        <a:t>30 unseen test runs: the classical method still wins</a:t>
                       </a:r>
                       <a:endParaRPr sz="1400" b="0" i="0">
                         <a:solidFill>
@@ -24842,7 +24842,7 @@
                 </a:solidFill>
                 <a:latin typeface="Calibri" panose="020F0502020204030204"/>
               </a:rPr>
-              <a:t>The comparison came out against the AI, and we report it that way: the claim we can defend is that RL reaches 90.8% of a strong tuned baseline, with a measured reason for the gap.</a:t>
+              <a:t>The result went against the AI, and we say so. What we can defend: RL reaches 90.8% of a strong, well-tuned baseline, and we know why it falls short.</a:t>
             </a:r>
             <a:endParaRPr sz="1700" b="0" i="0">
               <a:solidFill>
@@ -25521,7 +25521,7 @@
                 </a:solidFill>
                 <a:latin typeface="Calibri" panose="020F0502020204030204"/>
               </a:rPr>
-              <a:t>•  Best score without it: ₹24.9 lakh</a:t>
+              <a:t>•  Masking blocks impossible choices first</a:t>
             </a:r>
             <a:endParaRPr sz="1400" b="0" i="0">
               <a:solidFill>
@@ -25543,7 +25543,7 @@
                 </a:solidFill>
                 <a:latin typeface="Calibri" panose="020F0502020204030204"/>
               </a:rPr>
-              <a:t>•  With it: ₹76.4 lakh, about 3×</a:t>
+              <a:t>•  Score: ₹24.9 lakh → ₹76.4 lakh (3×)</a:t>
             </a:r>
             <a:endParaRPr sz="1400" b="0" i="0">
               <a:solidFill>
@@ -25634,7 +25634,7 @@
                 </a:solidFill>
                 <a:latin typeface="Calibri" panose="020F0502020204030204"/>
               </a:rPr>
-              <a:t>Why a joint action</a:t>
+              <a:t>Why one joint choice</a:t>
             </a:r>
             <a:endParaRPr sz="1700" b="1" i="0">
               <a:solidFill>
@@ -25656,7 +25656,7 @@
                 </a:solidFill>
                 <a:latin typeface="Calibri" panose="020F0502020204030204"/>
               </a:rPr>
-              <a:t>•  Quantity and supplier as one choice</a:t>
+              <a:t>•  Quantity and supplier chosen together</a:t>
             </a:r>
             <a:endParaRPr sz="1400" b="0" i="0">
               <a:solidFill>
@@ -25678,7 +25678,7 @@
                 </a:solidFill>
                 <a:latin typeface="Calibri" panose="020F0502020204030204"/>
               </a:rPr>
-              <a:t>•  2.8× faster training, matches reality</a:t>
+              <a:t>•  Trains 2.8× faster, fits real life</a:t>
             </a:r>
             <a:endParaRPr sz="1400" b="0" i="0">
               <a:solidFill>
@@ -25791,7 +25791,7 @@
                 </a:solidFill>
                 <a:latin typeface="Calibri" panose="020F0502020204030204"/>
               </a:rPr>
-              <a:t>•  8 settings tried, best 2 run to 2M steps</a:t>
+              <a:t>•  Tried 8 settings, ran the best 2 longer</a:t>
             </a:r>
             <a:endParaRPr sz="1400" b="0" i="0">
               <a:solidFill>
@@ -25813,7 +25813,7 @@
                 </a:solidFill>
                 <a:latin typeface="Calibri" panose="020F0502020204030204"/>
               </a:rPr>
-              <a:t>•  The lowest learning rate won</a:t>
+              <a:t>•  A slower learning rate worked best</a:t>
             </a:r>
             <a:endParaRPr sz="1400" b="0" i="0">
               <a:solidFill>

</xml_diff>